<commit_message>
Agrega refactorización y DVC
</commit_message>
<xml_diff>
--- a/Presentacion_Customer_Churn_Profesor.pptx
+++ b/Presentacion_Customer_Churn_Profesor.pptx
@@ -2,22 +2,22 @@
 <file path=ppt/presentation.xml><?xml version="1.0" encoding="utf-8"?>
 <p:presentation xmlns:p="http://schemas.openxmlformats.org/presentationml/2006/main">
   <p:sldMasterIdLst>
-    <p:sldMasterId xmlns:r="http://schemas.openxmlformats.org/officeDocument/2006/relationships" id="2147483648" r:id="R6bdd6ff8d3b843ed"/>
+    <p:sldMasterId xmlns:r="http://schemas.openxmlformats.org/officeDocument/2006/relationships" id="2147483648" r:id="R7413c3b3d81349c9"/>
   </p:sldMasterIdLst>
   <p:notesMasterIdLst>
-    <p:notesMasterId xmlns:r="http://schemas.openxmlformats.org/officeDocument/2006/relationships" r:id="Rc257b01811f14c6c"/>
+    <p:notesMasterId xmlns:r="http://schemas.openxmlformats.org/officeDocument/2006/relationships" r:id="R970c31b3d74b4aaa"/>
   </p:notesMasterIdLst>
   <p:sldIdLst>
-    <p:sldId xmlns:r="http://schemas.openxmlformats.org/officeDocument/2006/relationships" id="256" r:id="R9c412984d2374443"/>
-    <p:sldId xmlns:r="http://schemas.openxmlformats.org/officeDocument/2006/relationships" id="257" r:id="Ra4873508bb5b4c43"/>
-    <p:sldId xmlns:r="http://schemas.openxmlformats.org/officeDocument/2006/relationships" id="258" r:id="Rb6b898c41bf84c72"/>
-    <p:sldId xmlns:r="http://schemas.openxmlformats.org/officeDocument/2006/relationships" id="259" r:id="R79a7adcda1e84b63"/>
-    <p:sldId xmlns:r="http://schemas.openxmlformats.org/officeDocument/2006/relationships" id="260" r:id="R496c70d12f6e4d41"/>
-    <p:sldId xmlns:r="http://schemas.openxmlformats.org/officeDocument/2006/relationships" id="261" r:id="Rf22ae07d524f45d9"/>
-    <p:sldId xmlns:r="http://schemas.openxmlformats.org/officeDocument/2006/relationships" id="262" r:id="R1e8fc442cfaa4793"/>
-    <p:sldId xmlns:r="http://schemas.openxmlformats.org/officeDocument/2006/relationships" id="263" r:id="R2e3bbe37c116484a"/>
-    <p:sldId xmlns:r="http://schemas.openxmlformats.org/officeDocument/2006/relationships" id="264" r:id="R9e37efbe0cd84c63"/>
-    <p:sldId xmlns:r="http://schemas.openxmlformats.org/officeDocument/2006/relationships" id="265" r:id="R40fb0a44ce454f69"/>
+    <p:sldId xmlns:r="http://schemas.openxmlformats.org/officeDocument/2006/relationships" id="256" r:id="R43aebc412b274b0b"/>
+    <p:sldId xmlns:r="http://schemas.openxmlformats.org/officeDocument/2006/relationships" id="257" r:id="R476f24603d804ac2"/>
+    <p:sldId xmlns:r="http://schemas.openxmlformats.org/officeDocument/2006/relationships" id="258" r:id="Rb71a323ff42f46aa"/>
+    <p:sldId xmlns:r="http://schemas.openxmlformats.org/officeDocument/2006/relationships" id="259" r:id="R75c4e03341ee4577"/>
+    <p:sldId xmlns:r="http://schemas.openxmlformats.org/officeDocument/2006/relationships" id="260" r:id="Re207797c7ec44dbb"/>
+    <p:sldId xmlns:r="http://schemas.openxmlformats.org/officeDocument/2006/relationships" id="261" r:id="R9ff364547a6142ea"/>
+    <p:sldId xmlns:r="http://schemas.openxmlformats.org/officeDocument/2006/relationships" id="262" r:id="R9e9203bba9744b16"/>
+    <p:sldId xmlns:r="http://schemas.openxmlformats.org/officeDocument/2006/relationships" id="263" r:id="R24e9b8804fdb4699"/>
+    <p:sldId xmlns:r="http://schemas.openxmlformats.org/officeDocument/2006/relationships" id="264" r:id="R1baca44891384cd7"/>
+    <p:sldId xmlns:r="http://schemas.openxmlformats.org/officeDocument/2006/relationships" id="265" r:id="R45a8befa750e4b6b"/>
   </p:sldIdLst>
   <p:sldSz cx="12192000" cy="6858000"/>
   <p:notesSz cx="6858000" cy="9144000"/>
@@ -1081,7 +1081,7 @@
           <a:lstStyle xmlns:a="http://schemas.openxmlformats.org/drawingml/2006/main"/>
           <a:p xmlns:a="http://schemas.openxmlformats.org/drawingml/2006/main">
             <a:r>
-              <a:t>Fuente: requisitos del primer parcial y contenido actual del repositorio.</a:t>
+              <a:t>Fuente: requisitos del primer parcial y contenido actual de la rama refactorizacion-dvc.</a:t>
             </a:r>
           </a:p>
         </p:txBody>
@@ -1149,7 +1149,7 @@
   </p:cSld>
   <p:clrMap bg1="lt1" tx1="dk1" bg2="lt2" tx2="dk2" accent1="accent1" accent2="accent2" accent3="accent3" accent4="accent4" accent5="accent5" accent6="accent6" hlink="hlink" folHlink="folHlink"/>
   <p:sldLayoutIdLst>
-    <p:sldLayoutId xmlns:r="http://schemas.openxmlformats.org/officeDocument/2006/relationships" id="2147483649" r:id="R04cc97999abe4ec1"/>
+    <p:sldLayoutId xmlns:r="http://schemas.openxmlformats.org/officeDocument/2006/relationships" id="2147483649" r:id="R42a721a2149345c9"/>
   </p:sldLayoutIdLst>
   <p:txStyles>
     <p:titleStyle>
@@ -1975,7 +1975,7 @@
           <p:cNvPr id="6" name="">
             <a:extLst xmlns:a="http://schemas.openxmlformats.org/drawingml/2006/main">
               <a:ext uri="{FF2B5EF4-FFF2-40B4-BE49-F238E27FC236}">
-                <a16:creationId xmlns:a16="http://schemas.microsoft.com/office/drawing/2014/main" id="{26B0E272-F993-465E-A0F0-CBDA57EE073E}"/>
+                <a16:creationId xmlns:a16="http://schemas.microsoft.com/office/drawing/2014/main" id="{504A0C55-EE48-482D-820B-31EA37B1DE06}"/>
               </a:ext>
             </a:extLst>
           </p:cNvPr>
@@ -2032,7 +2032,7 @@
           <p:cNvPr id="2" name="">
             <a:extLst xmlns:a="http://schemas.openxmlformats.org/drawingml/2006/main">
               <a:ext uri="{FF2B5EF4-FFF2-40B4-BE49-F238E27FC236}">
-                <a16:creationId xmlns:a16="http://schemas.microsoft.com/office/drawing/2014/main" id="{BB940A5A-0CBC-4166-BCBD-01A237D7C71E}"/>
+                <a16:creationId xmlns:a16="http://schemas.microsoft.com/office/drawing/2014/main" id="{EE6905C5-B717-4582-81F9-EA3E2A6AA728}"/>
               </a:ext>
             </a:extLst>
           </p:cNvPr>
@@ -2089,7 +2089,7 @@
           <p:cNvPr id="3" name="">
             <a:extLst xmlns:a="http://schemas.openxmlformats.org/drawingml/2006/main">
               <a:ext uri="{FF2B5EF4-FFF2-40B4-BE49-F238E27FC236}">
-                <a16:creationId xmlns:a16="http://schemas.microsoft.com/office/drawing/2014/main" id="{C3DEB1F7-F943-4D82-A07E-3DA1F6383BB1}"/>
+                <a16:creationId xmlns:a16="http://schemas.microsoft.com/office/drawing/2014/main" id="{ED05E083-4EC5-4728-9527-C420E39BE748}"/>
               </a:ext>
             </a:extLst>
           </p:cNvPr>
@@ -2146,7 +2146,7 @@
           <p:cNvPr id="4" name="">
             <a:extLst xmlns:a="http://schemas.openxmlformats.org/drawingml/2006/main">
               <a:ext uri="{FF2B5EF4-FFF2-40B4-BE49-F238E27FC236}">
-                <a16:creationId xmlns:a16="http://schemas.microsoft.com/office/drawing/2014/main" id="{1E803ABC-7D84-462F-B5D5-C0B5C07220DF}"/>
+                <a16:creationId xmlns:a16="http://schemas.microsoft.com/office/drawing/2014/main" id="{F342896F-B725-4305-9084-D295766F06C2}"/>
               </a:ext>
             </a:extLst>
           </p:cNvPr>
@@ -2203,7 +2203,7 @@
           <p:cNvPr id="5" name="">
             <a:extLst xmlns:a="http://schemas.openxmlformats.org/drawingml/2006/main">
               <a:ext uri="{FF2B5EF4-FFF2-40B4-BE49-F238E27FC236}">
-                <a16:creationId xmlns:a16="http://schemas.microsoft.com/office/drawing/2014/main" id="{D528A56B-ABE8-42AE-9BFF-CB7EC2320560}"/>
+                <a16:creationId xmlns:a16="http://schemas.microsoft.com/office/drawing/2014/main" id="{77056CB0-5759-4CCF-A309-69F4B854B973}"/>
               </a:ext>
             </a:extLst>
           </p:cNvPr>
@@ -2258,7 +2258,7 @@
     </p:spTree>
     <p:extLst>
       <p:ext uri="{BB962C8B-B14F-4D97-AF65-F5344CB8AC3E}">
-        <p14:creationId xmlns:p14="http://schemas.microsoft.com/office/powerpoint/2010/main" val="1600567815"/>
+        <p14:creationId xmlns:p14="http://schemas.microsoft.com/office/powerpoint/2010/main" val="1960800982"/>
       </p:ext>
     </p:extLst>
   </p:cSld>
@@ -2289,7 +2289,7 @@
           <p:cNvPr id="6" name="">
             <a:extLst xmlns:a="http://schemas.openxmlformats.org/drawingml/2006/main">
               <a:ext uri="{FF2B5EF4-FFF2-40B4-BE49-F238E27FC236}">
-                <a16:creationId xmlns:a16="http://schemas.microsoft.com/office/drawing/2014/main" id="{84FE7F00-64A8-45D1-9ED5-EA471B7B6A8A}"/>
+                <a16:creationId xmlns:a16="http://schemas.microsoft.com/office/drawing/2014/main" id="{EC5C4D83-0900-4AA1-9A18-AE1E6FE78017}"/>
               </a:ext>
             </a:extLst>
           </p:cNvPr>
@@ -2300,8 +2300,8 @@
         </p:nvSpPr>
         <p:spPr>
           <a:xfrm xmlns:a="http://schemas.openxmlformats.org/drawingml/2006/main">
-            <a:off x="666750" y="323850"/>
-            <a:ext cx="10858500" cy="628650"/>
+            <a:off x="666750" y="495300"/>
+            <a:ext cx="10858500" cy="571500"/>
           </a:xfrm>
           <a:prstGeom xmlns:a="http://schemas.openxmlformats.org/drawingml/2006/main" prst="rect">
             <a:avLst/>
@@ -2318,7 +2318,7 @@
           <a:lstStyle xmlns:a="http://schemas.openxmlformats.org/drawingml/2006/main"/>
           <a:p xmlns:a="http://schemas.openxmlformats.org/drawingml/2006/main">
             <a:pPr algn="l">
-              <a:defRPr sz="3150" b="1">
+              <a:defRPr sz="2700" b="1">
                 <a:solidFill>
                   <a:srgbClr val="183A63"/>
                 </a:solidFill>
@@ -2328,7 +2328,7 @@
               </a:defRPr>
             </a:pPr>
             <a:r>
-              <a:rPr sz="3150" b="1">
+              <a:rPr sz="2700" b="1">
                 <a:solidFill>
                   <a:srgbClr val="183A63"/>
                 </a:solidFill>
@@ -2346,7 +2346,7 @@
           <p:cNvPr id="2" name="">
             <a:extLst xmlns:a="http://schemas.openxmlformats.org/drawingml/2006/main">
               <a:ext uri="{FF2B5EF4-FFF2-40B4-BE49-F238E27FC236}">
-                <a16:creationId xmlns:a16="http://schemas.microsoft.com/office/drawing/2014/main" id="{D47A49F8-2798-46D1-8B12-A29E24E55CDB}"/>
+                <a16:creationId xmlns:a16="http://schemas.microsoft.com/office/drawing/2014/main" id="{1C9B5AF4-989D-4625-85BE-599AFC5472AA}"/>
               </a:ext>
             </a:extLst>
           </p:cNvPr>
@@ -2405,8 +2405,8 @@
           <p:nvPr/>
         </p:nvGraphicFramePr>
         <p:xfrm>
-          <a:off xmlns:a="http://schemas.openxmlformats.org/drawingml/2006/main" x="857250" y="1238250"/>
-          <a:ext xmlns:a="http://schemas.openxmlformats.org/drawingml/2006/main" cx="10477500" cy="4095750"/>
+          <a:off xmlns:a="http://schemas.openxmlformats.org/drawingml/2006/main" x="857250" y="1381125"/>
+          <a:ext xmlns:a="http://schemas.openxmlformats.org/drawingml/2006/main" cx="10477500" cy="3619500"/>
         </p:xfrm>
         <a:graphic xmlns:a="http://schemas.openxmlformats.org/drawingml/2006/main">
           <a:graphicData uri="http://schemas.openxmlformats.org/drawingml/2006/table">
@@ -2416,7 +2416,7 @@
                 <a:gridCol w="6858000"/>
                 <a:gridCol w="3619500"/>
               </a:tblGrid>
-              <a:tr h="585107">
+              <a:tr h="603250">
                 <a:tc>
                   <a:txBody>
                     <a:bodyPr/>
@@ -2466,7 +2466,7 @@
                   </a:tcPr>
                 </a:tc>
               </a:tr>
-              <a:tr h="585107">
+              <a:tr h="603250">
                 <a:tc>
                   <a:txBody>
                     <a:bodyPr/>
@@ -2481,7 +2481,7 @@
                           <a:ea typeface="Aptos"/>
                           <a:cs typeface="Aptos"/>
                         </a:rPr>
-                        <a:t>Dataset bajo DVC y remoto en DagsHub</a:t>
+                        <a:t>Autenticación DVC y dvc push</a:t>
                       </a:r>
                     </a:p>
                   </a:txBody>
@@ -2505,7 +2505,7 @@
                           <a:ea typeface="Aptos"/>
                           <a:cs typeface="Aptos"/>
                         </a:rPr>
-                        <a:t>Pendiente</a:t>
+                        <a:t>Renovar token local</a:t>
                       </a:r>
                     </a:p>
                   </a:txBody>
@@ -2516,7 +2516,7 @@
                   </a:tcPr>
                 </a:tc>
               </a:tr>
-              <a:tr h="585107">
+              <a:tr h="603250">
                 <a:tc>
                   <a:txBody>
                     <a:bodyPr/>
@@ -2566,7 +2566,7 @@
                   </a:tcPr>
                 </a:tc>
               </a:tr>
-              <a:tr h="585107">
+              <a:tr h="603250">
                 <a:tc>
                   <a:txBody>
                     <a:bodyPr/>
@@ -2616,7 +2616,7 @@
                   </a:tcPr>
                 </a:tc>
               </a:tr>
-              <a:tr h="585107">
+              <a:tr h="603250">
                 <a:tc>
                   <a:txBody>
                     <a:bodyPr/>
@@ -2631,7 +2631,7 @@
                           <a:ea typeface="Aptos"/>
                           <a:cs typeface="Aptos"/>
                         </a:rPr>
-                        <a:t>Entrenamiento desde Python fuera del notebook</a:t>
+                        <a:t>Tag entrega-1 sobre el commit presentado</a:t>
                       </a:r>
                     </a:p>
                   </a:txBody>
@@ -2666,7 +2666,7 @@
                   </a:tcPr>
                 </a:tc>
               </a:tr>
-              <a:tr h="585107">
+              <a:tr h="603250">
                 <a:tc>
                   <a:txBody>
                     <a:bodyPr/>
@@ -2681,7 +2681,7 @@
                           <a:ea typeface="Aptos"/>
                           <a:cs typeface="Aptos"/>
                         </a:rPr>
-                        <a:t>Tag entrega-1 sobre el commit presentado</a:t>
+                        <a:t>Reproducción completa desde una segunda copia</a:t>
                       </a:r>
                     </a:p>
                   </a:txBody>
@@ -2716,56 +2716,6 @@
                   </a:tcPr>
                 </a:tc>
               </a:tr>
-              <a:tr h="585107">
-                <a:tc>
-                  <a:txBody>
-                    <a:bodyPr/>
-                    <a:lstStyle/>
-                    <a:p>
-                      <a:r>
-                        <a:rPr sz="1350">
-                          <a:solidFill>
-                            <a:srgbClr val="202B38"/>
-                          </a:solidFill>
-                          <a:latin typeface="Aptos"/>
-                          <a:ea typeface="Aptos"/>
-                          <a:cs typeface="Aptos"/>
-                        </a:rPr>
-                        <a:t>Reproducción completa desde una segunda copia</a:t>
-                      </a:r>
-                    </a:p>
-                  </a:txBody>
-                  <a:tcPr marL="91440" marR="91440" marT="45720" marB="45720" anchor="ctr">
-                    <a:solidFill>
-                      <a:srgbClr val="E8F0F5"/>
-                    </a:solidFill>
-                  </a:tcPr>
-                </a:tc>
-                <a:tc>
-                  <a:txBody>
-                    <a:bodyPr/>
-                    <a:lstStyle/>
-                    <a:p>
-                      <a:r>
-                        <a:rPr sz="1350" b="1">
-                          <a:solidFill>
-                            <a:srgbClr val="A66A17"/>
-                          </a:solidFill>
-                          <a:latin typeface="Aptos"/>
-                          <a:ea typeface="Aptos"/>
-                          <a:cs typeface="Aptos"/>
-                        </a:rPr>
-                        <a:t>Pendiente</a:t>
-                      </a:r>
-                    </a:p>
-                  </a:txBody>
-                  <a:tcPr marL="91440" marR="91440" marT="45720" marB="45720" anchor="ctr">
-                    <a:solidFill>
-                      <a:srgbClr val="FFF1D8"/>
-                    </a:solidFill>
-                  </a:tcPr>
-                </a:tc>
-              </a:tr>
             </a:tbl>
           </a:graphicData>
         </a:graphic>
@@ -2775,7 +2725,7 @@
           <p:cNvPr id="4" name="">
             <a:extLst xmlns:a="http://schemas.openxmlformats.org/drawingml/2006/main">
               <a:ext uri="{FF2B5EF4-FFF2-40B4-BE49-F238E27FC236}">
-                <a16:creationId xmlns:a16="http://schemas.microsoft.com/office/drawing/2014/main" id="{FCC646E8-E2E1-4A94-A412-5F399941353B}"/>
+                <a16:creationId xmlns:a16="http://schemas.microsoft.com/office/drawing/2014/main" id="{2B094882-0A67-4196-AAB9-957B112541B6}"/>
               </a:ext>
             </a:extLst>
           </p:cNvPr>
@@ -2786,8 +2736,8 @@
         </p:nvSpPr>
         <p:spPr>
           <a:xfrm xmlns:a="http://schemas.openxmlformats.org/drawingml/2006/main">
-            <a:off x="1285875" y="5572125"/>
-            <a:ext cx="9620250" cy="523875"/>
+            <a:off x="1095375" y="5381625"/>
+            <a:ext cx="10001250" cy="571500"/>
           </a:xfrm>
           <a:prstGeom xmlns:a="http://schemas.openxmlformats.org/drawingml/2006/main" prst="rect">
             <a:avLst/>
@@ -2804,7 +2754,7 @@
           <a:lstStyle xmlns:a="http://schemas.openxmlformats.org/drawingml/2006/main"/>
           <a:p xmlns:a="http://schemas.openxmlformats.org/drawingml/2006/main">
             <a:pPr algn="ctr">
-              <a:defRPr sz="1875" b="1">
+              <a:defRPr sz="1725" b="1">
                 <a:solidFill>
                   <a:srgbClr val="A66A17"/>
                 </a:solidFill>
@@ -2814,7 +2764,7 @@
               </a:defRPr>
             </a:pPr>
             <a:r>
-              <a:rPr sz="1875" b="1">
+              <a:rPr sz="1725" b="1">
                 <a:solidFill>
                   <a:srgbClr val="A66A17"/>
                 </a:solidFill>
@@ -2822,7 +2772,7 @@
                 <a:ea typeface="Aptos"/>
                 <a:cs typeface="Aptos"/>
               </a:rPr>
-              <a:t>La entrega todavía no permite reconstruir el origen de un modelo registrado.</a:t>
+              <a:t>La trazabilidad quedará completa al validar DVC, registrar las corridas y vincular el modelo candidato.</a:t>
             </a:r>
           </a:p>
         </p:txBody>
@@ -2832,7 +2782,7 @@
           <p:cNvPr id="5" name="">
             <a:extLst xmlns:a="http://schemas.openxmlformats.org/drawingml/2006/main">
               <a:ext uri="{FF2B5EF4-FFF2-40B4-BE49-F238E27FC236}">
-                <a16:creationId xmlns:a16="http://schemas.microsoft.com/office/drawing/2014/main" id="{5A86F24C-599A-4AAB-9F89-834D8C27C681}"/>
+                <a16:creationId xmlns:a16="http://schemas.microsoft.com/office/drawing/2014/main" id="{D12173AD-C0AB-4A29-8A44-2328BD7CA273}"/>
               </a:ext>
             </a:extLst>
           </p:cNvPr>
@@ -2843,7 +2793,7 @@
         </p:nvSpPr>
         <p:spPr>
           <a:xfrm xmlns:a="http://schemas.openxmlformats.org/drawingml/2006/main">
-            <a:off x="2667000" y="6096000"/>
+            <a:off x="2667000" y="6048375"/>
             <a:ext cx="6858000" cy="304800"/>
           </a:xfrm>
           <a:prstGeom xmlns:a="http://schemas.openxmlformats.org/drawingml/2006/main" prst="rect">
@@ -2887,7 +2837,7 @@
     </p:spTree>
     <p:extLst>
       <p:ext uri="{BB962C8B-B14F-4D97-AF65-F5344CB8AC3E}">
-        <p14:creationId xmlns:p14="http://schemas.microsoft.com/office/powerpoint/2010/main" val="391303845"/>
+        <p14:creationId xmlns:p14="http://schemas.microsoft.com/office/powerpoint/2010/main" val="1246389860"/>
       </p:ext>
     </p:extLst>
   </p:cSld>
@@ -2918,7 +2868,7 @@
           <p:cNvPr id="14" name="">
             <a:extLst xmlns:a="http://schemas.openxmlformats.org/drawingml/2006/main">
               <a:ext uri="{FF2B5EF4-FFF2-40B4-BE49-F238E27FC236}">
-                <a16:creationId xmlns:a16="http://schemas.microsoft.com/office/drawing/2014/main" id="{7D5A5C82-8494-44B7-BF39-4D9D3B210E36}"/>
+                <a16:creationId xmlns:a16="http://schemas.microsoft.com/office/drawing/2014/main" id="{49AAEA1B-3336-44FA-835A-37A6817820B6}"/>
               </a:ext>
             </a:extLst>
           </p:cNvPr>
@@ -2929,8 +2879,8 @@
         </p:nvSpPr>
         <p:spPr>
           <a:xfrm xmlns:a="http://schemas.openxmlformats.org/drawingml/2006/main">
-            <a:off x="666750" y="323850"/>
-            <a:ext cx="10858500" cy="628650"/>
+            <a:off x="666750" y="495300"/>
+            <a:ext cx="10858500" cy="571500"/>
           </a:xfrm>
           <a:prstGeom xmlns:a="http://schemas.openxmlformats.org/drawingml/2006/main" prst="rect">
             <a:avLst/>
@@ -2947,7 +2897,7 @@
           <a:lstStyle xmlns:a="http://schemas.openxmlformats.org/drawingml/2006/main"/>
           <a:p xmlns:a="http://schemas.openxmlformats.org/drawingml/2006/main">
             <a:pPr algn="l">
-              <a:defRPr sz="3150" b="1">
+              <a:defRPr sz="2700" b="1">
                 <a:solidFill>
                   <a:srgbClr val="183A63"/>
                 </a:solidFill>
@@ -2957,7 +2907,7 @@
               </a:defRPr>
             </a:pPr>
             <a:r>
-              <a:rPr sz="3150" b="1">
+              <a:rPr sz="2700" b="1">
                 <a:solidFill>
                   <a:srgbClr val="183A63"/>
                 </a:solidFill>
@@ -2975,7 +2925,7 @@
           <p:cNvPr id="2" name="">
             <a:extLst xmlns:a="http://schemas.openxmlformats.org/drawingml/2006/main">
               <a:ext uri="{FF2B5EF4-FFF2-40B4-BE49-F238E27FC236}">
-                <a16:creationId xmlns:a16="http://schemas.microsoft.com/office/drawing/2014/main" id="{20EC8BB7-E89C-4EDE-86D1-1E7C5F245EF3}"/>
+                <a16:creationId xmlns:a16="http://schemas.microsoft.com/office/drawing/2014/main" id="{C66268C9-D50A-4507-95EB-9D762983D4D0}"/>
               </a:ext>
             </a:extLst>
           </p:cNvPr>
@@ -3032,7 +2982,7 @@
           <p:cNvPr id="3" name="">
             <a:extLst xmlns:a="http://schemas.openxmlformats.org/drawingml/2006/main">
               <a:ext uri="{FF2B5EF4-FFF2-40B4-BE49-F238E27FC236}">
-                <a16:creationId xmlns:a16="http://schemas.microsoft.com/office/drawing/2014/main" id="{B1A4870F-4F9B-4732-A781-8D0A0B099810}"/>
+                <a16:creationId xmlns:a16="http://schemas.microsoft.com/office/drawing/2014/main" id="{B1929C88-C95A-4ACF-8383-5A4E125592D8}"/>
               </a:ext>
             </a:extLst>
           </p:cNvPr>
@@ -3089,7 +3039,7 @@
           <p:cNvPr id="4" name="">
             <a:extLst xmlns:a="http://schemas.openxmlformats.org/drawingml/2006/main">
               <a:ext uri="{FF2B5EF4-FFF2-40B4-BE49-F238E27FC236}">
-                <a16:creationId xmlns:a16="http://schemas.microsoft.com/office/drawing/2014/main" id="{447EC78B-AB50-4DE7-80E7-4F171990AF1A}"/>
+                <a16:creationId xmlns:a16="http://schemas.microsoft.com/office/drawing/2014/main" id="{7BA5C9A1-9EDD-43AF-973C-954DF94A22EF}"/>
               </a:ext>
             </a:extLst>
           </p:cNvPr>
@@ -3146,7 +3096,7 @@
           <p:cNvPr id="5" name="">
             <a:extLst xmlns:a="http://schemas.openxmlformats.org/drawingml/2006/main">
               <a:ext uri="{FF2B5EF4-FFF2-40B4-BE49-F238E27FC236}">
-                <a16:creationId xmlns:a16="http://schemas.microsoft.com/office/drawing/2014/main" id="{B1E74FE2-3762-47DF-930E-AA4DBB5E4851}"/>
+                <a16:creationId xmlns:a16="http://schemas.microsoft.com/office/drawing/2014/main" id="{B743CC17-6F7B-4589-9DD7-BB7A73160165}"/>
               </a:ext>
             </a:extLst>
           </p:cNvPr>
@@ -3203,7 +3153,7 @@
           <p:cNvPr id="6" name="">
             <a:extLst xmlns:a="http://schemas.openxmlformats.org/drawingml/2006/main">
               <a:ext uri="{FF2B5EF4-FFF2-40B4-BE49-F238E27FC236}">
-                <a16:creationId xmlns:a16="http://schemas.microsoft.com/office/drawing/2014/main" id="{90C036B9-7523-461E-908B-F723ED6F1A8E}"/>
+                <a16:creationId xmlns:a16="http://schemas.microsoft.com/office/drawing/2014/main" id="{4B7E4231-531D-4636-9113-931A7B71832A}"/>
               </a:ext>
             </a:extLst>
           </p:cNvPr>
@@ -3260,7 +3210,7 @@
           <p:cNvPr id="7" name="">
             <a:extLst xmlns:a="http://schemas.openxmlformats.org/drawingml/2006/main">
               <a:ext uri="{FF2B5EF4-FFF2-40B4-BE49-F238E27FC236}">
-                <a16:creationId xmlns:a16="http://schemas.microsoft.com/office/drawing/2014/main" id="{13163EEF-003D-400E-B5B9-8D11293224CE}"/>
+                <a16:creationId xmlns:a16="http://schemas.microsoft.com/office/drawing/2014/main" id="{89F4E08B-8207-447F-AC89-EB8285ED441A}"/>
               </a:ext>
             </a:extLst>
           </p:cNvPr>
@@ -3317,7 +3267,7 @@
           <p:cNvPr id="8" name="">
             <a:extLst xmlns:a="http://schemas.openxmlformats.org/drawingml/2006/main">
               <a:ext uri="{FF2B5EF4-FFF2-40B4-BE49-F238E27FC236}">
-                <a16:creationId xmlns:a16="http://schemas.microsoft.com/office/drawing/2014/main" id="{69BD7157-809F-4A4E-8DF7-06E6FBC83AAB}"/>
+                <a16:creationId xmlns:a16="http://schemas.microsoft.com/office/drawing/2014/main" id="{E9478287-0CAC-4B83-BAB1-6E309EFF06D6}"/>
               </a:ext>
             </a:extLst>
           </p:cNvPr>
@@ -3374,7 +3324,7 @@
           <p:cNvPr id="9" name="">
             <a:extLst xmlns:a="http://schemas.openxmlformats.org/drawingml/2006/main">
               <a:ext uri="{FF2B5EF4-FFF2-40B4-BE49-F238E27FC236}">
-                <a16:creationId xmlns:a16="http://schemas.microsoft.com/office/drawing/2014/main" id="{CA3ACB1F-306A-4D75-8EA4-0D1A9324C0A7}"/>
+                <a16:creationId xmlns:a16="http://schemas.microsoft.com/office/drawing/2014/main" id="{9EED0137-B105-40F7-B20D-4012A2835739}"/>
               </a:ext>
             </a:extLst>
           </p:cNvPr>
@@ -3431,7 +3381,7 @@
           <p:cNvPr id="10" name="">
             <a:extLst xmlns:a="http://schemas.openxmlformats.org/drawingml/2006/main">
               <a:ext uri="{FF2B5EF4-FFF2-40B4-BE49-F238E27FC236}">
-                <a16:creationId xmlns:a16="http://schemas.microsoft.com/office/drawing/2014/main" id="{2B534299-689A-4608-B6F9-4A6BC5B22FE0}"/>
+                <a16:creationId xmlns:a16="http://schemas.microsoft.com/office/drawing/2014/main" id="{A656FAAF-7010-4A79-B8DC-E388496400C8}"/>
               </a:ext>
             </a:extLst>
           </p:cNvPr>
@@ -3488,7 +3438,7 @@
           <p:cNvPr id="11" name="">
             <a:extLst xmlns:a="http://schemas.openxmlformats.org/drawingml/2006/main">
               <a:ext uri="{FF2B5EF4-FFF2-40B4-BE49-F238E27FC236}">
-                <a16:creationId xmlns:a16="http://schemas.microsoft.com/office/drawing/2014/main" id="{3943DDE1-9A15-4126-AC22-162AC5B2E84E}"/>
+                <a16:creationId xmlns:a16="http://schemas.microsoft.com/office/drawing/2014/main" id="{A237BDF4-9ABB-4CDF-93A0-D213947A5F0C}"/>
               </a:ext>
             </a:extLst>
           </p:cNvPr>
@@ -3545,7 +3495,7 @@
           <p:cNvPr id="12" name="">
             <a:extLst xmlns:a="http://schemas.openxmlformats.org/drawingml/2006/main">
               <a:ext uri="{FF2B5EF4-FFF2-40B4-BE49-F238E27FC236}">
-                <a16:creationId xmlns:a16="http://schemas.microsoft.com/office/drawing/2014/main" id="{260AF59C-15F2-47E8-9EFA-D572B42EE14A}"/>
+                <a16:creationId xmlns:a16="http://schemas.microsoft.com/office/drawing/2014/main" id="{33D9011A-E923-4D6C-9D2B-2AED6A2034C4}"/>
               </a:ext>
             </a:extLst>
           </p:cNvPr>
@@ -3602,7 +3552,7 @@
           <p:cNvPr id="13" name="">
             <a:extLst xmlns:a="http://schemas.openxmlformats.org/drawingml/2006/main">
               <a:ext uri="{FF2B5EF4-FFF2-40B4-BE49-F238E27FC236}">
-                <a16:creationId xmlns:a16="http://schemas.microsoft.com/office/drawing/2014/main" id="{A3DB685E-D5B4-4350-9C64-ED8B577449DE}"/>
+                <a16:creationId xmlns:a16="http://schemas.microsoft.com/office/drawing/2014/main" id="{0095CF20-11C6-4CD5-86E3-B2E32EF88D72}"/>
               </a:ext>
             </a:extLst>
           </p:cNvPr>
@@ -3657,7 +3607,7 @@
     </p:spTree>
     <p:extLst>
       <p:ext uri="{BB962C8B-B14F-4D97-AF65-F5344CB8AC3E}">
-        <p14:creationId xmlns:p14="http://schemas.microsoft.com/office/powerpoint/2010/main" val="1504370587"/>
+        <p14:creationId xmlns:p14="http://schemas.microsoft.com/office/powerpoint/2010/main" val="632492615"/>
       </p:ext>
     </p:extLst>
   </p:cSld>
@@ -3688,7 +3638,7 @@
           <p:cNvPr id="12" name="">
             <a:extLst xmlns:a="http://schemas.openxmlformats.org/drawingml/2006/main">
               <a:ext uri="{FF2B5EF4-FFF2-40B4-BE49-F238E27FC236}">
-                <a16:creationId xmlns:a16="http://schemas.microsoft.com/office/drawing/2014/main" id="{DE0077A3-E9E9-4D8C-881B-CD443813949A}"/>
+                <a16:creationId xmlns:a16="http://schemas.microsoft.com/office/drawing/2014/main" id="{EED7927C-E116-4975-BC73-4263FD85961C}"/>
               </a:ext>
             </a:extLst>
           </p:cNvPr>
@@ -3699,8 +3649,8 @@
         </p:nvSpPr>
         <p:spPr>
           <a:xfrm xmlns:a="http://schemas.openxmlformats.org/drawingml/2006/main">
-            <a:off x="666750" y="323850"/>
-            <a:ext cx="10858500" cy="628650"/>
+            <a:off x="666750" y="495300"/>
+            <a:ext cx="10858500" cy="571500"/>
           </a:xfrm>
           <a:prstGeom xmlns:a="http://schemas.openxmlformats.org/drawingml/2006/main" prst="rect">
             <a:avLst/>
@@ -3717,7 +3667,7 @@
           <a:lstStyle xmlns:a="http://schemas.openxmlformats.org/drawingml/2006/main"/>
           <a:p xmlns:a="http://schemas.openxmlformats.org/drawingml/2006/main">
             <a:pPr algn="l">
-              <a:defRPr sz="3150" b="1">
+              <a:defRPr sz="2700" b="1">
                 <a:solidFill>
                   <a:srgbClr val="183A63"/>
                 </a:solidFill>
@@ -3727,7 +3677,7 @@
               </a:defRPr>
             </a:pPr>
             <a:r>
-              <a:rPr sz="3150" b="1">
+              <a:rPr sz="2700" b="1">
                 <a:solidFill>
                   <a:srgbClr val="183A63"/>
                 </a:solidFill>
@@ -3745,7 +3695,7 @@
           <p:cNvPr id="2" name="">
             <a:extLst xmlns:a="http://schemas.openxmlformats.org/drawingml/2006/main">
               <a:ext uri="{FF2B5EF4-FFF2-40B4-BE49-F238E27FC236}">
-                <a16:creationId xmlns:a16="http://schemas.microsoft.com/office/drawing/2014/main" id="{140C0396-31E3-4D83-88C3-793F23DCE99A}"/>
+                <a16:creationId xmlns:a16="http://schemas.microsoft.com/office/drawing/2014/main" id="{E7511B16-C2D8-43D5-A76F-0A941A198399}"/>
               </a:ext>
             </a:extLst>
           </p:cNvPr>
@@ -3802,7 +3752,7 @@
           <p:cNvPr id="3" name="">
             <a:extLst xmlns:a="http://schemas.openxmlformats.org/drawingml/2006/main">
               <a:ext uri="{FF2B5EF4-FFF2-40B4-BE49-F238E27FC236}">
-                <a16:creationId xmlns:a16="http://schemas.microsoft.com/office/drawing/2014/main" id="{1422DA0B-219E-4AEC-AF2C-5F182DD2B98F}"/>
+                <a16:creationId xmlns:a16="http://schemas.microsoft.com/office/drawing/2014/main" id="{141FF393-8A14-4FDA-92F4-8F7E5EB71A1C}"/>
               </a:ext>
             </a:extLst>
           </p:cNvPr>
@@ -3859,7 +3809,7 @@
           <p:cNvPr id="4" name="">
             <a:extLst xmlns:a="http://schemas.openxmlformats.org/drawingml/2006/main">
               <a:ext uri="{FF2B5EF4-FFF2-40B4-BE49-F238E27FC236}">
-                <a16:creationId xmlns:a16="http://schemas.microsoft.com/office/drawing/2014/main" id="{1E583B89-A066-4AC3-8B04-49649B658770}"/>
+                <a16:creationId xmlns:a16="http://schemas.microsoft.com/office/drawing/2014/main" id="{1B79DED1-6968-4C08-999D-ABFFD23F7AA2}"/>
               </a:ext>
             </a:extLst>
           </p:cNvPr>
@@ -3939,7 +3889,7 @@
           <p:cNvPr id="5" name="">
             <a:extLst xmlns:a="http://schemas.openxmlformats.org/drawingml/2006/main">
               <a:ext uri="{FF2B5EF4-FFF2-40B4-BE49-F238E27FC236}">
-                <a16:creationId xmlns:a16="http://schemas.microsoft.com/office/drawing/2014/main" id="{FE5C4746-04CB-4ED6-8901-A553F07C9252}"/>
+                <a16:creationId xmlns:a16="http://schemas.microsoft.com/office/drawing/2014/main" id="{908E89F2-0D5C-45C3-B073-7B665236124F}"/>
               </a:ext>
             </a:extLst>
           </p:cNvPr>
@@ -3996,7 +3946,7 @@
           <p:cNvPr id="6" name="">
             <a:extLst xmlns:a="http://schemas.openxmlformats.org/drawingml/2006/main">
               <a:ext uri="{FF2B5EF4-FFF2-40B4-BE49-F238E27FC236}">
-                <a16:creationId xmlns:a16="http://schemas.microsoft.com/office/drawing/2014/main" id="{AD606812-4879-4B96-B11E-25FD3F6FB949}"/>
+                <a16:creationId xmlns:a16="http://schemas.microsoft.com/office/drawing/2014/main" id="{A42E9006-A01C-4679-9B6B-BCF986723064}"/>
               </a:ext>
             </a:extLst>
           </p:cNvPr>
@@ -4076,7 +4026,7 @@
           <p:cNvPr id="7" name="">
             <a:extLst xmlns:a="http://schemas.openxmlformats.org/drawingml/2006/main">
               <a:ext uri="{FF2B5EF4-FFF2-40B4-BE49-F238E27FC236}">
-                <a16:creationId xmlns:a16="http://schemas.microsoft.com/office/drawing/2014/main" id="{C8CCBB5E-EE4E-4E8B-8419-770636ECB06B}"/>
+                <a16:creationId xmlns:a16="http://schemas.microsoft.com/office/drawing/2014/main" id="{D30F5AAE-77DE-48ED-BDCA-7CE166B635A0}"/>
               </a:ext>
             </a:extLst>
           </p:cNvPr>
@@ -4133,7 +4083,7 @@
           <p:cNvPr id="8" name="">
             <a:extLst xmlns:a="http://schemas.openxmlformats.org/drawingml/2006/main">
               <a:ext uri="{FF2B5EF4-FFF2-40B4-BE49-F238E27FC236}">
-                <a16:creationId xmlns:a16="http://schemas.microsoft.com/office/drawing/2014/main" id="{C792F943-B531-42BF-846C-504005F8CB51}"/>
+                <a16:creationId xmlns:a16="http://schemas.microsoft.com/office/drawing/2014/main" id="{C20EF3DA-CFFE-4207-B787-F8AD9E8BFD81}"/>
               </a:ext>
             </a:extLst>
           </p:cNvPr>
@@ -4213,7 +4163,7 @@
           <p:cNvPr id="9" name="">
             <a:extLst xmlns:a="http://schemas.openxmlformats.org/drawingml/2006/main">
               <a:ext uri="{FF2B5EF4-FFF2-40B4-BE49-F238E27FC236}">
-                <a16:creationId xmlns:a16="http://schemas.microsoft.com/office/drawing/2014/main" id="{5419ED63-84CD-4242-8B33-EE2D7711465C}"/>
+                <a16:creationId xmlns:a16="http://schemas.microsoft.com/office/drawing/2014/main" id="{20000228-621A-4499-808B-81D833FD7956}"/>
               </a:ext>
             </a:extLst>
           </p:cNvPr>
@@ -4270,7 +4220,7 @@
           <p:cNvPr id="10" name="">
             <a:extLst xmlns:a="http://schemas.openxmlformats.org/drawingml/2006/main">
               <a:ext uri="{FF2B5EF4-FFF2-40B4-BE49-F238E27FC236}">
-                <a16:creationId xmlns:a16="http://schemas.microsoft.com/office/drawing/2014/main" id="{28B85A7A-F7FE-44E2-A075-0255BB25A41B}"/>
+                <a16:creationId xmlns:a16="http://schemas.microsoft.com/office/drawing/2014/main" id="{1B8B9A0B-4AC2-4F05-B874-2ADFD40A37DF}"/>
               </a:ext>
             </a:extLst>
           </p:cNvPr>
@@ -4350,7 +4300,7 @@
           <p:cNvPr id="11" name="">
             <a:extLst xmlns:a="http://schemas.openxmlformats.org/drawingml/2006/main">
               <a:ext uri="{FF2B5EF4-FFF2-40B4-BE49-F238E27FC236}">
-                <a16:creationId xmlns:a16="http://schemas.microsoft.com/office/drawing/2014/main" id="{884FB93D-ADE0-4AF3-880D-E36EDBC1842A}"/>
+                <a16:creationId xmlns:a16="http://schemas.microsoft.com/office/drawing/2014/main" id="{18B07B42-0489-49F7-B838-9DDC0B56D490}"/>
               </a:ext>
             </a:extLst>
           </p:cNvPr>
@@ -4405,7 +4355,7 @@
     </p:spTree>
     <p:extLst>
       <p:ext uri="{BB962C8B-B14F-4D97-AF65-F5344CB8AC3E}">
-        <p14:creationId xmlns:p14="http://schemas.microsoft.com/office/powerpoint/2010/main" val="1894887659"/>
+        <p14:creationId xmlns:p14="http://schemas.microsoft.com/office/powerpoint/2010/main" val="1399676675"/>
       </p:ext>
     </p:extLst>
   </p:cSld>
@@ -4436,7 +4386,7 @@
           <p:cNvPr id="11" name="">
             <a:extLst xmlns:a="http://schemas.openxmlformats.org/drawingml/2006/main">
               <a:ext uri="{FF2B5EF4-FFF2-40B4-BE49-F238E27FC236}">
-                <a16:creationId xmlns:a16="http://schemas.microsoft.com/office/drawing/2014/main" id="{0D63B204-72CD-49D3-980C-4BA71527E206}"/>
+                <a16:creationId xmlns:a16="http://schemas.microsoft.com/office/drawing/2014/main" id="{DA4C8B3F-AF3B-499C-8BCA-AC44A094051C}"/>
               </a:ext>
             </a:extLst>
           </p:cNvPr>
@@ -4447,8 +4397,8 @@
         </p:nvSpPr>
         <p:spPr>
           <a:xfrm xmlns:a="http://schemas.openxmlformats.org/drawingml/2006/main">
-            <a:off x="666750" y="323850"/>
-            <a:ext cx="10858500" cy="628650"/>
+            <a:off x="666750" y="495300"/>
+            <a:ext cx="10858500" cy="571500"/>
           </a:xfrm>
           <a:prstGeom xmlns:a="http://schemas.openxmlformats.org/drawingml/2006/main" prst="rect">
             <a:avLst/>
@@ -4465,7 +4415,7 @@
           <a:lstStyle xmlns:a="http://schemas.openxmlformats.org/drawingml/2006/main"/>
           <a:p xmlns:a="http://schemas.openxmlformats.org/drawingml/2006/main">
             <a:pPr algn="l">
-              <a:defRPr sz="3150" b="1">
+              <a:defRPr sz="2700" b="1">
                 <a:solidFill>
                   <a:srgbClr val="183A63"/>
                 </a:solidFill>
@@ -4475,7 +4425,7 @@
               </a:defRPr>
             </a:pPr>
             <a:r>
-              <a:rPr sz="3150" b="1">
+              <a:rPr sz="2700" b="1">
                 <a:solidFill>
                   <a:srgbClr val="183A63"/>
                 </a:solidFill>
@@ -4493,7 +4443,7 @@
           <p:cNvPr id="2" name="">
             <a:extLst xmlns:a="http://schemas.openxmlformats.org/drawingml/2006/main">
               <a:ext uri="{FF2B5EF4-FFF2-40B4-BE49-F238E27FC236}">
-                <a16:creationId xmlns:a16="http://schemas.microsoft.com/office/drawing/2014/main" id="{9BA74E78-CEBA-4593-9288-B5B653F80455}"/>
+                <a16:creationId xmlns:a16="http://schemas.microsoft.com/office/drawing/2014/main" id="{E655E8F4-514D-4675-B129-842675C13E48}"/>
               </a:ext>
             </a:extLst>
           </p:cNvPr>
@@ -4550,7 +4500,7 @@
           <p:cNvPr id="3" name="">
             <a:extLst xmlns:a="http://schemas.openxmlformats.org/drawingml/2006/main">
               <a:ext uri="{FF2B5EF4-FFF2-40B4-BE49-F238E27FC236}">
-                <a16:creationId xmlns:a16="http://schemas.microsoft.com/office/drawing/2014/main" id="{22E6E11B-932E-4DAE-861E-2EFAB93769C4}"/>
+                <a16:creationId xmlns:a16="http://schemas.microsoft.com/office/drawing/2014/main" id="{85CC9835-6531-46EC-92A8-0713E865EB93}"/>
               </a:ext>
             </a:extLst>
           </p:cNvPr>
@@ -4607,7 +4557,7 @@
           <p:cNvPr id="4" name="">
             <a:extLst xmlns:a="http://schemas.openxmlformats.org/drawingml/2006/main">
               <a:ext uri="{FF2B5EF4-FFF2-40B4-BE49-F238E27FC236}">
-                <a16:creationId xmlns:a16="http://schemas.microsoft.com/office/drawing/2014/main" id="{3E7065A3-2090-4F12-BE39-AD9435192827}"/>
+                <a16:creationId xmlns:a16="http://schemas.microsoft.com/office/drawing/2014/main" id="{4599A5B8-962C-448B-80C3-7F7DCE7E2578}"/>
               </a:ext>
             </a:extLst>
           </p:cNvPr>
@@ -4687,7 +4637,7 @@
           <p:cNvPr id="5" name="">
             <a:extLst xmlns:a="http://schemas.openxmlformats.org/drawingml/2006/main">
               <a:ext uri="{FF2B5EF4-FFF2-40B4-BE49-F238E27FC236}">
-                <a16:creationId xmlns:a16="http://schemas.microsoft.com/office/drawing/2014/main" id="{DC8797AE-832D-4050-B227-C9F2E911F6FD}"/>
+                <a16:creationId xmlns:a16="http://schemas.microsoft.com/office/drawing/2014/main" id="{B8C3BA1A-16D7-4B44-AF7A-276F9F644DF3}"/>
               </a:ext>
             </a:extLst>
           </p:cNvPr>
@@ -4744,7 +4694,7 @@
           <p:cNvPr id="6" name="">
             <a:extLst xmlns:a="http://schemas.openxmlformats.org/drawingml/2006/main">
               <a:ext uri="{FF2B5EF4-FFF2-40B4-BE49-F238E27FC236}">
-                <a16:creationId xmlns:a16="http://schemas.microsoft.com/office/drawing/2014/main" id="{03A7825C-0D85-4883-9EC1-C3AFF7E94672}"/>
+                <a16:creationId xmlns:a16="http://schemas.microsoft.com/office/drawing/2014/main" id="{166585A5-7D8B-40B3-B5B1-120D19562360}"/>
               </a:ext>
             </a:extLst>
           </p:cNvPr>
@@ -4824,7 +4774,7 @@
           <p:cNvPr id="7" name="">
             <a:extLst xmlns:a="http://schemas.openxmlformats.org/drawingml/2006/main">
               <a:ext uri="{FF2B5EF4-FFF2-40B4-BE49-F238E27FC236}">
-                <a16:creationId xmlns:a16="http://schemas.microsoft.com/office/drawing/2014/main" id="{721ADEA7-9A63-409C-8FBF-31C6F4D9B121}"/>
+                <a16:creationId xmlns:a16="http://schemas.microsoft.com/office/drawing/2014/main" id="{4278AB1D-738B-43D0-B096-2F7F09E37F1A}"/>
               </a:ext>
             </a:extLst>
           </p:cNvPr>
@@ -4881,7 +4831,7 @@
           <p:cNvPr id="8" name="">
             <a:extLst xmlns:a="http://schemas.openxmlformats.org/drawingml/2006/main">
               <a:ext uri="{FF2B5EF4-FFF2-40B4-BE49-F238E27FC236}">
-                <a16:creationId xmlns:a16="http://schemas.microsoft.com/office/drawing/2014/main" id="{9A52FBE9-FC65-4588-B526-299987B8A590}"/>
+                <a16:creationId xmlns:a16="http://schemas.microsoft.com/office/drawing/2014/main" id="{87B04080-CE44-401F-90C8-B81AE313BD7E}"/>
               </a:ext>
             </a:extLst>
           </p:cNvPr>
@@ -4961,7 +4911,7 @@
           <p:cNvPr id="9" name="">
             <a:extLst xmlns:a="http://schemas.openxmlformats.org/drawingml/2006/main">
               <a:ext uri="{FF2B5EF4-FFF2-40B4-BE49-F238E27FC236}">
-                <a16:creationId xmlns:a16="http://schemas.microsoft.com/office/drawing/2014/main" id="{89EA134B-2D20-4E45-BDBC-132BB4B62A2D}"/>
+                <a16:creationId xmlns:a16="http://schemas.microsoft.com/office/drawing/2014/main" id="{7EFBDF1B-192C-4998-AB1D-D05AFBCD158B}"/>
               </a:ext>
             </a:extLst>
           </p:cNvPr>
@@ -5018,7 +4968,7 @@
           <p:cNvPr id="10" name="">
             <a:extLst xmlns:a="http://schemas.openxmlformats.org/drawingml/2006/main">
               <a:ext uri="{FF2B5EF4-FFF2-40B4-BE49-F238E27FC236}">
-                <a16:creationId xmlns:a16="http://schemas.microsoft.com/office/drawing/2014/main" id="{CED828DB-1AA0-4866-9AFE-8A352471F6F2}"/>
+                <a16:creationId xmlns:a16="http://schemas.microsoft.com/office/drawing/2014/main" id="{49BF140C-0F47-4496-8074-B47602A31ECF}"/>
               </a:ext>
             </a:extLst>
           </p:cNvPr>
@@ -5073,7 +5023,7 @@
     </p:spTree>
     <p:extLst>
       <p:ext uri="{BB962C8B-B14F-4D97-AF65-F5344CB8AC3E}">
-        <p14:creationId xmlns:p14="http://schemas.microsoft.com/office/powerpoint/2010/main" val="1750819969"/>
+        <p14:creationId xmlns:p14="http://schemas.microsoft.com/office/powerpoint/2010/main" val="627245991"/>
       </p:ext>
     </p:extLst>
   </p:cSld>
@@ -5104,7 +5054,7 @@
           <p:cNvPr id="6" name="">
             <a:extLst xmlns:a="http://schemas.openxmlformats.org/drawingml/2006/main">
               <a:ext uri="{FF2B5EF4-FFF2-40B4-BE49-F238E27FC236}">
-                <a16:creationId xmlns:a16="http://schemas.microsoft.com/office/drawing/2014/main" id="{648C41A6-CA29-4BFE-8845-3122E5EBE014}"/>
+                <a16:creationId xmlns:a16="http://schemas.microsoft.com/office/drawing/2014/main" id="{4016F21B-7691-4C6B-9941-4C678F598CB8}"/>
               </a:ext>
             </a:extLst>
           </p:cNvPr>
@@ -5115,8 +5065,8 @@
         </p:nvSpPr>
         <p:spPr>
           <a:xfrm xmlns:a="http://schemas.openxmlformats.org/drawingml/2006/main">
-            <a:off x="666750" y="323850"/>
-            <a:ext cx="10858500" cy="628650"/>
+            <a:off x="666750" y="495300"/>
+            <a:ext cx="10858500" cy="571500"/>
           </a:xfrm>
           <a:prstGeom xmlns:a="http://schemas.openxmlformats.org/drawingml/2006/main" prst="rect">
             <a:avLst/>
@@ -5133,7 +5083,7 @@
           <a:lstStyle xmlns:a="http://schemas.openxmlformats.org/drawingml/2006/main"/>
           <a:p xmlns:a="http://schemas.openxmlformats.org/drawingml/2006/main">
             <a:pPr algn="l">
-              <a:defRPr sz="3150" b="1">
+              <a:defRPr sz="2700" b="1">
                 <a:solidFill>
                   <a:srgbClr val="183A63"/>
                 </a:solidFill>
@@ -5143,7 +5093,7 @@
               </a:defRPr>
             </a:pPr>
             <a:r>
-              <a:rPr sz="3150" b="1">
+              <a:rPr sz="2700" b="1">
                 <a:solidFill>
                   <a:srgbClr val="183A63"/>
                 </a:solidFill>
@@ -5161,7 +5111,7 @@
           <p:cNvPr id="2" name="">
             <a:extLst xmlns:a="http://schemas.openxmlformats.org/drawingml/2006/main">
               <a:ext uri="{FF2B5EF4-FFF2-40B4-BE49-F238E27FC236}">
-                <a16:creationId xmlns:a16="http://schemas.microsoft.com/office/drawing/2014/main" id="{6CD8798A-2668-4FBD-9A53-6FBE7000258C}"/>
+                <a16:creationId xmlns:a16="http://schemas.microsoft.com/office/drawing/2014/main" id="{A2E688BA-380A-457A-AD9D-A5B4EC2EF828}"/>
               </a:ext>
             </a:extLst>
           </p:cNvPr>
@@ -5537,7 +5487,7 @@
           <p:cNvPr id="4" name="">
             <a:extLst xmlns:a="http://schemas.openxmlformats.org/drawingml/2006/main">
               <a:ext uri="{FF2B5EF4-FFF2-40B4-BE49-F238E27FC236}">
-                <a16:creationId xmlns:a16="http://schemas.microsoft.com/office/drawing/2014/main" id="{8A640481-CA71-4772-98C0-5EA163314CBE}"/>
+                <a16:creationId xmlns:a16="http://schemas.microsoft.com/office/drawing/2014/main" id="{617FC581-6C36-41F8-8578-2ED4F7DDB1C6}"/>
               </a:ext>
             </a:extLst>
           </p:cNvPr>
@@ -5594,7 +5544,7 @@
           <p:cNvPr id="5" name="">
             <a:extLst xmlns:a="http://schemas.openxmlformats.org/drawingml/2006/main">
               <a:ext uri="{FF2B5EF4-FFF2-40B4-BE49-F238E27FC236}">
-                <a16:creationId xmlns:a16="http://schemas.microsoft.com/office/drawing/2014/main" id="{7B1D4744-263C-4246-AEA9-0A3438D47F28}"/>
+                <a16:creationId xmlns:a16="http://schemas.microsoft.com/office/drawing/2014/main" id="{F8DD3483-CCCB-46BC-ABF8-C79365A85551}"/>
               </a:ext>
             </a:extLst>
           </p:cNvPr>
@@ -5649,7 +5599,7 @@
     </p:spTree>
     <p:extLst>
       <p:ext uri="{BB962C8B-B14F-4D97-AF65-F5344CB8AC3E}">
-        <p14:creationId xmlns:p14="http://schemas.microsoft.com/office/powerpoint/2010/main" val="1166030265"/>
+        <p14:creationId xmlns:p14="http://schemas.microsoft.com/office/powerpoint/2010/main" val="1645497895"/>
       </p:ext>
     </p:extLst>
   </p:cSld>
@@ -5680,7 +5630,7 @@
           <p:cNvPr id="6" name="">
             <a:extLst xmlns:a="http://schemas.openxmlformats.org/drawingml/2006/main">
               <a:ext uri="{FF2B5EF4-FFF2-40B4-BE49-F238E27FC236}">
-                <a16:creationId xmlns:a16="http://schemas.microsoft.com/office/drawing/2014/main" id="{B58FBCA3-8248-449B-80B8-FC31950156B9}"/>
+                <a16:creationId xmlns:a16="http://schemas.microsoft.com/office/drawing/2014/main" id="{07DF8277-A25D-4124-8604-BBB1493C5DE2}"/>
               </a:ext>
             </a:extLst>
           </p:cNvPr>
@@ -5691,8 +5641,8 @@
         </p:nvSpPr>
         <p:spPr>
           <a:xfrm xmlns:a="http://schemas.openxmlformats.org/drawingml/2006/main">
-            <a:off x="666750" y="323850"/>
-            <a:ext cx="10858500" cy="628650"/>
+            <a:off x="666750" y="495300"/>
+            <a:ext cx="10858500" cy="571500"/>
           </a:xfrm>
           <a:prstGeom xmlns:a="http://schemas.openxmlformats.org/drawingml/2006/main" prst="rect">
             <a:avLst/>
@@ -5709,7 +5659,7 @@
           <a:lstStyle xmlns:a="http://schemas.openxmlformats.org/drawingml/2006/main"/>
           <a:p xmlns:a="http://schemas.openxmlformats.org/drawingml/2006/main">
             <a:pPr algn="l">
-              <a:defRPr sz="3150" b="1">
+              <a:defRPr sz="2700" b="1">
                 <a:solidFill>
                   <a:srgbClr val="183A63"/>
                 </a:solidFill>
@@ -5719,7 +5669,7 @@
               </a:defRPr>
             </a:pPr>
             <a:r>
-              <a:rPr sz="3150" b="1">
+              <a:rPr sz="2700" b="1">
                 <a:solidFill>
                   <a:srgbClr val="183A63"/>
                 </a:solidFill>
@@ -5737,7 +5687,7 @@
           <p:cNvPr id="2" name="">
             <a:extLst xmlns:a="http://schemas.openxmlformats.org/drawingml/2006/main">
               <a:ext uri="{FF2B5EF4-FFF2-40B4-BE49-F238E27FC236}">
-                <a16:creationId xmlns:a16="http://schemas.microsoft.com/office/drawing/2014/main" id="{E3CEAA7A-133F-402F-8CED-E06DCBAD0869}"/>
+                <a16:creationId xmlns:a16="http://schemas.microsoft.com/office/drawing/2014/main" id="{30AC9F95-5C04-4828-980D-946D8B70F2FC}"/>
               </a:ext>
             </a:extLst>
           </p:cNvPr>
@@ -6113,7 +6063,7 @@
           <p:cNvPr id="4" name="">
             <a:extLst xmlns:a="http://schemas.openxmlformats.org/drawingml/2006/main">
               <a:ext uri="{FF2B5EF4-FFF2-40B4-BE49-F238E27FC236}">
-                <a16:creationId xmlns:a16="http://schemas.microsoft.com/office/drawing/2014/main" id="{5D672BAB-A74A-45BA-96C6-9402E162DC87}"/>
+                <a16:creationId xmlns:a16="http://schemas.microsoft.com/office/drawing/2014/main" id="{121AD79F-BD92-49B4-9F33-5AC1230AB104}"/>
               </a:ext>
             </a:extLst>
           </p:cNvPr>
@@ -6170,7 +6120,7 @@
           <p:cNvPr id="5" name="">
             <a:extLst xmlns:a="http://schemas.openxmlformats.org/drawingml/2006/main">
               <a:ext uri="{FF2B5EF4-FFF2-40B4-BE49-F238E27FC236}">
-                <a16:creationId xmlns:a16="http://schemas.microsoft.com/office/drawing/2014/main" id="{BEB3A8C2-01D7-4BEE-B979-55F3A3CFA1EE}"/>
+                <a16:creationId xmlns:a16="http://schemas.microsoft.com/office/drawing/2014/main" id="{C601ADE6-E6A9-4287-8FB1-8BA6F1AA583F}"/>
               </a:ext>
             </a:extLst>
           </p:cNvPr>
@@ -6225,7 +6175,7 @@
     </p:spTree>
     <p:extLst>
       <p:ext uri="{BB962C8B-B14F-4D97-AF65-F5344CB8AC3E}">
-        <p14:creationId xmlns:p14="http://schemas.microsoft.com/office/powerpoint/2010/main" val="1788330637"/>
+        <p14:creationId xmlns:p14="http://schemas.microsoft.com/office/powerpoint/2010/main" val="829968619"/>
       </p:ext>
     </p:extLst>
   </p:cSld>
@@ -6256,7 +6206,7 @@
           <p:cNvPr id="8" name="">
             <a:extLst xmlns:a="http://schemas.openxmlformats.org/drawingml/2006/main">
               <a:ext uri="{FF2B5EF4-FFF2-40B4-BE49-F238E27FC236}">
-                <a16:creationId xmlns:a16="http://schemas.microsoft.com/office/drawing/2014/main" id="{1606B7FE-9233-49B4-93EE-F3849D3ACDC3}"/>
+                <a16:creationId xmlns:a16="http://schemas.microsoft.com/office/drawing/2014/main" id="{89092B85-B40B-46F1-A564-33C5DC131AF6}"/>
               </a:ext>
             </a:extLst>
           </p:cNvPr>
@@ -6267,8 +6217,8 @@
         </p:nvSpPr>
         <p:spPr>
           <a:xfrm xmlns:a="http://schemas.openxmlformats.org/drawingml/2006/main">
-            <a:off x="666750" y="323850"/>
-            <a:ext cx="10858500" cy="628650"/>
+            <a:off x="666750" y="495300"/>
+            <a:ext cx="10858500" cy="571500"/>
           </a:xfrm>
           <a:prstGeom xmlns:a="http://schemas.openxmlformats.org/drawingml/2006/main" prst="rect">
             <a:avLst/>
@@ -6285,7 +6235,7 @@
           <a:lstStyle xmlns:a="http://schemas.openxmlformats.org/drawingml/2006/main"/>
           <a:p xmlns:a="http://schemas.openxmlformats.org/drawingml/2006/main">
             <a:pPr algn="l">
-              <a:defRPr sz="3150" b="1">
+              <a:defRPr sz="2700" b="1">
                 <a:solidFill>
                   <a:srgbClr val="183A63"/>
                 </a:solidFill>
@@ -6295,7 +6245,7 @@
               </a:defRPr>
             </a:pPr>
             <a:r>
-              <a:rPr sz="3150" b="1">
+              <a:rPr sz="2700" b="1">
                 <a:solidFill>
                   <a:srgbClr val="183A63"/>
                 </a:solidFill>
@@ -6313,7 +6263,7 @@
           <p:cNvPr id="2" name="">
             <a:extLst xmlns:a="http://schemas.openxmlformats.org/drawingml/2006/main">
               <a:ext uri="{FF2B5EF4-FFF2-40B4-BE49-F238E27FC236}">
-                <a16:creationId xmlns:a16="http://schemas.microsoft.com/office/drawing/2014/main" id="{D2AB2628-14C3-441C-B8D2-CE058FAF7099}"/>
+                <a16:creationId xmlns:a16="http://schemas.microsoft.com/office/drawing/2014/main" id="{71F7690C-207E-4496-8F5D-DE352CDC2F61}"/>
               </a:ext>
             </a:extLst>
           </p:cNvPr>
@@ -6377,7 +6327,7 @@
         </p:xfrm>
         <a:graphic xmlns:a="http://schemas.openxmlformats.org/drawingml/2006/main">
           <a:graphicData uri="http://schemas.openxmlformats.org/drawingml/2006/chart">
-            <c:chart xmlns:r="http://schemas.openxmlformats.org/officeDocument/2006/relationships" xmlns:c="http://schemas.openxmlformats.org/drawingml/2006/chart" r:id="Re98b42bf79374cad"/>
+            <c:chart xmlns:r="http://schemas.openxmlformats.org/officeDocument/2006/relationships" xmlns:c="http://schemas.openxmlformats.org/drawingml/2006/chart" r:id="R65864b45fb9b4810"/>
           </a:graphicData>
         </a:graphic>
       </p:graphicFrame>
@@ -6386,7 +6336,7 @@
           <p:cNvPr id="4" name="">
             <a:extLst xmlns:a="http://schemas.openxmlformats.org/drawingml/2006/main">
               <a:ext uri="{FF2B5EF4-FFF2-40B4-BE49-F238E27FC236}">
-                <a16:creationId xmlns:a16="http://schemas.microsoft.com/office/drawing/2014/main" id="{BFB72849-CACA-4C39-83E6-EBD6DE1BC666}"/>
+                <a16:creationId xmlns:a16="http://schemas.microsoft.com/office/drawing/2014/main" id="{1466EBB1-B079-496E-BE34-41E2EFE7020E}"/>
               </a:ext>
             </a:extLst>
           </p:cNvPr>
@@ -6443,7 +6393,7 @@
           <p:cNvPr id="5" name="">
             <a:extLst xmlns:a="http://schemas.openxmlformats.org/drawingml/2006/main">
               <a:ext uri="{FF2B5EF4-FFF2-40B4-BE49-F238E27FC236}">
-                <a16:creationId xmlns:a16="http://schemas.microsoft.com/office/drawing/2014/main" id="{010D489A-746D-412E-A3C6-42CC2880ADA6}"/>
+                <a16:creationId xmlns:a16="http://schemas.microsoft.com/office/drawing/2014/main" id="{6F74EF3A-4675-456E-AEE8-0FE47AE9940A}"/>
               </a:ext>
             </a:extLst>
           </p:cNvPr>
@@ -6523,7 +6473,7 @@
           <p:cNvPr id="6" name="">
             <a:extLst xmlns:a="http://schemas.openxmlformats.org/drawingml/2006/main">
               <a:ext uri="{FF2B5EF4-FFF2-40B4-BE49-F238E27FC236}">
-                <a16:creationId xmlns:a16="http://schemas.microsoft.com/office/drawing/2014/main" id="{9A216EC9-CF2E-4BC5-B6CF-D97903C96B4F}"/>
+                <a16:creationId xmlns:a16="http://schemas.microsoft.com/office/drawing/2014/main" id="{4B8923D1-DEF9-40A4-95EA-8D5F661EE1B6}"/>
               </a:ext>
             </a:extLst>
           </p:cNvPr>
@@ -6626,7 +6576,7 @@
           <p:cNvPr id="7" name="">
             <a:extLst xmlns:a="http://schemas.openxmlformats.org/drawingml/2006/main">
               <a:ext uri="{FF2B5EF4-FFF2-40B4-BE49-F238E27FC236}">
-                <a16:creationId xmlns:a16="http://schemas.microsoft.com/office/drawing/2014/main" id="{6FDA5340-399A-40FB-AA7E-BD3BB938A873}"/>
+                <a16:creationId xmlns:a16="http://schemas.microsoft.com/office/drawing/2014/main" id="{6AD023F7-96E1-480B-9A7A-5B1A7E20ACBE}"/>
               </a:ext>
             </a:extLst>
           </p:cNvPr>
@@ -6681,7 +6631,7 @@
     </p:spTree>
     <p:extLst>
       <p:ext uri="{BB962C8B-B14F-4D97-AF65-F5344CB8AC3E}">
-        <p14:creationId xmlns:p14="http://schemas.microsoft.com/office/powerpoint/2010/main" val="246511939"/>
+        <p14:creationId xmlns:p14="http://schemas.microsoft.com/office/powerpoint/2010/main" val="231216573"/>
       </p:ext>
     </p:extLst>
   </p:cSld>
@@ -6712,7 +6662,7 @@
           <p:cNvPr id="10" name="">
             <a:extLst xmlns:a="http://schemas.openxmlformats.org/drawingml/2006/main">
               <a:ext uri="{FF2B5EF4-FFF2-40B4-BE49-F238E27FC236}">
-                <a16:creationId xmlns:a16="http://schemas.microsoft.com/office/drawing/2014/main" id="{45F5ECC3-1FAA-4F60-B611-EAE9971F69E8}"/>
+                <a16:creationId xmlns:a16="http://schemas.microsoft.com/office/drawing/2014/main" id="{0F43E412-43C3-43F7-B643-45EAF0215825}"/>
               </a:ext>
             </a:extLst>
           </p:cNvPr>
@@ -6723,8 +6673,8 @@
         </p:nvSpPr>
         <p:spPr>
           <a:xfrm xmlns:a="http://schemas.openxmlformats.org/drawingml/2006/main">
-            <a:off x="666750" y="323850"/>
-            <a:ext cx="10858500" cy="628650"/>
+            <a:off x="666750" y="495300"/>
+            <a:ext cx="10858500" cy="571500"/>
           </a:xfrm>
           <a:prstGeom xmlns:a="http://schemas.openxmlformats.org/drawingml/2006/main" prst="rect">
             <a:avLst/>
@@ -6741,7 +6691,7 @@
           <a:lstStyle xmlns:a="http://schemas.openxmlformats.org/drawingml/2006/main"/>
           <a:p xmlns:a="http://schemas.openxmlformats.org/drawingml/2006/main">
             <a:pPr algn="l">
-              <a:defRPr sz="3150" b="1">
+              <a:defRPr sz="2700" b="1">
                 <a:solidFill>
                   <a:srgbClr val="183A63"/>
                 </a:solidFill>
@@ -6751,7 +6701,7 @@
               </a:defRPr>
             </a:pPr>
             <a:r>
-              <a:rPr sz="3150" b="1">
+              <a:rPr sz="2700" b="1">
                 <a:solidFill>
                   <a:srgbClr val="183A63"/>
                 </a:solidFill>
@@ -6769,7 +6719,7 @@
           <p:cNvPr id="2" name="">
             <a:extLst xmlns:a="http://schemas.openxmlformats.org/drawingml/2006/main">
               <a:ext uri="{FF2B5EF4-FFF2-40B4-BE49-F238E27FC236}">
-                <a16:creationId xmlns:a16="http://schemas.microsoft.com/office/drawing/2014/main" id="{D219FA12-E140-4899-9D02-563B44E2B8F1}"/>
+                <a16:creationId xmlns:a16="http://schemas.microsoft.com/office/drawing/2014/main" id="{9B62E4D9-C02A-4C32-AA30-236FD34C3C80}"/>
               </a:ext>
             </a:extLst>
           </p:cNvPr>
@@ -6826,7 +6776,7 @@
           <p:cNvPr id="3" name="">
             <a:extLst xmlns:a="http://schemas.openxmlformats.org/drawingml/2006/main">
               <a:ext uri="{FF2B5EF4-FFF2-40B4-BE49-F238E27FC236}">
-                <a16:creationId xmlns:a16="http://schemas.microsoft.com/office/drawing/2014/main" id="{5D912B12-BC5A-417E-8A9C-758336A09DFC}"/>
+                <a16:creationId xmlns:a16="http://schemas.microsoft.com/office/drawing/2014/main" id="{E853359D-07CA-40CE-92ED-6685D29834EA}"/>
               </a:ext>
             </a:extLst>
           </p:cNvPr>
@@ -7128,7 +7078,7 @@
           <p:cNvPr id="5" name="">
             <a:extLst xmlns:a="http://schemas.openxmlformats.org/drawingml/2006/main">
               <a:ext uri="{FF2B5EF4-FFF2-40B4-BE49-F238E27FC236}">
-                <a16:creationId xmlns:a16="http://schemas.microsoft.com/office/drawing/2014/main" id="{580F7B04-A9F0-41A5-826F-FCC059655BD1}"/>
+                <a16:creationId xmlns:a16="http://schemas.microsoft.com/office/drawing/2014/main" id="{41CB93E3-3694-4113-87A9-CE9E38C692D4}"/>
               </a:ext>
             </a:extLst>
           </p:cNvPr>
@@ -7185,7 +7135,7 @@
           <p:cNvPr id="6" name="">
             <a:extLst xmlns:a="http://schemas.openxmlformats.org/drawingml/2006/main">
               <a:ext uri="{FF2B5EF4-FFF2-40B4-BE49-F238E27FC236}">
-                <a16:creationId xmlns:a16="http://schemas.microsoft.com/office/drawing/2014/main" id="{A5F89D4E-CF5A-4124-B54C-E8B02C7B9F1D}"/>
+                <a16:creationId xmlns:a16="http://schemas.microsoft.com/office/drawing/2014/main" id="{6F1A6F94-0252-4D3C-B234-06B9CBB44705}"/>
               </a:ext>
             </a:extLst>
           </p:cNvPr>
@@ -7242,7 +7192,7 @@
           <p:cNvPr id="7" name="">
             <a:extLst xmlns:a="http://schemas.openxmlformats.org/drawingml/2006/main">
               <a:ext uri="{FF2B5EF4-FFF2-40B4-BE49-F238E27FC236}">
-                <a16:creationId xmlns:a16="http://schemas.microsoft.com/office/drawing/2014/main" id="{378174A8-2890-4936-A6AC-5329431FA120}"/>
+                <a16:creationId xmlns:a16="http://schemas.microsoft.com/office/drawing/2014/main" id="{4A427EF5-4576-402E-BCC5-68444C04001A}"/>
               </a:ext>
             </a:extLst>
           </p:cNvPr>
@@ -7299,7 +7249,7 @@
           <p:cNvPr id="8" name="">
             <a:extLst xmlns:a="http://schemas.openxmlformats.org/drawingml/2006/main">
               <a:ext uri="{FF2B5EF4-FFF2-40B4-BE49-F238E27FC236}">
-                <a16:creationId xmlns:a16="http://schemas.microsoft.com/office/drawing/2014/main" id="{32858739-8E2C-41B2-90BD-7752495C7BB5}"/>
+                <a16:creationId xmlns:a16="http://schemas.microsoft.com/office/drawing/2014/main" id="{8F338D22-1754-48AB-92DA-553C51733153}"/>
               </a:ext>
             </a:extLst>
           </p:cNvPr>
@@ -7356,7 +7306,7 @@
           <p:cNvPr id="9" name="">
             <a:extLst xmlns:a="http://schemas.openxmlformats.org/drawingml/2006/main">
               <a:ext uri="{FF2B5EF4-FFF2-40B4-BE49-F238E27FC236}">
-                <a16:creationId xmlns:a16="http://schemas.microsoft.com/office/drawing/2014/main" id="{8F237DA7-9184-4C5A-8E1A-C2FD7D5D039F}"/>
+                <a16:creationId xmlns:a16="http://schemas.microsoft.com/office/drawing/2014/main" id="{A4A089F7-B1BD-4AFB-95EE-653FDB5FE0A3}"/>
               </a:ext>
             </a:extLst>
           </p:cNvPr>
@@ -7411,7 +7361,7 @@
     </p:spTree>
     <p:extLst>
       <p:ext uri="{BB962C8B-B14F-4D97-AF65-F5344CB8AC3E}">
-        <p14:creationId xmlns:p14="http://schemas.microsoft.com/office/powerpoint/2010/main" val="1869647125"/>
+        <p14:creationId xmlns:p14="http://schemas.microsoft.com/office/powerpoint/2010/main" val="586516284"/>
       </p:ext>
     </p:extLst>
   </p:cSld>
@@ -7442,7 +7392,7 @@
           <p:cNvPr id="5" name="">
             <a:extLst xmlns:a="http://schemas.openxmlformats.org/drawingml/2006/main">
               <a:ext uri="{FF2B5EF4-FFF2-40B4-BE49-F238E27FC236}">
-                <a16:creationId xmlns:a16="http://schemas.microsoft.com/office/drawing/2014/main" id="{4C184EA5-C0AD-4E20-831A-7D327E07AB85}"/>
+                <a16:creationId xmlns:a16="http://schemas.microsoft.com/office/drawing/2014/main" id="{C8ED97DB-CF15-4F0D-8712-E4F772F2DC9E}"/>
               </a:ext>
             </a:extLst>
           </p:cNvPr>
@@ -7453,8 +7403,8 @@
         </p:nvSpPr>
         <p:spPr>
           <a:xfrm xmlns:a="http://schemas.openxmlformats.org/drawingml/2006/main">
-            <a:off x="666750" y="323850"/>
-            <a:ext cx="10858500" cy="628650"/>
+            <a:off x="666750" y="495300"/>
+            <a:ext cx="10858500" cy="571500"/>
           </a:xfrm>
           <a:prstGeom xmlns:a="http://schemas.openxmlformats.org/drawingml/2006/main" prst="rect">
             <a:avLst/>
@@ -7471,7 +7421,7 @@
           <a:lstStyle xmlns:a="http://schemas.openxmlformats.org/drawingml/2006/main"/>
           <a:p xmlns:a="http://schemas.openxmlformats.org/drawingml/2006/main">
             <a:pPr algn="l">
-              <a:defRPr sz="3150" b="1">
+              <a:defRPr sz="2700" b="1">
                 <a:solidFill>
                   <a:srgbClr val="183A63"/>
                 </a:solidFill>
@@ -7481,7 +7431,7 @@
               </a:defRPr>
             </a:pPr>
             <a:r>
-              <a:rPr sz="3150" b="1">
+              <a:rPr sz="2700" b="1">
                 <a:solidFill>
                   <a:srgbClr val="183A63"/>
                 </a:solidFill>
@@ -7499,7 +7449,7 @@
           <p:cNvPr id="2" name="">
             <a:extLst xmlns:a="http://schemas.openxmlformats.org/drawingml/2006/main">
               <a:ext uri="{FF2B5EF4-FFF2-40B4-BE49-F238E27FC236}">
-                <a16:creationId xmlns:a16="http://schemas.microsoft.com/office/drawing/2014/main" id="{FF356096-57F3-44F1-A973-69AD5EC24C4B}"/>
+                <a16:creationId xmlns:a16="http://schemas.microsoft.com/office/drawing/2014/main" id="{610F1A92-1396-409B-BF01-DE977352EA47}"/>
               </a:ext>
             </a:extLst>
           </p:cNvPr>
@@ -7558,8 +7508,8 @@
           <p:nvPr/>
         </p:nvGraphicFramePr>
         <p:xfrm>
-          <a:off xmlns:a="http://schemas.openxmlformats.org/drawingml/2006/main" x="666750" y="1238250"/>
-          <a:ext xmlns:a="http://schemas.openxmlformats.org/drawingml/2006/main" cx="10858500" cy="4476750"/>
+          <a:off xmlns:a="http://schemas.openxmlformats.org/drawingml/2006/main" x="666750" y="1162050"/>
+          <a:ext xmlns:a="http://schemas.openxmlformats.org/drawingml/2006/main" cx="10858500" cy="4857750"/>
         </p:xfrm>
         <a:graphic xmlns:a="http://schemas.openxmlformats.org/drawingml/2006/main">
           <a:graphicData uri="http://schemas.openxmlformats.org/drawingml/2006/table">
@@ -7569,14 +7519,14 @@
                 <a:gridCol w="4000500"/>
                 <a:gridCol w="6858000"/>
               </a:tblGrid>
-              <a:tr h="639536">
+              <a:tr h="485775">
                 <a:tc>
                   <a:txBody>
                     <a:bodyPr/>
                     <a:lstStyle/>
                     <a:p>
                       <a:r>
-                        <a:rPr sz="1275" b="1">
+                        <a:rPr sz="1125" b="1">
                           <a:solidFill>
                             <a:srgbClr val="FFFFFF"/>
                           </a:solidFill>
@@ -7600,7 +7550,7 @@
                     <a:lstStyle/>
                     <a:p>
                       <a:r>
-                        <a:rPr sz="1275" b="1">
+                        <a:rPr sz="1125" b="1">
                           <a:solidFill>
                             <a:srgbClr val="FFFFFF"/>
                           </a:solidFill>
@@ -7619,14 +7569,14 @@
                   </a:tcPr>
                 </a:tc>
               </a:tr>
-              <a:tr h="639536">
+              <a:tr h="485775">
                 <a:tc>
                   <a:txBody>
                     <a:bodyPr/>
                     <a:lstStyle/>
                     <a:p>
                       <a:r>
-                        <a:rPr sz="1275">
+                        <a:rPr sz="1125">
                           <a:solidFill>
                             <a:srgbClr val="202B38"/>
                           </a:solidFill>
@@ -7650,7 +7600,7 @@
                     <a:lstStyle/>
                     <a:p>
                       <a:r>
-                        <a:rPr sz="1275">
+                        <a:rPr sz="1125">
                           <a:solidFill>
                             <a:srgbClr val="202B38"/>
                           </a:solidFill>
@@ -7669,14 +7619,14 @@
                   </a:tcPr>
                 </a:tc>
               </a:tr>
-              <a:tr h="639536">
+              <a:tr h="485775">
                 <a:tc>
                   <a:txBody>
                     <a:bodyPr/>
                     <a:lstStyle/>
                     <a:p>
                       <a:r>
-                        <a:rPr sz="1275">
+                        <a:rPr sz="1125">
                           <a:solidFill>
                             <a:srgbClr val="202B38"/>
                           </a:solidFill>
@@ -7700,7 +7650,7 @@
                     <a:lstStyle/>
                     <a:p>
                       <a:r>
-                        <a:rPr sz="1275">
+                        <a:rPr sz="1125">
                           <a:solidFill>
                             <a:srgbClr val="202B38"/>
                           </a:solidFill>
@@ -7719,14 +7669,14 @@
                   </a:tcPr>
                 </a:tc>
               </a:tr>
-              <a:tr h="639536">
+              <a:tr h="485775">
                 <a:tc>
                   <a:txBody>
                     <a:bodyPr/>
                     <a:lstStyle/>
                     <a:p>
                       <a:r>
-                        <a:rPr sz="1275">
+                        <a:rPr sz="1125">
                           <a:solidFill>
                             <a:srgbClr val="202B38"/>
                           </a:solidFill>
@@ -7750,7 +7700,7 @@
                     <a:lstStyle/>
                     <a:p>
                       <a:r>
-                        <a:rPr sz="1275">
+                        <a:rPr sz="1125">
                           <a:solidFill>
                             <a:srgbClr val="202B38"/>
                           </a:solidFill>
@@ -7769,14 +7719,14 @@
                   </a:tcPr>
                 </a:tc>
               </a:tr>
-              <a:tr h="639536">
+              <a:tr h="485775">
                 <a:tc>
                   <a:txBody>
                     <a:bodyPr/>
                     <a:lstStyle/>
                     <a:p>
                       <a:r>
-                        <a:rPr sz="1275">
+                        <a:rPr sz="1125">
                           <a:solidFill>
                             <a:srgbClr val="202B38"/>
                           </a:solidFill>
@@ -7800,7 +7750,7 @@
                     <a:lstStyle/>
                     <a:p>
                       <a:r>
-                        <a:rPr sz="1275">
+                        <a:rPr sz="1125">
                           <a:solidFill>
                             <a:srgbClr val="202B38"/>
                           </a:solidFill>
@@ -7819,14 +7769,14 @@
                   </a:tcPr>
                 </a:tc>
               </a:tr>
-              <a:tr h="639536">
+              <a:tr h="485775">
                 <a:tc>
                   <a:txBody>
                     <a:bodyPr/>
                     <a:lstStyle/>
                     <a:p>
                       <a:r>
-                        <a:rPr sz="1275">
+                        <a:rPr sz="1125">
                           <a:solidFill>
                             <a:srgbClr val="202B38"/>
                           </a:solidFill>
@@ -7850,7 +7800,7 @@
                     <a:lstStyle/>
                     <a:p>
                       <a:r>
-                        <a:rPr sz="1275">
+                        <a:rPr sz="1125">
                           <a:solidFill>
                             <a:srgbClr val="202B38"/>
                           </a:solidFill>
@@ -7869,14 +7819,14 @@
                   </a:tcPr>
                 </a:tc>
               </a:tr>
-              <a:tr h="639536">
+              <a:tr h="485775">
                 <a:tc>
                   <a:txBody>
                     <a:bodyPr/>
                     <a:lstStyle/>
                     <a:p>
                       <a:r>
-                        <a:rPr sz="1275">
+                        <a:rPr sz="1125">
                           <a:solidFill>
                             <a:srgbClr val="202B38"/>
                           </a:solidFill>
@@ -7884,7 +7834,7 @@
                           <a:ea typeface="Aptos"/>
                           <a:cs typeface="Aptos"/>
                         </a:rPr>
-                        <a:t>Selección justificada</a:t>
+                        <a:t>Entrenamiento desde Python</a:t>
                       </a:r>
                     </a:p>
                   </a:txBody>
@@ -7900,7 +7850,7 @@
                     <a:lstStyle/>
                     <a:p>
                       <a:r>
-                        <a:rPr sz="1275">
+                        <a:rPr sz="1125">
                           <a:solidFill>
                             <a:srgbClr val="202B38"/>
                           </a:solidFill>
@@ -7908,7 +7858,7 @@
                           <a:ea typeface="Aptos"/>
                           <a:cs typeface="Aptos"/>
                         </a:rPr>
-                        <a:t>Recall prioritario y métricas complementarias</a:t>
+                        <a:t>src/training/train.py ejecutable como módulo</a:t>
                       </a:r>
                     </a:p>
                   </a:txBody>
@@ -7919,6 +7869,156 @@
                   </a:tcPr>
                 </a:tc>
               </a:tr>
+              <a:tr h="485775">
+                <a:tc>
+                  <a:txBody>
+                    <a:bodyPr/>
+                    <a:lstStyle/>
+                    <a:p>
+                      <a:r>
+                        <a:rPr sz="1125">
+                          <a:solidFill>
+                            <a:srgbClr val="202B38"/>
+                          </a:solidFill>
+                          <a:latin typeface="Aptos"/>
+                          <a:ea typeface="Aptos"/>
+                          <a:cs typeface="Aptos"/>
+                        </a:rPr>
+                        <a:t>Pruebas automáticas</a:t>
+                      </a:r>
+                    </a:p>
+                  </a:txBody>
+                  <a:tcPr marL="91440" marR="91440" marT="45720" marB="45720" anchor="ctr">
+                    <a:solidFill>
+                      <a:srgbClr val="FFFFFF"/>
+                    </a:solidFill>
+                  </a:tcPr>
+                </a:tc>
+                <a:tc>
+                  <a:txBody>
+                    <a:bodyPr/>
+                    <a:lstStyle/>
+                    <a:p>
+                      <a:r>
+                        <a:rPr sz="1125">
+                          <a:solidFill>
+                            <a:srgbClr val="202B38"/>
+                          </a:solidFill>
+                          <a:latin typeface="Aptos"/>
+                          <a:ea typeface="Aptos"/>
+                          <a:cs typeface="Aptos"/>
+                        </a:rPr>
+                        <a:t>Métricas y preprocesamiento comprobados</a:t>
+                      </a:r>
+                    </a:p>
+                  </a:txBody>
+                  <a:tcPr marL="91440" marR="91440" marT="45720" marB="45720" anchor="ctr">
+                    <a:solidFill>
+                      <a:srgbClr val="FFFFFF"/>
+                    </a:solidFill>
+                  </a:tcPr>
+                </a:tc>
+              </a:tr>
+              <a:tr h="485775">
+                <a:tc>
+                  <a:txBody>
+                    <a:bodyPr/>
+                    <a:lstStyle/>
+                    <a:p>
+                      <a:r>
+                        <a:rPr sz="1125">
+                          <a:solidFill>
+                            <a:srgbClr val="202B38"/>
+                          </a:solidFill>
+                          <a:latin typeface="Aptos"/>
+                          <a:ea typeface="Aptos"/>
+                          <a:cs typeface="Aptos"/>
+                        </a:rPr>
+                        <a:t>Dataset rastreado con DVC</a:t>
+                      </a:r>
+                    </a:p>
+                  </a:txBody>
+                  <a:tcPr marL="91440" marR="91440" marT="45720" marB="45720" anchor="ctr">
+                    <a:solidFill>
+                      <a:srgbClr val="E8F0F5"/>
+                    </a:solidFill>
+                  </a:tcPr>
+                </a:tc>
+                <a:tc>
+                  <a:txBody>
+                    <a:bodyPr/>
+                    <a:lstStyle/>
+                    <a:p>
+                      <a:r>
+                        <a:rPr sz="1125">
+                          <a:solidFill>
+                            <a:srgbClr val="202B38"/>
+                          </a:solidFill>
+                          <a:latin typeface="Aptos"/>
+                          <a:ea typeface="Aptos"/>
+                          <a:cs typeface="Aptos"/>
+                        </a:rPr>
+                        <a:t>Archivo .dvc y cache local verificados</a:t>
+                      </a:r>
+                    </a:p>
+                  </a:txBody>
+                  <a:tcPr marL="91440" marR="91440" marT="45720" marB="45720" anchor="ctr">
+                    <a:solidFill>
+                      <a:srgbClr val="E8F0F5"/>
+                    </a:solidFill>
+                  </a:tcPr>
+                </a:tc>
+              </a:tr>
+              <a:tr h="485775">
+                <a:tc>
+                  <a:txBody>
+                    <a:bodyPr/>
+                    <a:lstStyle/>
+                    <a:p>
+                      <a:r>
+                        <a:rPr sz="1125">
+                          <a:solidFill>
+                            <a:srgbClr val="202B38"/>
+                          </a:solidFill>
+                          <a:latin typeface="Aptos"/>
+                          <a:ea typeface="Aptos"/>
+                          <a:cs typeface="Aptos"/>
+                        </a:rPr>
+                        <a:t>Remote DVC configurado</a:t>
+                      </a:r>
+                    </a:p>
+                  </a:txBody>
+                  <a:tcPr marL="91440" marR="91440" marT="45720" marB="45720" anchor="ctr">
+                    <a:solidFill>
+                      <a:srgbClr val="FFFFFF"/>
+                    </a:solidFill>
+                  </a:tcPr>
+                </a:tc>
+                <a:tc>
+                  <a:txBody>
+                    <a:bodyPr/>
+                    <a:lstStyle/>
+                    <a:p>
+                      <a:r>
+                        <a:rPr sz="1125">
+                          <a:solidFill>
+                            <a:srgbClr val="202B38"/>
+                          </a:solidFill>
+                          <a:latin typeface="Aptos"/>
+                          <a:ea typeface="Aptos"/>
+                          <a:cs typeface="Aptos"/>
+                        </a:rPr>
+                        <a:t>DagsHub: giselle.san/entregaPrimerParcial</a:t>
+                      </a:r>
+                    </a:p>
+                  </a:txBody>
+                  <a:tcPr marL="91440" marR="91440" marT="45720" marB="45720" anchor="ctr">
+                    <a:solidFill>
+                      <a:srgbClr val="FFFFFF"/>
+                    </a:solidFill>
+                  </a:tcPr>
+                </a:tc>
+              </a:tr>
             </a:tbl>
           </a:graphicData>
         </a:graphic>
@@ -7928,7 +8028,7 @@
           <p:cNvPr id="4" name="">
             <a:extLst xmlns:a="http://schemas.openxmlformats.org/drawingml/2006/main">
               <a:ext uri="{FF2B5EF4-FFF2-40B4-BE49-F238E27FC236}">
-                <a16:creationId xmlns:a16="http://schemas.microsoft.com/office/drawing/2014/main" id="{4502704E-E720-47CF-84E6-5D38CDD40495}"/>
+                <a16:creationId xmlns:a16="http://schemas.microsoft.com/office/drawing/2014/main" id="{8BA51312-769F-4861-82B4-9553AD5EFD62}"/>
               </a:ext>
             </a:extLst>
           </p:cNvPr>
@@ -7939,8 +8039,8 @@
         </p:nvSpPr>
         <p:spPr>
           <a:xfrm xmlns:a="http://schemas.openxmlformats.org/drawingml/2006/main">
-            <a:off x="1714500" y="5905500"/>
-            <a:ext cx="8763000" cy="400050"/>
+            <a:off x="1714500" y="6115050"/>
+            <a:ext cx="8763000" cy="333375"/>
           </a:xfrm>
           <a:prstGeom xmlns:a="http://schemas.openxmlformats.org/drawingml/2006/main" prst="rect">
             <a:avLst/>
@@ -7957,7 +8057,7 @@
           <a:lstStyle xmlns:a="http://schemas.openxmlformats.org/drawingml/2006/main"/>
           <a:p xmlns:a="http://schemas.openxmlformats.org/drawingml/2006/main">
             <a:pPr algn="ctr">
-              <a:defRPr sz="1725" b="1">
+              <a:defRPr sz="1500" b="1">
                 <a:solidFill>
                   <a:srgbClr val="2F7D55"/>
                 </a:solidFill>
@@ -7967,7 +8067,7 @@
               </a:defRPr>
             </a:pPr>
             <a:r>
-              <a:rPr sz="1725" b="1">
+              <a:rPr sz="1500" b="1">
                 <a:solidFill>
                   <a:srgbClr val="2F7D55"/>
                 </a:solidFill>
@@ -7975,7 +8075,7 @@
                 <a:ea typeface="Aptos"/>
                 <a:cs typeface="Aptos"/>
               </a:rPr>
-              <a:t>Estos puntos pueden verificarse directamente en el notebook.</a:t>
+              <a:t>El notebook conserva el análisis y src contiene la lógica reutilizable.</a:t>
             </a:r>
           </a:p>
         </p:txBody>
@@ -7983,7 +8083,7 @@
     </p:spTree>
     <p:extLst>
       <p:ext uri="{BB962C8B-B14F-4D97-AF65-F5344CB8AC3E}">
-        <p14:creationId xmlns:p14="http://schemas.microsoft.com/office/powerpoint/2010/main" val="714015638"/>
+        <p14:creationId xmlns:p14="http://schemas.microsoft.com/office/powerpoint/2010/main" val="1518022377"/>
       </p:ext>
     </p:extLst>
   </p:cSld>

</xml_diff>

<commit_message>
Completa MLflow y evidencias
</commit_message>
<xml_diff>
--- a/Presentacion_Customer_Churn_Profesor.pptx
+++ b/Presentacion_Customer_Churn_Profesor.pptx
@@ -2,22 +2,22 @@
 <file path=ppt/presentation.xml><?xml version="1.0" encoding="utf-8"?>
 <p:presentation xmlns:p="http://schemas.openxmlformats.org/presentationml/2006/main">
   <p:sldMasterIdLst>
-    <p:sldMasterId xmlns:r="http://schemas.openxmlformats.org/officeDocument/2006/relationships" id="2147483648" r:id="R7413c3b3d81349c9"/>
+    <p:sldMasterId xmlns:r="http://schemas.openxmlformats.org/officeDocument/2006/relationships" id="2147483648" r:id="R5ad306ddce6c4177"/>
   </p:sldMasterIdLst>
   <p:notesMasterIdLst>
-    <p:notesMasterId xmlns:r="http://schemas.openxmlformats.org/officeDocument/2006/relationships" r:id="R970c31b3d74b4aaa"/>
+    <p:notesMasterId xmlns:r="http://schemas.openxmlformats.org/officeDocument/2006/relationships" r:id="R94d0ab3397aa4cac"/>
   </p:notesMasterIdLst>
   <p:sldIdLst>
-    <p:sldId xmlns:r="http://schemas.openxmlformats.org/officeDocument/2006/relationships" id="256" r:id="R43aebc412b274b0b"/>
-    <p:sldId xmlns:r="http://schemas.openxmlformats.org/officeDocument/2006/relationships" id="257" r:id="R476f24603d804ac2"/>
-    <p:sldId xmlns:r="http://schemas.openxmlformats.org/officeDocument/2006/relationships" id="258" r:id="Rb71a323ff42f46aa"/>
-    <p:sldId xmlns:r="http://schemas.openxmlformats.org/officeDocument/2006/relationships" id="259" r:id="R75c4e03341ee4577"/>
-    <p:sldId xmlns:r="http://schemas.openxmlformats.org/officeDocument/2006/relationships" id="260" r:id="Re207797c7ec44dbb"/>
-    <p:sldId xmlns:r="http://schemas.openxmlformats.org/officeDocument/2006/relationships" id="261" r:id="R9ff364547a6142ea"/>
-    <p:sldId xmlns:r="http://schemas.openxmlformats.org/officeDocument/2006/relationships" id="262" r:id="R9e9203bba9744b16"/>
-    <p:sldId xmlns:r="http://schemas.openxmlformats.org/officeDocument/2006/relationships" id="263" r:id="R24e9b8804fdb4699"/>
-    <p:sldId xmlns:r="http://schemas.openxmlformats.org/officeDocument/2006/relationships" id="264" r:id="R1baca44891384cd7"/>
-    <p:sldId xmlns:r="http://schemas.openxmlformats.org/officeDocument/2006/relationships" id="265" r:id="R45a8befa750e4b6b"/>
+    <p:sldId xmlns:r="http://schemas.openxmlformats.org/officeDocument/2006/relationships" id="256" r:id="Rce5ea2d5b6a44943"/>
+    <p:sldId xmlns:r="http://schemas.openxmlformats.org/officeDocument/2006/relationships" id="257" r:id="R6707963a5f2f41c8"/>
+    <p:sldId xmlns:r="http://schemas.openxmlformats.org/officeDocument/2006/relationships" id="258" r:id="R2c1fa98f881c4df9"/>
+    <p:sldId xmlns:r="http://schemas.openxmlformats.org/officeDocument/2006/relationships" id="259" r:id="Rd263ced642944bdb"/>
+    <p:sldId xmlns:r="http://schemas.openxmlformats.org/officeDocument/2006/relationships" id="260" r:id="R35e11bc6120d4bc5"/>
+    <p:sldId xmlns:r="http://schemas.openxmlformats.org/officeDocument/2006/relationships" id="261" r:id="Ra093d36e802444bf"/>
+    <p:sldId xmlns:r="http://schemas.openxmlformats.org/officeDocument/2006/relationships" id="262" r:id="R5751410aed3a4b8e"/>
+    <p:sldId xmlns:r="http://schemas.openxmlformats.org/officeDocument/2006/relationships" id="263" r:id="Rf001e941562f4e07"/>
+    <p:sldId xmlns:r="http://schemas.openxmlformats.org/officeDocument/2006/relationships" id="264" r:id="R6657dd313a894d22"/>
+    <p:sldId xmlns:r="http://schemas.openxmlformats.org/officeDocument/2006/relationships" id="265" r:id="Rac0d72c7cf5a43ec"/>
   </p:sldIdLst>
   <p:sldSz cx="12192000" cy="6858000"/>
   <p:notesSz cx="6858000" cy="9144000"/>
@@ -731,7 +731,7 @@
           <a:lstStyle xmlns:a="http://schemas.openxmlformats.org/drawingml/2006/main"/>
           <a:p xmlns:a="http://schemas.openxmlformats.org/drawingml/2006/main">
             <a:r>
-              <a:t>Fuente: celda de partición train/test del notebook. test_size=0.2, stratify=y y random_state=42.</a:t>
+              <a:t>Fuente: src/training/train.py. Separación estratificada 60/20/20 con random_state=42.</a:t>
             </a:r>
           </a:p>
         </p:txBody>
@@ -871,7 +871,7 @@
           <a:lstStyle xmlns:a="http://schemas.openxmlformats.org/drawingml/2006/main"/>
           <a:p xmlns:a="http://schemas.openxmlformats.org/drawingml/2006/main">
             <a:r>
-              <a:t>Fuente: secciones 9.1, 9.2 y 9.3 del notebook.</a:t>
+              <a:t>Fuente: lista model_candidates de src/training/train.py.</a:t>
             </a:r>
           </a:p>
         </p:txBody>
@@ -941,7 +941,7 @@
           <a:lstStyle xmlns:a="http://schemas.openxmlformats.org/drawingml/2006/main"/>
           <a:p xmlns:a="http://schemas.openxmlformats.org/drawingml/2006/main">
             <a:r>
-              <a:t>Fuente: tabla df_resultados del notebook. Valores redondeados a dos decimales.</a:t>
+              <a:t>Fuente: results/generated/experiment_results.csv generado por MLflow.</a:t>
             </a:r>
           </a:p>
         </p:txBody>
@@ -1011,7 +1011,7 @@
           <a:lstStyle xmlns:a="http://schemas.openxmlformats.org/drawingml/2006/main"/>
           <a:p xmlns:a="http://schemas.openxmlformats.org/drawingml/2006/main">
             <a:r>
-              <a:t>Fuente: interpretación de la matriz de confusión de Regresión Logística en el notebook.</a:t>
+              <a:t>Fuente: Run final cbc3cc5511bf4a5fae054191f097fe76 en DagsHub MLflow.</a:t>
             </a:r>
           </a:p>
         </p:txBody>
@@ -1081,7 +1081,7 @@
           <a:lstStyle xmlns:a="http://schemas.openxmlformats.org/drawingml/2006/main"/>
           <a:p xmlns:a="http://schemas.openxmlformats.org/drawingml/2006/main">
             <a:r>
-              <a:t>Fuente: requisitos del primer parcial y contenido actual de la rama refactorizacion-dvc.</a:t>
+              <a:t>Fuente: experimento customer-churn-entrega-1 en DagsHub MLflow.</a:t>
             </a:r>
           </a:p>
         </p:txBody>
@@ -1149,7 +1149,7 @@
   </p:cSld>
   <p:clrMap bg1="lt1" tx1="dk1" bg2="lt2" tx2="dk2" accent1="accent1" accent2="accent2" accent3="accent3" accent4="accent4" accent5="accent5" accent6="accent6" hlink="hlink" folHlink="folHlink"/>
   <p:sldLayoutIdLst>
-    <p:sldLayoutId xmlns:r="http://schemas.openxmlformats.org/officeDocument/2006/relationships" id="2147483649" r:id="R42a721a2149345c9"/>
+    <p:sldLayoutId xmlns:r="http://schemas.openxmlformats.org/officeDocument/2006/relationships" id="2147483649" r:id="R2677a6c79202417f"/>
   </p:sldLayoutIdLst>
   <p:txStyles>
     <p:titleStyle>
@@ -1698,35 +1698,53 @@
           </c:spPr>
           <c:cat>
             <c:strRef>
-              <c:f>'Chart Data'!$A$2:$A$4</c:f>
+              <c:f>'Chart Data'!$A$2:$A$7</c:f>
               <c:strCache>
-                <c:ptCount val="3"/>
+                <c:ptCount val="6"/>
                 <c:pt idx="0">
                   <c:v>Dummy</c:v>
                 </c:pt>
                 <c:pt idx="1">
-                  <c:v>Regresión Logística</c:v>
+                  <c:v>LogReg C0,5</c:v>
                 </c:pt>
                 <c:pt idx="2">
-                  <c:v>Random Forest</c:v>
+                  <c:v>LogReg C1</c:v>
+                </c:pt>
+                <c:pt idx="3">
+                  <c:v>LogReg t0,35</c:v>
+                </c:pt>
+                <c:pt idx="4">
+                  <c:v>RF prof. 5</c:v>
+                </c:pt>
+                <c:pt idx="5">
+                  <c:v>RF prof. 10</c:v>
                 </c:pt>
               </c:strCache>
             </c:strRef>
           </c:cat>
           <c:val>
             <c:numRef>
-              <c:f>'Chart Data'!$B$2:$B$4</c:f>
+              <c:f>'Chart Data'!$B$2:$B$7</c:f>
               <c:numCache>
                 <c:formatCode>General</c:formatCode>
-                <c:ptCount val="3"/>
+                <c:ptCount val="6"/>
                 <c:pt idx="0">
                   <c:v>0</c:v>
                 </c:pt>
                 <c:pt idx="1">
-                  <c:v>0.72</c:v>
+                  <c:v>0.768</c:v>
                 </c:pt>
                 <c:pt idx="2">
-                  <c:v>0.61</c:v>
+                  <c:v>0.771</c:v>
+                </c:pt>
+                <c:pt idx="3">
+                  <c:v>0.887</c:v>
+                </c:pt>
+                <c:pt idx="4">
+                  <c:v>0.784</c:v>
+                </c:pt>
+                <c:pt idx="5">
+                  <c:v>0.717</c:v>
                 </c:pt>
               </c:numCache>
             </c:numRef>
@@ -1745,35 +1763,53 @@
           </c:spPr>
           <c:cat>
             <c:strRef>
-              <c:f>'Chart Data'!$C$2:$C$4</c:f>
+              <c:f>'Chart Data'!$C$2:$C$7</c:f>
               <c:strCache>
-                <c:ptCount val="3"/>
+                <c:ptCount val="6"/>
                 <c:pt idx="0">
                   <c:v>Dummy</c:v>
                 </c:pt>
                 <c:pt idx="1">
-                  <c:v>Regresión Logística</c:v>
+                  <c:v>LogReg C0,5</c:v>
                 </c:pt>
                 <c:pt idx="2">
-                  <c:v>Random Forest</c:v>
+                  <c:v>LogReg C1</c:v>
+                </c:pt>
+                <c:pt idx="3">
+                  <c:v>LogReg t0,35</c:v>
+                </c:pt>
+                <c:pt idx="4">
+                  <c:v>RF prof. 5</c:v>
+                </c:pt>
+                <c:pt idx="5">
+                  <c:v>RF prof. 10</c:v>
                 </c:pt>
               </c:strCache>
             </c:strRef>
           </c:cat>
           <c:val>
             <c:numRef>
-              <c:f>'Chart Data'!$D$2:$D$4</c:f>
+              <c:f>'Chart Data'!$D$2:$D$7</c:f>
               <c:numCache>
                 <c:formatCode>General</c:formatCode>
-                <c:ptCount val="3"/>
+                <c:ptCount val="6"/>
                 <c:pt idx="0">
                   <c:v>0</c:v>
                 </c:pt>
                 <c:pt idx="1">
-                  <c:v>0.58</c:v>
+                  <c:v>0.603</c:v>
                 </c:pt>
                 <c:pt idx="2">
-                  <c:v>0.57</c:v>
+                  <c:v>0.603</c:v>
+                </c:pt>
+                <c:pt idx="3">
+                  <c:v>0.573</c:v>
+                </c:pt>
+                <c:pt idx="4">
+                  <c:v>0.583</c:v>
+                </c:pt>
+                <c:pt idx="5">
+                  <c:v>0.6</c:v>
                 </c:pt>
               </c:numCache>
             </c:numRef>
@@ -1792,35 +1828,53 @@
           </c:spPr>
           <c:cat>
             <c:strRef>
-              <c:f>'Chart Data'!$E$2:$E$4</c:f>
+              <c:f>'Chart Data'!$E$2:$E$7</c:f>
               <c:strCache>
-                <c:ptCount val="3"/>
+                <c:ptCount val="6"/>
                 <c:pt idx="0">
                   <c:v>Dummy</c:v>
                 </c:pt>
                 <c:pt idx="1">
-                  <c:v>Regresión Logística</c:v>
+                  <c:v>LogReg C0,5</c:v>
                 </c:pt>
                 <c:pt idx="2">
-                  <c:v>Random Forest</c:v>
+                  <c:v>LogReg C1</c:v>
+                </c:pt>
+                <c:pt idx="3">
+                  <c:v>LogReg t0,35</c:v>
+                </c:pt>
+                <c:pt idx="4">
+                  <c:v>RF prof. 5</c:v>
+                </c:pt>
+                <c:pt idx="5">
+                  <c:v>RF prof. 10</c:v>
                 </c:pt>
               </c:strCache>
             </c:strRef>
           </c:cat>
           <c:val>
             <c:numRef>
-              <c:f>'Chart Data'!$F$2:$F$4</c:f>
+              <c:f>'Chart Data'!$F$2:$F$7</c:f>
               <c:numCache>
                 <c:formatCode>General</c:formatCode>
-                <c:ptCount val="3"/>
+                <c:ptCount val="6"/>
                 <c:pt idx="0">
                   <c:v>0.5</c:v>
                 </c:pt>
                 <c:pt idx="1">
-                  <c:v>0.81</c:v>
+                  <c:v>0.821</c:v>
                 </c:pt>
                 <c:pt idx="2">
-                  <c:v>0.8</c:v>
+                  <c:v>0.821</c:v>
+                </c:pt>
+                <c:pt idx="3">
+                  <c:v>0.821</c:v>
+                </c:pt>
+                <c:pt idx="4">
+                  <c:v>0.804</c:v>
+                </c:pt>
+                <c:pt idx="5">
+                  <c:v>0.807</c:v>
                 </c:pt>
               </c:numCache>
             </c:numRef>
@@ -1975,7 +2029,7 @@
           <p:cNvPr id="6" name="">
             <a:extLst xmlns:a="http://schemas.openxmlformats.org/drawingml/2006/main">
               <a:ext uri="{FF2B5EF4-FFF2-40B4-BE49-F238E27FC236}">
-                <a16:creationId xmlns:a16="http://schemas.microsoft.com/office/drawing/2014/main" id="{504A0C55-EE48-482D-820B-31EA37B1DE06}"/>
+                <a16:creationId xmlns:a16="http://schemas.microsoft.com/office/drawing/2014/main" id="{B1E5AA1B-7CE4-4931-B7C7-CEA71303B18B}"/>
               </a:ext>
             </a:extLst>
           </p:cNvPr>
@@ -2032,7 +2086,7 @@
           <p:cNvPr id="2" name="">
             <a:extLst xmlns:a="http://schemas.openxmlformats.org/drawingml/2006/main">
               <a:ext uri="{FF2B5EF4-FFF2-40B4-BE49-F238E27FC236}">
-                <a16:creationId xmlns:a16="http://schemas.microsoft.com/office/drawing/2014/main" id="{EE6905C5-B717-4582-81F9-EA3E2A6AA728}"/>
+                <a16:creationId xmlns:a16="http://schemas.microsoft.com/office/drawing/2014/main" id="{724DACC3-DAF2-4C90-BCB3-8392AC626B43}"/>
               </a:ext>
             </a:extLst>
           </p:cNvPr>
@@ -2089,7 +2143,7 @@
           <p:cNvPr id="3" name="">
             <a:extLst xmlns:a="http://schemas.openxmlformats.org/drawingml/2006/main">
               <a:ext uri="{FF2B5EF4-FFF2-40B4-BE49-F238E27FC236}">
-                <a16:creationId xmlns:a16="http://schemas.microsoft.com/office/drawing/2014/main" id="{ED05E083-4EC5-4728-9527-C420E39BE748}"/>
+                <a16:creationId xmlns:a16="http://schemas.microsoft.com/office/drawing/2014/main" id="{46B92414-4540-4178-B0E3-672EFEF5D443}"/>
               </a:ext>
             </a:extLst>
           </p:cNvPr>
@@ -2146,7 +2200,7 @@
           <p:cNvPr id="4" name="">
             <a:extLst xmlns:a="http://schemas.openxmlformats.org/drawingml/2006/main">
               <a:ext uri="{FF2B5EF4-FFF2-40B4-BE49-F238E27FC236}">
-                <a16:creationId xmlns:a16="http://schemas.microsoft.com/office/drawing/2014/main" id="{F342896F-B725-4305-9084-D295766F06C2}"/>
+                <a16:creationId xmlns:a16="http://schemas.microsoft.com/office/drawing/2014/main" id="{332D5369-E08C-4004-8AA9-B752C9C162CB}"/>
               </a:ext>
             </a:extLst>
           </p:cNvPr>
@@ -2203,7 +2257,7 @@
           <p:cNvPr id="5" name="">
             <a:extLst xmlns:a="http://schemas.openxmlformats.org/drawingml/2006/main">
               <a:ext uri="{FF2B5EF4-FFF2-40B4-BE49-F238E27FC236}">
-                <a16:creationId xmlns:a16="http://schemas.microsoft.com/office/drawing/2014/main" id="{77056CB0-5759-4CCF-A309-69F4B854B973}"/>
+                <a16:creationId xmlns:a16="http://schemas.microsoft.com/office/drawing/2014/main" id="{DA28A34C-652C-47F2-9F4E-846C50D20ABB}"/>
               </a:ext>
             </a:extLst>
           </p:cNvPr>
@@ -2258,7 +2312,7 @@
     </p:spTree>
     <p:extLst>
       <p:ext uri="{BB962C8B-B14F-4D97-AF65-F5344CB8AC3E}">
-        <p14:creationId xmlns:p14="http://schemas.microsoft.com/office/powerpoint/2010/main" val="1960800982"/>
+        <p14:creationId xmlns:p14="http://schemas.microsoft.com/office/powerpoint/2010/main" val="1420998760"/>
       </p:ext>
     </p:extLst>
   </p:cSld>
@@ -2289,7 +2343,7 @@
           <p:cNvPr id="6" name="">
             <a:extLst xmlns:a="http://schemas.openxmlformats.org/drawingml/2006/main">
               <a:ext uri="{FF2B5EF4-FFF2-40B4-BE49-F238E27FC236}">
-                <a16:creationId xmlns:a16="http://schemas.microsoft.com/office/drawing/2014/main" id="{EC5C4D83-0900-4AA1-9A18-AE1E6FE78017}"/>
+                <a16:creationId xmlns:a16="http://schemas.microsoft.com/office/drawing/2014/main" id="{67AB3A5A-3B02-4381-A562-282BFE2490FB}"/>
               </a:ext>
             </a:extLst>
           </p:cNvPr>
@@ -2336,7 +2390,7 @@
                 <a:ea typeface="Aptos"/>
                 <a:cs typeface="Aptos"/>
               </a:rPr>
-              <a:t>Requisitos pendientes para el cierre</a:t>
+              <a:t>Trazabilidad de la entrega</a:t>
             </a:r>
           </a:p>
         </p:txBody>
@@ -2346,7 +2400,7 @@
           <p:cNvPr id="2" name="">
             <a:extLst xmlns:a="http://schemas.openxmlformats.org/drawingml/2006/main">
               <a:ext uri="{FF2B5EF4-FFF2-40B4-BE49-F238E27FC236}">
-                <a16:creationId xmlns:a16="http://schemas.microsoft.com/office/drawing/2014/main" id="{1C9B5AF4-989D-4625-85BE-599AFC5472AA}"/>
+                <a16:creationId xmlns:a16="http://schemas.microsoft.com/office/drawing/2014/main" id="{D4E445AA-296E-40C3-B62D-4F96224AD715}"/>
               </a:ext>
             </a:extLst>
           </p:cNvPr>
@@ -2405,25 +2459,25 @@
           <p:nvPr/>
         </p:nvGraphicFramePr>
         <p:xfrm>
-          <a:off xmlns:a="http://schemas.openxmlformats.org/drawingml/2006/main" x="857250" y="1381125"/>
-          <a:ext xmlns:a="http://schemas.openxmlformats.org/drawingml/2006/main" cx="10477500" cy="3619500"/>
+          <a:off xmlns:a="http://schemas.openxmlformats.org/drawingml/2006/main" x="857250" y="1285875"/>
+          <a:ext xmlns:a="http://schemas.openxmlformats.org/drawingml/2006/main" cx="10477500" cy="4191000"/>
         </p:xfrm>
         <a:graphic xmlns:a="http://schemas.openxmlformats.org/drawingml/2006/main">
           <a:graphicData uri="http://schemas.openxmlformats.org/drawingml/2006/table">
             <a:tbl>
               <a:tblPr/>
               <a:tblGrid>
-                <a:gridCol w="6858000"/>
-                <a:gridCol w="3619500"/>
+                <a:gridCol w="4095750"/>
+                <a:gridCol w="6381750"/>
               </a:tblGrid>
-              <a:tr h="603250">
+              <a:tr h="598714">
                 <a:tc>
                   <a:txBody>
                     <a:bodyPr/>
                     <a:lstStyle/>
                     <a:p>
                       <a:r>
-                        <a:rPr sz="1350" b="1">
+                        <a:rPr sz="1275" b="1">
                           <a:solidFill>
                             <a:srgbClr val="FFFFFF"/>
                           </a:solidFill>
@@ -2431,7 +2485,7 @@
                           <a:ea typeface="Aptos"/>
                           <a:cs typeface="Aptos"/>
                         </a:rPr>
-                        <a:t>Requisito</a:t>
+                        <a:t>Componente</a:t>
                       </a:r>
                     </a:p>
                   </a:txBody>
@@ -2447,7 +2501,7 @@
                     <a:lstStyle/>
                     <a:p>
                       <a:r>
-                        <a:rPr sz="1350" b="1">
+                        <a:rPr sz="1275" b="1">
                           <a:solidFill>
                             <a:srgbClr val="FFFFFF"/>
                           </a:solidFill>
@@ -2455,7 +2509,7 @@
                           <a:ea typeface="Aptos"/>
                           <a:cs typeface="Aptos"/>
                         </a:rPr>
-                        <a:t>Estado</a:t>
+                        <a:t>Evidencia</a:t>
                       </a:r>
                     </a:p>
                   </a:txBody>
@@ -2466,14 +2520,14 @@
                   </a:tcPr>
                 </a:tc>
               </a:tr>
-              <a:tr h="603250">
+              <a:tr h="598714">
                 <a:tc>
                   <a:txBody>
                     <a:bodyPr/>
                     <a:lstStyle/>
                     <a:p>
                       <a:r>
-                        <a:rPr sz="1350">
+                        <a:rPr sz="1275">
                           <a:solidFill>
                             <a:srgbClr val="202B38"/>
                           </a:solidFill>
@@ -2481,7 +2535,7 @@
                           <a:ea typeface="Aptos"/>
                           <a:cs typeface="Aptos"/>
                         </a:rPr>
-                        <a:t>Autenticación DVC y dvc push</a:t>
+                        <a:t>Git y GitHub</a:t>
                       </a:r>
                     </a:p>
                   </a:txBody>
@@ -2497,7 +2551,7 @@
                     <a:lstStyle/>
                     <a:p>
                       <a:r>
-                        <a:rPr sz="1350" b="1">
+                        <a:rPr sz="1275" b="1">
                           <a:solidFill>
                             <a:srgbClr val="A66A17"/>
                           </a:solidFill>
@@ -2505,7 +2559,7 @@
                           <a:ea typeface="Aptos"/>
                           <a:cs typeface="Aptos"/>
                         </a:rPr>
-                        <a:t>Renovar token local</a:t>
+                        <a:t>Código en main; Run originado en commit f629724</a:t>
                       </a:r>
                     </a:p>
                   </a:txBody>
@@ -2516,14 +2570,14 @@
                   </a:tcPr>
                 </a:tc>
               </a:tr>
-              <a:tr h="603250">
+              <a:tr h="598714">
                 <a:tc>
                   <a:txBody>
                     <a:bodyPr/>
                     <a:lstStyle/>
                     <a:p>
                       <a:r>
-                        <a:rPr sz="1350">
+                        <a:rPr sz="1275">
                           <a:solidFill>
                             <a:srgbClr val="202B38"/>
                           </a:solidFill>
@@ -2531,7 +2585,7 @@
                           <a:ea typeface="Aptos"/>
                           <a:cs typeface="Aptos"/>
                         </a:rPr>
-                        <a:t>Seis corridas relevantes en MLflow</a:t>
+                        <a:t>DVC</a:t>
                       </a:r>
                     </a:p>
                   </a:txBody>
@@ -2547,7 +2601,7 @@
                     <a:lstStyle/>
                     <a:p>
                       <a:r>
-                        <a:rPr sz="1350" b="1">
+                        <a:rPr sz="1275" b="1">
                           <a:solidFill>
                             <a:srgbClr val="A66A17"/>
                           </a:solidFill>
@@ -2555,7 +2609,7 @@
                           <a:ea typeface="Aptos"/>
                           <a:cs typeface="Aptos"/>
                         </a:rPr>
-                        <a:t>Pendiente</a:t>
+                        <a:t>dvc push y dvc pull desde una segunda copia</a:t>
                       </a:r>
                     </a:p>
                   </a:txBody>
@@ -2566,14 +2620,14 @@
                   </a:tcPr>
                 </a:tc>
               </a:tr>
-              <a:tr h="603250">
+              <a:tr h="598714">
                 <a:tc>
                   <a:txBody>
                     <a:bodyPr/>
                     <a:lstStyle/>
                     <a:p>
                       <a:r>
-                        <a:rPr sz="1350">
+                        <a:rPr sz="1275">
                           <a:solidFill>
                             <a:srgbClr val="202B38"/>
                           </a:solidFill>
@@ -2581,7 +2635,7 @@
                           <a:ea typeface="Aptos"/>
                           <a:cs typeface="Aptos"/>
                         </a:rPr>
-                        <a:t>Modelo candidato en Model Registry</a:t>
+                        <a:t>MLflow</a:t>
                       </a:r>
                     </a:p>
                   </a:txBody>
@@ -2597,7 +2651,7 @@
                     <a:lstStyle/>
                     <a:p>
                       <a:r>
-                        <a:rPr sz="1350" b="1">
+                        <a:rPr sz="1275" b="1">
                           <a:solidFill>
                             <a:srgbClr val="A66A17"/>
                           </a:solidFill>
@@ -2605,7 +2659,7 @@
                           <a:ea typeface="Aptos"/>
                           <a:cs typeface="Aptos"/>
                         </a:rPr>
-                        <a:t>Pendiente</a:t>
+                        <a:t>Seis Runs y una corrida final en DagsHub</a:t>
                       </a:r>
                     </a:p>
                   </a:txBody>
@@ -2616,14 +2670,14 @@
                   </a:tcPr>
                 </a:tc>
               </a:tr>
-              <a:tr h="603250">
+              <a:tr h="598714">
                 <a:tc>
                   <a:txBody>
                     <a:bodyPr/>
                     <a:lstStyle/>
                     <a:p>
                       <a:r>
-                        <a:rPr sz="1350">
+                        <a:rPr sz="1275">
                           <a:solidFill>
                             <a:srgbClr val="202B38"/>
                           </a:solidFill>
@@ -2631,7 +2685,7 @@
                           <a:ea typeface="Aptos"/>
                           <a:cs typeface="Aptos"/>
                         </a:rPr>
-                        <a:t>Tag entrega-1 sobre el commit presentado</a:t>
+                        <a:t>Model Registry</a:t>
                       </a:r>
                     </a:p>
                   </a:txBody>
@@ -2647,7 +2701,7 @@
                     <a:lstStyle/>
                     <a:p>
                       <a:r>
-                        <a:rPr sz="1350" b="1">
+                        <a:rPr sz="1275" b="1">
                           <a:solidFill>
                             <a:srgbClr val="A66A17"/>
                           </a:solidFill>
@@ -2655,7 +2709,7 @@
                           <a:ea typeface="Aptos"/>
                           <a:cs typeface="Aptos"/>
                         </a:rPr>
-                        <a:t>Pendiente</a:t>
+                        <a:t>customer-churn-candidate, versión 4</a:t>
                       </a:r>
                     </a:p>
                   </a:txBody>
@@ -2666,14 +2720,14 @@
                   </a:tcPr>
                 </a:tc>
               </a:tr>
-              <a:tr h="603250">
+              <a:tr h="598714">
                 <a:tc>
                   <a:txBody>
                     <a:bodyPr/>
                     <a:lstStyle/>
                     <a:p>
                       <a:r>
-                        <a:rPr sz="1350">
+                        <a:rPr sz="1275">
                           <a:solidFill>
                             <a:srgbClr val="202B38"/>
                           </a:solidFill>
@@ -2681,7 +2735,7 @@
                           <a:ea typeface="Aptos"/>
                           <a:cs typeface="Aptos"/>
                         </a:rPr>
-                        <a:t>Reproducción completa desde una segunda copia</a:t>
+                        <a:t>Candidato</a:t>
                       </a:r>
                     </a:p>
                   </a:txBody>
@@ -2697,7 +2751,7 @@
                     <a:lstStyle/>
                     <a:p>
                       <a:r>
-                        <a:rPr sz="1350" b="1">
+                        <a:rPr sz="1275" b="1">
                           <a:solidFill>
                             <a:srgbClr val="A66A17"/>
                           </a:solidFill>
@@ -2705,7 +2759,57 @@
                           <a:ea typeface="Aptos"/>
                           <a:cs typeface="Aptos"/>
                         </a:rPr>
-                        <a:t>Pendiente</a:t>
+                        <a:t>Run cbc3cc5511bf4a5fae054191f097fe76</a:t>
+                      </a:r>
+                    </a:p>
+                  </a:txBody>
+                  <a:tcPr marL="91440" marR="91440" marT="45720" marB="45720" anchor="ctr">
+                    <a:solidFill>
+                      <a:srgbClr val="FFF1D8"/>
+                    </a:solidFill>
+                  </a:tcPr>
+                </a:tc>
+              </a:tr>
+              <a:tr h="598714">
+                <a:tc>
+                  <a:txBody>
+                    <a:bodyPr/>
+                    <a:lstStyle/>
+                    <a:p>
+                      <a:r>
+                        <a:rPr sz="1275">
+                          <a:solidFill>
+                            <a:srgbClr val="202B38"/>
+                          </a:solidFill>
+                          <a:latin typeface="Aptos"/>
+                          <a:ea typeface="Aptos"/>
+                          <a:cs typeface="Aptos"/>
+                        </a:rPr>
+                        <a:t>Cierre</a:t>
+                      </a:r>
+                    </a:p>
+                  </a:txBody>
+                  <a:tcPr marL="91440" marR="91440" marT="45720" marB="45720" anchor="ctr">
+                    <a:solidFill>
+                      <a:srgbClr val="E8F0F5"/>
+                    </a:solidFill>
+                  </a:tcPr>
+                </a:tc>
+                <a:tc>
+                  <a:txBody>
+                    <a:bodyPr/>
+                    <a:lstStyle/>
+                    <a:p>
+                      <a:r>
+                        <a:rPr sz="1275" b="1">
+                          <a:solidFill>
+                            <a:srgbClr val="A66A17"/>
+                          </a:solidFill>
+                          <a:latin typeface="Aptos"/>
+                          <a:ea typeface="Aptos"/>
+                          <a:cs typeface="Aptos"/>
+                        </a:rPr>
+                        <a:t>Tag entrega-1 identifica el commit presentado</a:t>
                       </a:r>
                     </a:p>
                   </a:txBody>
@@ -2725,7 +2829,7 @@
           <p:cNvPr id="4" name="">
             <a:extLst xmlns:a="http://schemas.openxmlformats.org/drawingml/2006/main">
               <a:ext uri="{FF2B5EF4-FFF2-40B4-BE49-F238E27FC236}">
-                <a16:creationId xmlns:a16="http://schemas.microsoft.com/office/drawing/2014/main" id="{2B094882-0A67-4196-AAB9-957B112541B6}"/>
+                <a16:creationId xmlns:a16="http://schemas.microsoft.com/office/drawing/2014/main" id="{C9B6F00B-1860-435C-A265-BFEF5BBCA411}"/>
               </a:ext>
             </a:extLst>
           </p:cNvPr>
@@ -2736,8 +2840,8 @@
         </p:nvSpPr>
         <p:spPr>
           <a:xfrm xmlns:a="http://schemas.openxmlformats.org/drawingml/2006/main">
-            <a:off x="1095375" y="5381625"/>
-            <a:ext cx="10001250" cy="571500"/>
+            <a:off x="1095375" y="5762625"/>
+            <a:ext cx="10001250" cy="428625"/>
           </a:xfrm>
           <a:prstGeom xmlns:a="http://schemas.openxmlformats.org/drawingml/2006/main" prst="rect">
             <a:avLst/>
@@ -2754,9 +2858,9 @@
           <a:lstStyle xmlns:a="http://schemas.openxmlformats.org/drawingml/2006/main"/>
           <a:p xmlns:a="http://schemas.openxmlformats.org/drawingml/2006/main">
             <a:pPr algn="ctr">
-              <a:defRPr sz="1725" b="1">
-                <a:solidFill>
-                  <a:srgbClr val="A66A17"/>
+              <a:defRPr sz="1650" b="1">
+                <a:solidFill>
+                  <a:srgbClr val="183A63"/>
                 </a:solidFill>
                 <a:latin typeface="Aptos"/>
                 <a:ea typeface="Aptos"/>
@@ -2764,15 +2868,15 @@
               </a:defRPr>
             </a:pPr>
             <a:r>
-              <a:rPr sz="1725" b="1">
-                <a:solidFill>
-                  <a:srgbClr val="A66A17"/>
+              <a:rPr sz="1650" b="1">
+                <a:solidFill>
+                  <a:srgbClr val="183A63"/>
                 </a:solidFill>
                 <a:latin typeface="Aptos"/>
                 <a:ea typeface="Aptos"/>
                 <a:cs typeface="Aptos"/>
               </a:rPr>
-              <a:t>La trazabilidad quedará completa al validar DVC, registrar las corridas y vincular el modelo candidato.</a:t>
+              <a:t>Git identifica el código, DVC identifica los datos y MLflow identifica el modelo.</a:t>
             </a:r>
           </a:p>
         </p:txBody>
@@ -2782,7 +2886,7 @@
           <p:cNvPr id="5" name="">
             <a:extLst xmlns:a="http://schemas.openxmlformats.org/drawingml/2006/main">
               <a:ext uri="{FF2B5EF4-FFF2-40B4-BE49-F238E27FC236}">
-                <a16:creationId xmlns:a16="http://schemas.microsoft.com/office/drawing/2014/main" id="{D12173AD-C0AB-4A29-8A44-2328BD7CA273}"/>
+                <a16:creationId xmlns:a16="http://schemas.microsoft.com/office/drawing/2014/main" id="{1D31C949-1B95-48E6-A121-0FA01050004F}"/>
               </a:ext>
             </a:extLst>
           </p:cNvPr>
@@ -2793,8 +2897,8 @@
         </p:nvSpPr>
         <p:spPr>
           <a:xfrm xmlns:a="http://schemas.openxmlformats.org/drawingml/2006/main">
-            <a:off x="2667000" y="6048375"/>
-            <a:ext cx="6858000" cy="304800"/>
+            <a:off x="2667000" y="6238875"/>
+            <a:ext cx="6858000" cy="266700"/>
           </a:xfrm>
           <a:prstGeom xmlns:a="http://schemas.openxmlformats.org/drawingml/2006/main" prst="rect">
             <a:avLst/>
@@ -2806,12 +2910,12 @@
         </p:spPr>
         <p:txBody>
           <a:bodyPr xmlns:a="http://schemas.openxmlformats.org/drawingml/2006/main" anchor="ctr">
-            <a:normAutofit fontScale="100000"/>
+            <a:normAutofit fontScale="90196"/>
           </a:bodyPr>
           <a:lstStyle xmlns:a="http://schemas.openxmlformats.org/drawingml/2006/main"/>
           <a:p xmlns:a="http://schemas.openxmlformats.org/drawingml/2006/main">
             <a:pPr algn="ctr">
-              <a:defRPr sz="1350" b="0">
+              <a:defRPr sz="1275" b="0">
                 <a:solidFill>
                   <a:srgbClr val="5F6B78"/>
                 </a:solidFill>
@@ -2821,7 +2925,7 @@
               </a:defRPr>
             </a:pPr>
             <a:r>
-              <a:rPr sz="1350" b="0">
+              <a:rPr sz="1275" b="0">
                 <a:solidFill>
                   <a:srgbClr val="5F6B78"/>
                 </a:solidFill>
@@ -2837,7 +2941,7 @@
     </p:spTree>
     <p:extLst>
       <p:ext uri="{BB962C8B-B14F-4D97-AF65-F5344CB8AC3E}">
-        <p14:creationId xmlns:p14="http://schemas.microsoft.com/office/powerpoint/2010/main" val="1246389860"/>
+        <p14:creationId xmlns:p14="http://schemas.microsoft.com/office/powerpoint/2010/main" val="419234121"/>
       </p:ext>
     </p:extLst>
   </p:cSld>
@@ -2868,7 +2972,7 @@
           <p:cNvPr id="14" name="">
             <a:extLst xmlns:a="http://schemas.openxmlformats.org/drawingml/2006/main">
               <a:ext uri="{FF2B5EF4-FFF2-40B4-BE49-F238E27FC236}">
-                <a16:creationId xmlns:a16="http://schemas.microsoft.com/office/drawing/2014/main" id="{49AAEA1B-3336-44FA-835A-37A6817820B6}"/>
+                <a16:creationId xmlns:a16="http://schemas.microsoft.com/office/drawing/2014/main" id="{ACB0D9B3-1E61-4FDF-AD2B-665B6202BAEE}"/>
               </a:ext>
             </a:extLst>
           </p:cNvPr>
@@ -2925,7 +3029,7 @@
           <p:cNvPr id="2" name="">
             <a:extLst xmlns:a="http://schemas.openxmlformats.org/drawingml/2006/main">
               <a:ext uri="{FF2B5EF4-FFF2-40B4-BE49-F238E27FC236}">
-                <a16:creationId xmlns:a16="http://schemas.microsoft.com/office/drawing/2014/main" id="{C66268C9-D50A-4507-95EB-9D762983D4D0}"/>
+                <a16:creationId xmlns:a16="http://schemas.microsoft.com/office/drawing/2014/main" id="{42E533C7-4F02-4671-B724-F94EDDACF85B}"/>
               </a:ext>
             </a:extLst>
           </p:cNvPr>
@@ -2982,7 +3086,7 @@
           <p:cNvPr id="3" name="">
             <a:extLst xmlns:a="http://schemas.openxmlformats.org/drawingml/2006/main">
               <a:ext uri="{FF2B5EF4-FFF2-40B4-BE49-F238E27FC236}">
-                <a16:creationId xmlns:a16="http://schemas.microsoft.com/office/drawing/2014/main" id="{B1929C88-C95A-4ACF-8383-5A4E125592D8}"/>
+                <a16:creationId xmlns:a16="http://schemas.microsoft.com/office/drawing/2014/main" id="{D9E416DB-F40E-45A4-BDC2-AD5634E57EEE}"/>
               </a:ext>
             </a:extLst>
           </p:cNvPr>
@@ -3039,7 +3143,7 @@
           <p:cNvPr id="4" name="">
             <a:extLst xmlns:a="http://schemas.openxmlformats.org/drawingml/2006/main">
               <a:ext uri="{FF2B5EF4-FFF2-40B4-BE49-F238E27FC236}">
-                <a16:creationId xmlns:a16="http://schemas.microsoft.com/office/drawing/2014/main" id="{7BA5C9A1-9EDD-43AF-973C-954DF94A22EF}"/>
+                <a16:creationId xmlns:a16="http://schemas.microsoft.com/office/drawing/2014/main" id="{C5ECEDD9-1925-4F75-BCE8-6895145A6F26}"/>
               </a:ext>
             </a:extLst>
           </p:cNvPr>
@@ -3096,7 +3200,7 @@
           <p:cNvPr id="5" name="">
             <a:extLst xmlns:a="http://schemas.openxmlformats.org/drawingml/2006/main">
               <a:ext uri="{FF2B5EF4-FFF2-40B4-BE49-F238E27FC236}">
-                <a16:creationId xmlns:a16="http://schemas.microsoft.com/office/drawing/2014/main" id="{B743CC17-6F7B-4589-9DD7-BB7A73160165}"/>
+                <a16:creationId xmlns:a16="http://schemas.microsoft.com/office/drawing/2014/main" id="{7CF752D5-4E79-4BE1-A17A-790734EBEFEF}"/>
               </a:ext>
             </a:extLst>
           </p:cNvPr>
@@ -3153,7 +3257,7 @@
           <p:cNvPr id="6" name="">
             <a:extLst xmlns:a="http://schemas.openxmlformats.org/drawingml/2006/main">
               <a:ext uri="{FF2B5EF4-FFF2-40B4-BE49-F238E27FC236}">
-                <a16:creationId xmlns:a16="http://schemas.microsoft.com/office/drawing/2014/main" id="{4B7E4231-531D-4636-9113-931A7B71832A}"/>
+                <a16:creationId xmlns:a16="http://schemas.microsoft.com/office/drawing/2014/main" id="{B03425E7-469B-47F7-8CEB-9162F1029C77}"/>
               </a:ext>
             </a:extLst>
           </p:cNvPr>
@@ -3210,7 +3314,7 @@
           <p:cNvPr id="7" name="">
             <a:extLst xmlns:a="http://schemas.openxmlformats.org/drawingml/2006/main">
               <a:ext uri="{FF2B5EF4-FFF2-40B4-BE49-F238E27FC236}">
-                <a16:creationId xmlns:a16="http://schemas.microsoft.com/office/drawing/2014/main" id="{89F4E08B-8207-447F-AC89-EB8285ED441A}"/>
+                <a16:creationId xmlns:a16="http://schemas.microsoft.com/office/drawing/2014/main" id="{EDCD3232-39F8-417E-816A-CAC95FEC61A2}"/>
               </a:ext>
             </a:extLst>
           </p:cNvPr>
@@ -3267,7 +3371,7 @@
           <p:cNvPr id="8" name="">
             <a:extLst xmlns:a="http://schemas.openxmlformats.org/drawingml/2006/main">
               <a:ext uri="{FF2B5EF4-FFF2-40B4-BE49-F238E27FC236}">
-                <a16:creationId xmlns:a16="http://schemas.microsoft.com/office/drawing/2014/main" id="{E9478287-0CAC-4B83-BAB1-6E309EFF06D6}"/>
+                <a16:creationId xmlns:a16="http://schemas.microsoft.com/office/drawing/2014/main" id="{DB959FBA-E445-469A-9090-FC57175A74C0}"/>
               </a:ext>
             </a:extLst>
           </p:cNvPr>
@@ -3324,7 +3428,7 @@
           <p:cNvPr id="9" name="">
             <a:extLst xmlns:a="http://schemas.openxmlformats.org/drawingml/2006/main">
               <a:ext uri="{FF2B5EF4-FFF2-40B4-BE49-F238E27FC236}">
-                <a16:creationId xmlns:a16="http://schemas.microsoft.com/office/drawing/2014/main" id="{9EED0137-B105-40F7-B20D-4012A2835739}"/>
+                <a16:creationId xmlns:a16="http://schemas.microsoft.com/office/drawing/2014/main" id="{6802DA4C-D7FA-41B0-BD34-5767D505319F}"/>
               </a:ext>
             </a:extLst>
           </p:cNvPr>
@@ -3381,7 +3485,7 @@
           <p:cNvPr id="10" name="">
             <a:extLst xmlns:a="http://schemas.openxmlformats.org/drawingml/2006/main">
               <a:ext uri="{FF2B5EF4-FFF2-40B4-BE49-F238E27FC236}">
-                <a16:creationId xmlns:a16="http://schemas.microsoft.com/office/drawing/2014/main" id="{A656FAAF-7010-4A79-B8DC-E388496400C8}"/>
+                <a16:creationId xmlns:a16="http://schemas.microsoft.com/office/drawing/2014/main" id="{880D700E-29F9-438C-8090-BDCBCE488BFB}"/>
               </a:ext>
             </a:extLst>
           </p:cNvPr>
@@ -3438,7 +3542,7 @@
           <p:cNvPr id="11" name="">
             <a:extLst xmlns:a="http://schemas.openxmlformats.org/drawingml/2006/main">
               <a:ext uri="{FF2B5EF4-FFF2-40B4-BE49-F238E27FC236}">
-                <a16:creationId xmlns:a16="http://schemas.microsoft.com/office/drawing/2014/main" id="{A237BDF4-9ABB-4CDF-93A0-D213947A5F0C}"/>
+                <a16:creationId xmlns:a16="http://schemas.microsoft.com/office/drawing/2014/main" id="{D2E5C884-3BAA-437E-8122-A7D8908692D1}"/>
               </a:ext>
             </a:extLst>
           </p:cNvPr>
@@ -3495,7 +3599,7 @@
           <p:cNvPr id="12" name="">
             <a:extLst xmlns:a="http://schemas.openxmlformats.org/drawingml/2006/main">
               <a:ext uri="{FF2B5EF4-FFF2-40B4-BE49-F238E27FC236}">
-                <a16:creationId xmlns:a16="http://schemas.microsoft.com/office/drawing/2014/main" id="{33D9011A-E923-4D6C-9D2B-2AED6A2034C4}"/>
+                <a16:creationId xmlns:a16="http://schemas.microsoft.com/office/drawing/2014/main" id="{A1CC832E-5A13-47A0-8AFE-71D9A0CC3E31}"/>
               </a:ext>
             </a:extLst>
           </p:cNvPr>
@@ -3552,7 +3656,7 @@
           <p:cNvPr id="13" name="">
             <a:extLst xmlns:a="http://schemas.openxmlformats.org/drawingml/2006/main">
               <a:ext uri="{FF2B5EF4-FFF2-40B4-BE49-F238E27FC236}">
-                <a16:creationId xmlns:a16="http://schemas.microsoft.com/office/drawing/2014/main" id="{0095CF20-11C6-4CD5-86E3-B2E32EF88D72}"/>
+                <a16:creationId xmlns:a16="http://schemas.microsoft.com/office/drawing/2014/main" id="{25C49684-4B2E-4757-A64E-650F33FB06A2}"/>
               </a:ext>
             </a:extLst>
           </p:cNvPr>
@@ -3607,7 +3711,7 @@
     </p:spTree>
     <p:extLst>
       <p:ext uri="{BB962C8B-B14F-4D97-AF65-F5344CB8AC3E}">
-        <p14:creationId xmlns:p14="http://schemas.microsoft.com/office/powerpoint/2010/main" val="632492615"/>
+        <p14:creationId xmlns:p14="http://schemas.microsoft.com/office/powerpoint/2010/main" val="524178982"/>
       </p:ext>
     </p:extLst>
   </p:cSld>
@@ -3638,7 +3742,7 @@
           <p:cNvPr id="12" name="">
             <a:extLst xmlns:a="http://schemas.openxmlformats.org/drawingml/2006/main">
               <a:ext uri="{FF2B5EF4-FFF2-40B4-BE49-F238E27FC236}">
-                <a16:creationId xmlns:a16="http://schemas.microsoft.com/office/drawing/2014/main" id="{EED7927C-E116-4975-BC73-4263FD85961C}"/>
+                <a16:creationId xmlns:a16="http://schemas.microsoft.com/office/drawing/2014/main" id="{DE7C66DF-6E08-4AE7-AF0E-B5B9A666B2C8}"/>
               </a:ext>
             </a:extLst>
           </p:cNvPr>
@@ -3695,7 +3799,7 @@
           <p:cNvPr id="2" name="">
             <a:extLst xmlns:a="http://schemas.openxmlformats.org/drawingml/2006/main">
               <a:ext uri="{FF2B5EF4-FFF2-40B4-BE49-F238E27FC236}">
-                <a16:creationId xmlns:a16="http://schemas.microsoft.com/office/drawing/2014/main" id="{E7511B16-C2D8-43D5-A76F-0A941A198399}"/>
+                <a16:creationId xmlns:a16="http://schemas.microsoft.com/office/drawing/2014/main" id="{E63BF609-5CD8-4C42-B0B1-FABEA69E460D}"/>
               </a:ext>
             </a:extLst>
           </p:cNvPr>
@@ -3752,7 +3856,7 @@
           <p:cNvPr id="3" name="">
             <a:extLst xmlns:a="http://schemas.openxmlformats.org/drawingml/2006/main">
               <a:ext uri="{FF2B5EF4-FFF2-40B4-BE49-F238E27FC236}">
-                <a16:creationId xmlns:a16="http://schemas.microsoft.com/office/drawing/2014/main" id="{141FF393-8A14-4FDA-92F4-8F7E5EB71A1C}"/>
+                <a16:creationId xmlns:a16="http://schemas.microsoft.com/office/drawing/2014/main" id="{943B8840-9239-4F53-B702-107E44C7AFDC}"/>
               </a:ext>
             </a:extLst>
           </p:cNvPr>
@@ -3809,7 +3913,7 @@
           <p:cNvPr id="4" name="">
             <a:extLst xmlns:a="http://schemas.openxmlformats.org/drawingml/2006/main">
               <a:ext uri="{FF2B5EF4-FFF2-40B4-BE49-F238E27FC236}">
-                <a16:creationId xmlns:a16="http://schemas.microsoft.com/office/drawing/2014/main" id="{1B79DED1-6968-4C08-999D-ABFFD23F7AA2}"/>
+                <a16:creationId xmlns:a16="http://schemas.microsoft.com/office/drawing/2014/main" id="{4CB51720-F355-48FC-9166-37BB2DA486C1}"/>
               </a:ext>
             </a:extLst>
           </p:cNvPr>
@@ -3889,7 +3993,7 @@
           <p:cNvPr id="5" name="">
             <a:extLst xmlns:a="http://schemas.openxmlformats.org/drawingml/2006/main">
               <a:ext uri="{FF2B5EF4-FFF2-40B4-BE49-F238E27FC236}">
-                <a16:creationId xmlns:a16="http://schemas.microsoft.com/office/drawing/2014/main" id="{908E89F2-0D5C-45C3-B073-7B665236124F}"/>
+                <a16:creationId xmlns:a16="http://schemas.microsoft.com/office/drawing/2014/main" id="{A47C8CBF-21F5-4919-B6E4-2CFFC0156CF3}"/>
               </a:ext>
             </a:extLst>
           </p:cNvPr>
@@ -3946,7 +4050,7 @@
           <p:cNvPr id="6" name="">
             <a:extLst xmlns:a="http://schemas.openxmlformats.org/drawingml/2006/main">
               <a:ext uri="{FF2B5EF4-FFF2-40B4-BE49-F238E27FC236}">
-                <a16:creationId xmlns:a16="http://schemas.microsoft.com/office/drawing/2014/main" id="{A42E9006-A01C-4679-9B6B-BCF986723064}"/>
+                <a16:creationId xmlns:a16="http://schemas.microsoft.com/office/drawing/2014/main" id="{3B0D5DA3-7DE4-4FCF-8D73-4AA6638645A0}"/>
               </a:ext>
             </a:extLst>
           </p:cNvPr>
@@ -4026,7 +4130,7 @@
           <p:cNvPr id="7" name="">
             <a:extLst xmlns:a="http://schemas.openxmlformats.org/drawingml/2006/main">
               <a:ext uri="{FF2B5EF4-FFF2-40B4-BE49-F238E27FC236}">
-                <a16:creationId xmlns:a16="http://schemas.microsoft.com/office/drawing/2014/main" id="{D30F5AAE-77DE-48ED-BDCA-7CE166B635A0}"/>
+                <a16:creationId xmlns:a16="http://schemas.microsoft.com/office/drawing/2014/main" id="{B4B89356-1EC3-4EB6-B7C8-3FDC06495F61}"/>
               </a:ext>
             </a:extLst>
           </p:cNvPr>
@@ -4083,7 +4187,7 @@
           <p:cNvPr id="8" name="">
             <a:extLst xmlns:a="http://schemas.openxmlformats.org/drawingml/2006/main">
               <a:ext uri="{FF2B5EF4-FFF2-40B4-BE49-F238E27FC236}">
-                <a16:creationId xmlns:a16="http://schemas.microsoft.com/office/drawing/2014/main" id="{C20EF3DA-CFFE-4207-B787-F8AD9E8BFD81}"/>
+                <a16:creationId xmlns:a16="http://schemas.microsoft.com/office/drawing/2014/main" id="{7386657B-0EFF-4FC3-8BE2-C62ADB073389}"/>
               </a:ext>
             </a:extLst>
           </p:cNvPr>
@@ -4163,7 +4267,7 @@
           <p:cNvPr id="9" name="">
             <a:extLst xmlns:a="http://schemas.openxmlformats.org/drawingml/2006/main">
               <a:ext uri="{FF2B5EF4-FFF2-40B4-BE49-F238E27FC236}">
-                <a16:creationId xmlns:a16="http://schemas.microsoft.com/office/drawing/2014/main" id="{20000228-621A-4499-808B-81D833FD7956}"/>
+                <a16:creationId xmlns:a16="http://schemas.microsoft.com/office/drawing/2014/main" id="{1F382501-5529-43D5-BA78-0DCC31A09721}"/>
               </a:ext>
             </a:extLst>
           </p:cNvPr>
@@ -4220,7 +4324,7 @@
           <p:cNvPr id="10" name="">
             <a:extLst xmlns:a="http://schemas.openxmlformats.org/drawingml/2006/main">
               <a:ext uri="{FF2B5EF4-FFF2-40B4-BE49-F238E27FC236}">
-                <a16:creationId xmlns:a16="http://schemas.microsoft.com/office/drawing/2014/main" id="{1B8B9A0B-4AC2-4F05-B874-2ADFD40A37DF}"/>
+                <a16:creationId xmlns:a16="http://schemas.microsoft.com/office/drawing/2014/main" id="{02BB6B03-12FE-4ABF-A71E-7165AC808393}"/>
               </a:ext>
             </a:extLst>
           </p:cNvPr>
@@ -4300,7 +4404,7 @@
           <p:cNvPr id="11" name="">
             <a:extLst xmlns:a="http://schemas.openxmlformats.org/drawingml/2006/main">
               <a:ext uri="{FF2B5EF4-FFF2-40B4-BE49-F238E27FC236}">
-                <a16:creationId xmlns:a16="http://schemas.microsoft.com/office/drawing/2014/main" id="{18B07B42-0489-49F7-B838-9DDC0B56D490}"/>
+                <a16:creationId xmlns:a16="http://schemas.microsoft.com/office/drawing/2014/main" id="{B33F7A44-D99D-4DBF-AEA1-8C8DE76488B7}"/>
               </a:ext>
             </a:extLst>
           </p:cNvPr>
@@ -4355,7 +4459,7 @@
     </p:spTree>
     <p:extLst>
       <p:ext uri="{BB962C8B-B14F-4D97-AF65-F5344CB8AC3E}">
-        <p14:creationId xmlns:p14="http://schemas.microsoft.com/office/powerpoint/2010/main" val="1399676675"/>
+        <p14:creationId xmlns:p14="http://schemas.microsoft.com/office/powerpoint/2010/main" val="1375394100"/>
       </p:ext>
     </p:extLst>
   </p:cSld>
@@ -4386,7 +4490,7 @@
           <p:cNvPr id="11" name="">
             <a:extLst xmlns:a="http://schemas.openxmlformats.org/drawingml/2006/main">
               <a:ext uri="{FF2B5EF4-FFF2-40B4-BE49-F238E27FC236}">
-                <a16:creationId xmlns:a16="http://schemas.microsoft.com/office/drawing/2014/main" id="{DA4C8B3F-AF3B-499C-8BCA-AC44A094051C}"/>
+                <a16:creationId xmlns:a16="http://schemas.microsoft.com/office/drawing/2014/main" id="{B2F061E9-9497-49E5-AFB9-F5863B9B385D}"/>
               </a:ext>
             </a:extLst>
           </p:cNvPr>
@@ -4433,7 +4537,7 @@
                 <a:ea typeface="Aptos"/>
                 <a:cs typeface="Aptos"/>
               </a:rPr>
-              <a:t>Partición reproducible</a:t>
+              <a:t>Partición para selección y evaluación</a:t>
             </a:r>
           </a:p>
         </p:txBody>
@@ -4443,7 +4547,7 @@
           <p:cNvPr id="2" name="">
             <a:extLst xmlns:a="http://schemas.openxmlformats.org/drawingml/2006/main">
               <a:ext uri="{FF2B5EF4-FFF2-40B4-BE49-F238E27FC236}">
-                <a16:creationId xmlns:a16="http://schemas.microsoft.com/office/drawing/2014/main" id="{E655E8F4-514D-4675-B129-842675C13E48}"/>
+                <a16:creationId xmlns:a16="http://schemas.microsoft.com/office/drawing/2014/main" id="{88D674DC-5DE4-480B-A94F-A9BE704B62B0}"/>
               </a:ext>
             </a:extLst>
           </p:cNvPr>
@@ -4500,7 +4604,7 @@
           <p:cNvPr id="3" name="">
             <a:extLst xmlns:a="http://schemas.openxmlformats.org/drawingml/2006/main">
               <a:ext uri="{FF2B5EF4-FFF2-40B4-BE49-F238E27FC236}">
-                <a16:creationId xmlns:a16="http://schemas.microsoft.com/office/drawing/2014/main" id="{85CC9835-6531-46EC-92A8-0713E865EB93}"/>
+                <a16:creationId xmlns:a16="http://schemas.microsoft.com/office/drawing/2014/main" id="{20421CCC-FBE9-4489-A356-1435528E0AFF}"/>
               </a:ext>
             </a:extLst>
           </p:cNvPr>
@@ -4511,7 +4615,7 @@
         </p:nvSpPr>
         <p:spPr>
           <a:xfrm xmlns:a="http://schemas.openxmlformats.org/drawingml/2006/main">
-            <a:off x="1428750" y="1809750"/>
+            <a:off x="1285875" y="1809750"/>
             <a:ext cx="2381250" cy="857250"/>
           </a:xfrm>
           <a:prstGeom xmlns:a="http://schemas.openxmlformats.org/drawingml/2006/main" prst="rect">
@@ -4547,7 +4651,7 @@
                 <a:ea typeface="Aptos"/>
                 <a:cs typeface="Aptos"/>
               </a:rPr>
-              <a:t>80 %</a:t>
+              <a:t>60 %</a:t>
             </a:r>
           </a:p>
         </p:txBody>
@@ -4557,7 +4661,7 @@
           <p:cNvPr id="4" name="">
             <a:extLst xmlns:a="http://schemas.openxmlformats.org/drawingml/2006/main">
               <a:ext uri="{FF2B5EF4-FFF2-40B4-BE49-F238E27FC236}">
-                <a16:creationId xmlns:a16="http://schemas.microsoft.com/office/drawing/2014/main" id="{4599A5B8-962C-448B-80C3-7F7DCE7E2578}"/>
+                <a16:creationId xmlns:a16="http://schemas.microsoft.com/office/drawing/2014/main" id="{82B58F77-C6FA-4C66-B95A-2E7180F49DCD}"/>
               </a:ext>
             </a:extLst>
           </p:cNvPr>
@@ -4568,7 +4672,7 @@
         </p:nvSpPr>
         <p:spPr>
           <a:xfrm xmlns:a="http://schemas.openxmlformats.org/drawingml/2006/main">
-            <a:off x="1428750" y="2667000"/>
+            <a:off x="1285875" y="2667000"/>
             <a:ext cx="2381250" cy="857250"/>
           </a:xfrm>
           <a:prstGeom xmlns:a="http://schemas.openxmlformats.org/drawingml/2006/main" prst="rect">
@@ -4627,7 +4731,7 @@
                 <a:ea typeface="Aptos"/>
                 <a:cs typeface="Aptos"/>
               </a:rPr>
-              <a:t>5.634 clientes</a:t>
+              <a:t>4.225 clientes</a:t>
             </a:r>
           </a:p>
         </p:txBody>
@@ -4637,7 +4741,7 @@
           <p:cNvPr id="5" name="">
             <a:extLst xmlns:a="http://schemas.openxmlformats.org/drawingml/2006/main">
               <a:ext uri="{FF2B5EF4-FFF2-40B4-BE49-F238E27FC236}">
-                <a16:creationId xmlns:a16="http://schemas.microsoft.com/office/drawing/2014/main" id="{B8C3BA1A-16D7-4B44-AF7A-276F9F644DF3}"/>
+                <a16:creationId xmlns:a16="http://schemas.microsoft.com/office/drawing/2014/main" id="{962BA24B-7494-4961-B869-36C20CCA874A}"/>
               </a:ext>
             </a:extLst>
           </p:cNvPr>
@@ -4648,7 +4752,7 @@
         </p:nvSpPr>
         <p:spPr>
           <a:xfrm xmlns:a="http://schemas.openxmlformats.org/drawingml/2006/main">
-            <a:off x="4953000" y="1809750"/>
+            <a:off x="4905375" y="1809750"/>
             <a:ext cx="2381250" cy="857250"/>
           </a:xfrm>
           <a:prstGeom xmlns:a="http://schemas.openxmlformats.org/drawingml/2006/main" prst="rect">
@@ -4694,7 +4798,7 @@
           <p:cNvPr id="6" name="">
             <a:extLst xmlns:a="http://schemas.openxmlformats.org/drawingml/2006/main">
               <a:ext uri="{FF2B5EF4-FFF2-40B4-BE49-F238E27FC236}">
-                <a16:creationId xmlns:a16="http://schemas.microsoft.com/office/drawing/2014/main" id="{166585A5-7D8B-40B3-B5B1-120D19562360}"/>
+                <a16:creationId xmlns:a16="http://schemas.microsoft.com/office/drawing/2014/main" id="{17F18194-0318-4170-A881-177EBE445460}"/>
               </a:ext>
             </a:extLst>
           </p:cNvPr>
@@ -4705,7 +4809,7 @@
         </p:nvSpPr>
         <p:spPr>
           <a:xfrm xmlns:a="http://schemas.openxmlformats.org/drawingml/2006/main">
-            <a:off x="4953000" y="2667000"/>
+            <a:off x="4905375" y="2667000"/>
             <a:ext cx="2381250" cy="857250"/>
           </a:xfrm>
           <a:prstGeom xmlns:a="http://schemas.openxmlformats.org/drawingml/2006/main" prst="rect">
@@ -4741,7 +4845,7 @@
                 <a:ea typeface="Aptos"/>
                 <a:cs typeface="Aptos"/>
               </a:rPr>
-              <a:t>Test</a:t>
+              <a:t>Validación</a:t>
             </a:r>
           </a:p>
           <a:p xmlns:a="http://schemas.openxmlformats.org/drawingml/2006/main">
@@ -4774,7 +4878,7 @@
           <p:cNvPr id="7" name="">
             <a:extLst xmlns:a="http://schemas.openxmlformats.org/drawingml/2006/main">
               <a:ext uri="{FF2B5EF4-FFF2-40B4-BE49-F238E27FC236}">
-                <a16:creationId xmlns:a16="http://schemas.microsoft.com/office/drawing/2014/main" id="{4278AB1D-738B-43D0-B096-2F7F09E37F1A}"/>
+                <a16:creationId xmlns:a16="http://schemas.microsoft.com/office/drawing/2014/main" id="{5FA06DE2-B0DA-46B1-978E-37BAE6641E03}"/>
               </a:ext>
             </a:extLst>
           </p:cNvPr>
@@ -4785,7 +4889,7 @@
         </p:nvSpPr>
         <p:spPr>
           <a:xfrm xmlns:a="http://schemas.openxmlformats.org/drawingml/2006/main">
-            <a:off x="8477250" y="1809750"/>
+            <a:off x="8524875" y="1809750"/>
             <a:ext cx="2381250" cy="857250"/>
           </a:xfrm>
           <a:prstGeom xmlns:a="http://schemas.openxmlformats.org/drawingml/2006/main" prst="rect">
@@ -4803,7 +4907,7 @@
           <a:lstStyle xmlns:a="http://schemas.openxmlformats.org/drawingml/2006/main"/>
           <a:p xmlns:a="http://schemas.openxmlformats.org/drawingml/2006/main">
             <a:pPr algn="ctr">
-              <a:defRPr sz="3900" b="1">
+              <a:defRPr sz="4500" b="1">
                 <a:solidFill>
                   <a:srgbClr val="5487C2"/>
                 </a:solidFill>
@@ -4813,7 +4917,7 @@
               </a:defRPr>
             </a:pPr>
             <a:r>
-              <a:rPr sz="3900" b="1">
+              <a:rPr sz="4500" b="1">
                 <a:solidFill>
                   <a:srgbClr val="5487C2"/>
                 </a:solidFill>
@@ -4821,7 +4925,7 @@
                 <a:ea typeface="Aptos"/>
                 <a:cs typeface="Aptos"/>
               </a:rPr>
-              <a:t>26,36 %</a:t>
+              <a:t>20 %</a:t>
             </a:r>
           </a:p>
         </p:txBody>
@@ -4831,7 +4935,7 @@
           <p:cNvPr id="8" name="">
             <a:extLst xmlns:a="http://schemas.openxmlformats.org/drawingml/2006/main">
               <a:ext uri="{FF2B5EF4-FFF2-40B4-BE49-F238E27FC236}">
-                <a16:creationId xmlns:a16="http://schemas.microsoft.com/office/drawing/2014/main" id="{87B04080-CE44-401F-90C8-B81AE313BD7E}"/>
+                <a16:creationId xmlns:a16="http://schemas.microsoft.com/office/drawing/2014/main" id="{F0110525-E073-4063-AE44-9C5FC491E2EF}"/>
               </a:ext>
             </a:extLst>
           </p:cNvPr>
@@ -4842,7 +4946,7 @@
         </p:nvSpPr>
         <p:spPr>
           <a:xfrm xmlns:a="http://schemas.openxmlformats.org/drawingml/2006/main">
-            <a:off x="8477250" y="2667000"/>
+            <a:off x="8524875" y="2667000"/>
             <a:ext cx="2381250" cy="857250"/>
           </a:xfrm>
           <a:prstGeom xmlns:a="http://schemas.openxmlformats.org/drawingml/2006/main" prst="rect">
@@ -4878,7 +4982,7 @@
                 <a:ea typeface="Aptos"/>
                 <a:cs typeface="Aptos"/>
               </a:rPr>
-              <a:t>churn en train</a:t>
+              <a:t>Test aislado</a:t>
             </a:r>
           </a:p>
           <a:p xmlns:a="http://schemas.openxmlformats.org/drawingml/2006/main">
@@ -4901,7 +5005,7 @@
                 <a:ea typeface="Aptos"/>
                 <a:cs typeface="Aptos"/>
               </a:rPr>
-              <a:t>26,40 % en test</a:t>
+              <a:t>1.409 clientes</a:t>
             </a:r>
           </a:p>
         </p:txBody>
@@ -4911,7 +5015,7 @@
           <p:cNvPr id="9" name="">
             <a:extLst xmlns:a="http://schemas.openxmlformats.org/drawingml/2006/main">
               <a:ext uri="{FF2B5EF4-FFF2-40B4-BE49-F238E27FC236}">
-                <a16:creationId xmlns:a16="http://schemas.microsoft.com/office/drawing/2014/main" id="{7EFBDF1B-192C-4998-AB1D-D05AFBCD158B}"/>
+                <a16:creationId xmlns:a16="http://schemas.microsoft.com/office/drawing/2014/main" id="{CD38CBDA-3528-4667-B6CA-417CBE8DC40F}"/>
               </a:ext>
             </a:extLst>
           </p:cNvPr>
@@ -4922,8 +5026,8 @@
         </p:nvSpPr>
         <p:spPr>
           <a:xfrm xmlns:a="http://schemas.openxmlformats.org/drawingml/2006/main">
-            <a:off x="1476375" y="4476750"/>
-            <a:ext cx="9239250" cy="523875"/>
+            <a:off x="1190625" y="4476750"/>
+            <a:ext cx="9810750" cy="571500"/>
           </a:xfrm>
           <a:prstGeom xmlns:a="http://schemas.openxmlformats.org/drawingml/2006/main" prst="rect">
             <a:avLst/>
@@ -4940,7 +5044,7 @@
           <a:lstStyle xmlns:a="http://schemas.openxmlformats.org/drawingml/2006/main"/>
           <a:p xmlns:a="http://schemas.openxmlformats.org/drawingml/2006/main">
             <a:pPr algn="ctr">
-              <a:defRPr sz="2025" b="1">
+              <a:defRPr sz="1875" b="1">
                 <a:solidFill>
                   <a:srgbClr val="183A63"/>
                 </a:solidFill>
@@ -4950,7 +5054,7 @@
               </a:defRPr>
             </a:pPr>
             <a:r>
-              <a:rPr sz="2025" b="1">
+              <a:rPr sz="1875" b="1">
                 <a:solidFill>
                   <a:srgbClr val="183A63"/>
                 </a:solidFill>
@@ -4958,7 +5062,7 @@
                 <a:ea typeface="Aptos"/>
                 <a:cs typeface="Aptos"/>
               </a:rPr>
-              <a:t>La estratificación conserva la proporción de la clase positiva.</a:t>
+              <a:t>La validación selecciona el candidato. El test se usa una sola vez al final.</a:t>
             </a:r>
           </a:p>
         </p:txBody>
@@ -4968,7 +5072,7 @@
           <p:cNvPr id="10" name="">
             <a:extLst xmlns:a="http://schemas.openxmlformats.org/drawingml/2006/main">
               <a:ext uri="{FF2B5EF4-FFF2-40B4-BE49-F238E27FC236}">
-                <a16:creationId xmlns:a16="http://schemas.microsoft.com/office/drawing/2014/main" id="{49BF140C-0F47-4496-8074-B47602A31ECF}"/>
+                <a16:creationId xmlns:a16="http://schemas.microsoft.com/office/drawing/2014/main" id="{99A9B6C6-2E07-4904-A72E-95FF2D81CF42}"/>
               </a:ext>
             </a:extLst>
           </p:cNvPr>
@@ -5023,7 +5127,7 @@
     </p:spTree>
     <p:extLst>
       <p:ext uri="{BB962C8B-B14F-4D97-AF65-F5344CB8AC3E}">
-        <p14:creationId xmlns:p14="http://schemas.microsoft.com/office/powerpoint/2010/main" val="627245991"/>
+        <p14:creationId xmlns:p14="http://schemas.microsoft.com/office/powerpoint/2010/main" val="2083621732"/>
       </p:ext>
     </p:extLst>
   </p:cSld>
@@ -5054,7 +5158,7 @@
           <p:cNvPr id="6" name="">
             <a:extLst xmlns:a="http://schemas.openxmlformats.org/drawingml/2006/main">
               <a:ext uri="{FF2B5EF4-FFF2-40B4-BE49-F238E27FC236}">
-                <a16:creationId xmlns:a16="http://schemas.microsoft.com/office/drawing/2014/main" id="{4016F21B-7691-4C6B-9941-4C678F598CB8}"/>
+                <a16:creationId xmlns:a16="http://schemas.microsoft.com/office/drawing/2014/main" id="{89D12413-8600-4498-907F-786E033DD517}"/>
               </a:ext>
             </a:extLst>
           </p:cNvPr>
@@ -5111,7 +5215,7 @@
           <p:cNvPr id="2" name="">
             <a:extLst xmlns:a="http://schemas.openxmlformats.org/drawingml/2006/main">
               <a:ext uri="{FF2B5EF4-FFF2-40B4-BE49-F238E27FC236}">
-                <a16:creationId xmlns:a16="http://schemas.microsoft.com/office/drawing/2014/main" id="{A2E688BA-380A-457A-AD9D-A5B4EC2EF828}"/>
+                <a16:creationId xmlns:a16="http://schemas.microsoft.com/office/drawing/2014/main" id="{9CC209C8-C60A-412B-A218-A8C7CDB86994}"/>
               </a:ext>
             </a:extLst>
           </p:cNvPr>
@@ -5487,7 +5591,7 @@
           <p:cNvPr id="4" name="">
             <a:extLst xmlns:a="http://schemas.openxmlformats.org/drawingml/2006/main">
               <a:ext uri="{FF2B5EF4-FFF2-40B4-BE49-F238E27FC236}">
-                <a16:creationId xmlns:a16="http://schemas.microsoft.com/office/drawing/2014/main" id="{617FC581-6C36-41F8-8578-2ED4F7DDB1C6}"/>
+                <a16:creationId xmlns:a16="http://schemas.microsoft.com/office/drawing/2014/main" id="{32276044-14C6-4FAB-9E6E-5139ED8A8D1A}"/>
               </a:ext>
             </a:extLst>
           </p:cNvPr>
@@ -5544,7 +5648,7 @@
           <p:cNvPr id="5" name="">
             <a:extLst xmlns:a="http://schemas.openxmlformats.org/drawingml/2006/main">
               <a:ext uri="{FF2B5EF4-FFF2-40B4-BE49-F238E27FC236}">
-                <a16:creationId xmlns:a16="http://schemas.microsoft.com/office/drawing/2014/main" id="{F8DD3483-CCCB-46BC-ABF8-C79365A85551}"/>
+                <a16:creationId xmlns:a16="http://schemas.microsoft.com/office/drawing/2014/main" id="{53971930-57CA-4379-B0E8-E00DC63D7F23}"/>
               </a:ext>
             </a:extLst>
           </p:cNvPr>
@@ -5599,7 +5703,7 @@
     </p:spTree>
     <p:extLst>
       <p:ext uri="{BB962C8B-B14F-4D97-AF65-F5344CB8AC3E}">
-        <p14:creationId xmlns:p14="http://schemas.microsoft.com/office/powerpoint/2010/main" val="1645497895"/>
+        <p14:creationId xmlns:p14="http://schemas.microsoft.com/office/powerpoint/2010/main" val="1723969173"/>
       </p:ext>
     </p:extLst>
   </p:cSld>
@@ -5630,7 +5734,7 @@
           <p:cNvPr id="6" name="">
             <a:extLst xmlns:a="http://schemas.openxmlformats.org/drawingml/2006/main">
               <a:ext uri="{FF2B5EF4-FFF2-40B4-BE49-F238E27FC236}">
-                <a16:creationId xmlns:a16="http://schemas.microsoft.com/office/drawing/2014/main" id="{07DF8277-A25D-4124-8604-BBB1493C5DE2}"/>
+                <a16:creationId xmlns:a16="http://schemas.microsoft.com/office/drawing/2014/main" id="{4BFC8537-0CB6-44A0-840A-A59E7E38FB0B}"/>
               </a:ext>
             </a:extLst>
           </p:cNvPr>
@@ -5687,7 +5791,7 @@
           <p:cNvPr id="2" name="">
             <a:extLst xmlns:a="http://schemas.openxmlformats.org/drawingml/2006/main">
               <a:ext uri="{FF2B5EF4-FFF2-40B4-BE49-F238E27FC236}">
-                <a16:creationId xmlns:a16="http://schemas.microsoft.com/office/drawing/2014/main" id="{30AC9F95-5C04-4828-980D-946D8B70F2FC}"/>
+                <a16:creationId xmlns:a16="http://schemas.microsoft.com/office/drawing/2014/main" id="{A2436E65-2B80-4B7C-9F17-FFF8FA076F15}"/>
               </a:ext>
             </a:extLst>
           </p:cNvPr>
@@ -5747,7 +5851,7 @@
         </p:nvGraphicFramePr>
         <p:xfrm>
           <a:off xmlns:a="http://schemas.openxmlformats.org/drawingml/2006/main" x="809625" y="1381125"/>
-          <a:ext xmlns:a="http://schemas.openxmlformats.org/drawingml/2006/main" cx="10572750" cy="2952750"/>
+          <a:ext xmlns:a="http://schemas.openxmlformats.org/drawingml/2006/main" cx="10572750" cy="3238500"/>
         </p:xfrm>
         <a:graphic xmlns:a="http://schemas.openxmlformats.org/drawingml/2006/main">
           <a:graphicData uri="http://schemas.openxmlformats.org/drawingml/2006/table">
@@ -5758,14 +5862,14 @@
                 <a:gridCol w="5334000"/>
                 <a:gridCol w="3238500"/>
               </a:tblGrid>
-              <a:tr h="738188">
+              <a:tr h="647700">
                 <a:tc>
                   <a:txBody>
                     <a:bodyPr/>
                     <a:lstStyle/>
                     <a:p>
                       <a:r>
-                        <a:rPr sz="1425" b="1">
+                        <a:rPr sz="1350" b="1">
                           <a:solidFill>
                             <a:srgbClr val="FFFFFF"/>
                           </a:solidFill>
@@ -5789,7 +5893,7 @@
                     <a:lstStyle/>
                     <a:p>
                       <a:r>
-                        <a:rPr sz="1425" b="1">
+                        <a:rPr sz="1350" b="1">
                           <a:solidFill>
                             <a:srgbClr val="FFFFFF"/>
                           </a:solidFill>
@@ -5813,7 +5917,7 @@
                     <a:lstStyle/>
                     <a:p>
                       <a:r>
-                        <a:rPr sz="1425" b="1">
+                        <a:rPr sz="1350" b="1">
                           <a:solidFill>
                             <a:srgbClr val="FFFFFF"/>
                           </a:solidFill>
@@ -5832,14 +5936,14 @@
                   </a:tcPr>
                 </a:tc>
               </a:tr>
-              <a:tr h="738188">
+              <a:tr h="647700">
                 <a:tc>
                   <a:txBody>
                     <a:bodyPr/>
                     <a:lstStyle/>
                     <a:p>
                       <a:r>
-                        <a:rPr sz="1425">
+                        <a:rPr sz="1350">
                           <a:solidFill>
                             <a:srgbClr val="202B38"/>
                           </a:solidFill>
@@ -5863,7 +5967,7 @@
                     <a:lstStyle/>
                     <a:p>
                       <a:r>
-                        <a:rPr sz="1425">
+                        <a:rPr sz="1350">
                           <a:solidFill>
                             <a:srgbClr val="202B38"/>
                           </a:solidFill>
@@ -5887,7 +5991,7 @@
                     <a:lstStyle/>
                     <a:p>
                       <a:r>
-                        <a:rPr sz="1425">
+                        <a:rPr sz="1350">
                           <a:solidFill>
                             <a:srgbClr val="202B38"/>
                           </a:solidFill>
@@ -5906,14 +6010,14 @@
                   </a:tcPr>
                 </a:tc>
               </a:tr>
-              <a:tr h="738188">
+              <a:tr h="647700">
                 <a:tc>
                   <a:txBody>
                     <a:bodyPr/>
                     <a:lstStyle/>
                     <a:p>
                       <a:r>
-                        <a:rPr sz="1425">
+                        <a:rPr sz="1350">
                           <a:solidFill>
                             <a:srgbClr val="202B38"/>
                           </a:solidFill>
@@ -5937,7 +6041,7 @@
                     <a:lstStyle/>
                     <a:p>
                       <a:r>
-                        <a:rPr sz="1425">
+                        <a:rPr sz="1350">
                           <a:solidFill>
                             <a:srgbClr val="202B38"/>
                           </a:solidFill>
@@ -5945,7 +6049,7 @@
                           <a:ea typeface="Aptos"/>
                           <a:cs typeface="Aptos"/>
                         </a:rPr>
-                        <a:t>Regresión Logística balanceada</a:t>
+                        <a:t>Logística balanceada con C=0,5 y C=1</a:t>
                       </a:r>
                     </a:p>
                   </a:txBody>
@@ -5961,7 +6065,7 @@
                     <a:lstStyle/>
                     <a:p>
                       <a:r>
-                        <a:rPr sz="1425">
+                        <a:rPr sz="1350">
                           <a:solidFill>
                             <a:srgbClr val="202B38"/>
                           </a:solidFill>
@@ -5969,7 +6073,7 @@
                           <a:ea typeface="Aptos"/>
                           <a:cs typeface="Aptos"/>
                         </a:rPr>
-                        <a:t>Prioriza la clase minoritaria</a:t>
+                        <a:t>Compara regularización</a:t>
                       </a:r>
                     </a:p>
                   </a:txBody>
@@ -5980,14 +6084,14 @@
                   </a:tcPr>
                 </a:tc>
               </a:tr>
-              <a:tr h="738188">
+              <a:tr h="647700">
                 <a:tc>
                   <a:txBody>
                     <a:bodyPr/>
                     <a:lstStyle/>
                     <a:p>
                       <a:r>
-                        <a:rPr sz="1425">
+                        <a:rPr sz="1350">
                           <a:solidFill>
                             <a:srgbClr val="202B38"/>
                           </a:solidFill>
@@ -5995,7 +6099,7 @@
                           <a:ea typeface="Aptos"/>
                           <a:cs typeface="Aptos"/>
                         </a:rPr>
-                        <a:t>Árbol</a:t>
+                        <a:t>Umbral</a:t>
                       </a:r>
                     </a:p>
                   </a:txBody>
@@ -6011,7 +6115,7 @@
                     <a:lstStyle/>
                     <a:p>
                       <a:r>
-                        <a:rPr sz="1425">
+                        <a:rPr sz="1350">
                           <a:solidFill>
                             <a:srgbClr val="202B38"/>
                           </a:solidFill>
@@ -6019,7 +6123,7 @@
                           <a:ea typeface="Aptos"/>
                           <a:cs typeface="Aptos"/>
                         </a:rPr>
-                        <a:t>Random Forest, 100 árboles, profundidad 10</a:t>
+                        <a:t>Logística C=1 con threshold=0,35</a:t>
                       </a:r>
                     </a:p>
                   </a:txBody>
@@ -6035,7 +6139,7 @@
                     <a:lstStyle/>
                     <a:p>
                       <a:r>
-                        <a:rPr sz="1425">
+                        <a:rPr sz="1350">
                           <a:solidFill>
                             <a:srgbClr val="202B38"/>
                           </a:solidFill>
@@ -6043,7 +6147,7 @@
                           <a:ea typeface="Aptos"/>
                           <a:cs typeface="Aptos"/>
                         </a:rPr>
-                        <a:t>Alternativa no lineal</a:t>
+                        <a:t>Aumenta la detección de churn</a:t>
                       </a:r>
                     </a:p>
                   </a:txBody>
@@ -6054,6 +6158,80 @@
                   </a:tcPr>
                 </a:tc>
               </a:tr>
+              <a:tr h="647700">
+                <a:tc>
+                  <a:txBody>
+                    <a:bodyPr/>
+                    <a:lstStyle/>
+                    <a:p>
+                      <a:r>
+                        <a:rPr sz="1350">
+                          <a:solidFill>
+                            <a:srgbClr val="202B38"/>
+                          </a:solidFill>
+                          <a:latin typeface="Aptos"/>
+                          <a:ea typeface="Aptos"/>
+                          <a:cs typeface="Aptos"/>
+                        </a:rPr>
+                        <a:t>Árbol</a:t>
+                      </a:r>
+                    </a:p>
+                  </a:txBody>
+                  <a:tcPr marL="91440" marR="91440" marT="45720" marB="45720" anchor="ctr">
+                    <a:solidFill>
+                      <a:srgbClr val="E8F0F5"/>
+                    </a:solidFill>
+                  </a:tcPr>
+                </a:tc>
+                <a:tc>
+                  <a:txBody>
+                    <a:bodyPr/>
+                    <a:lstStyle/>
+                    <a:p>
+                      <a:r>
+                        <a:rPr sz="1350">
+                          <a:solidFill>
+                            <a:srgbClr val="202B38"/>
+                          </a:solidFill>
+                          <a:latin typeface="Aptos"/>
+                          <a:ea typeface="Aptos"/>
+                          <a:cs typeface="Aptos"/>
+                        </a:rPr>
+                        <a:t>Random Forest con profundidad 5 y 10</a:t>
+                      </a:r>
+                    </a:p>
+                  </a:txBody>
+                  <a:tcPr marL="91440" marR="91440" marT="45720" marB="45720" anchor="ctr">
+                    <a:solidFill>
+                      <a:srgbClr val="E8F0F5"/>
+                    </a:solidFill>
+                  </a:tcPr>
+                </a:tc>
+                <a:tc>
+                  <a:txBody>
+                    <a:bodyPr/>
+                    <a:lstStyle/>
+                    <a:p>
+                      <a:r>
+                        <a:rPr sz="1350">
+                          <a:solidFill>
+                            <a:srgbClr val="202B38"/>
+                          </a:solidFill>
+                          <a:latin typeface="Aptos"/>
+                          <a:ea typeface="Aptos"/>
+                          <a:cs typeface="Aptos"/>
+                        </a:rPr>
+                        <a:t>Compara complejidad</a:t>
+                      </a:r>
+                    </a:p>
+                  </a:txBody>
+                  <a:tcPr marL="91440" marR="91440" marT="45720" marB="45720" anchor="ctr">
+                    <a:solidFill>
+                      <a:srgbClr val="E8F0F5"/>
+                    </a:solidFill>
+                  </a:tcPr>
+                </a:tc>
+              </a:tr>
             </a:tbl>
           </a:graphicData>
         </a:graphic>
@@ -6063,7 +6241,7 @@
           <p:cNvPr id="4" name="">
             <a:extLst xmlns:a="http://schemas.openxmlformats.org/drawingml/2006/main">
               <a:ext uri="{FF2B5EF4-FFF2-40B4-BE49-F238E27FC236}">
-                <a16:creationId xmlns:a16="http://schemas.microsoft.com/office/drawing/2014/main" id="{121AD79F-BD92-49B4-9F33-5AC1230AB104}"/>
+                <a16:creationId xmlns:a16="http://schemas.microsoft.com/office/drawing/2014/main" id="{8F7846F1-7967-4637-AA97-C47F80BE41AE}"/>
               </a:ext>
             </a:extLst>
           </p:cNvPr>
@@ -6074,7 +6252,7 @@
         </p:nvSpPr>
         <p:spPr>
           <a:xfrm xmlns:a="http://schemas.openxmlformats.org/drawingml/2006/main">
-            <a:off x="1190625" y="4905375"/>
+            <a:off x="1190625" y="4953000"/>
             <a:ext cx="9810750" cy="523875"/>
           </a:xfrm>
           <a:prstGeom xmlns:a="http://schemas.openxmlformats.org/drawingml/2006/main" prst="rect">
@@ -6110,7 +6288,7 @@
                 <a:ea typeface="Aptos"/>
                 <a:cs typeface="Aptos"/>
               </a:rPr>
-              <a:t>Los tres modelos usan el mismo preprocesamiento y la misma partición.</a:t>
+              <a:t>Las seis corridas usan el mismo pipeline y la misma partición.</a:t>
             </a:r>
           </a:p>
         </p:txBody>
@@ -6120,7 +6298,7 @@
           <p:cNvPr id="5" name="">
             <a:extLst xmlns:a="http://schemas.openxmlformats.org/drawingml/2006/main">
               <a:ext uri="{FF2B5EF4-FFF2-40B4-BE49-F238E27FC236}">
-                <a16:creationId xmlns:a16="http://schemas.microsoft.com/office/drawing/2014/main" id="{C601ADE6-E6A9-4287-8FB1-8BA6F1AA583F}"/>
+                <a16:creationId xmlns:a16="http://schemas.microsoft.com/office/drawing/2014/main" id="{35C954ED-836B-4AD4-A2F7-420682E615BF}"/>
               </a:ext>
             </a:extLst>
           </p:cNvPr>
@@ -6175,7 +6353,7 @@
     </p:spTree>
     <p:extLst>
       <p:ext uri="{BB962C8B-B14F-4D97-AF65-F5344CB8AC3E}">
-        <p14:creationId xmlns:p14="http://schemas.microsoft.com/office/powerpoint/2010/main" val="829968619"/>
+        <p14:creationId xmlns:p14="http://schemas.microsoft.com/office/powerpoint/2010/main" val="1877151977"/>
       </p:ext>
     </p:extLst>
   </p:cSld>
@@ -6206,7 +6384,7 @@
           <p:cNvPr id="8" name="">
             <a:extLst xmlns:a="http://schemas.openxmlformats.org/drawingml/2006/main">
               <a:ext uri="{FF2B5EF4-FFF2-40B4-BE49-F238E27FC236}">
-                <a16:creationId xmlns:a16="http://schemas.microsoft.com/office/drawing/2014/main" id="{89092B85-B40B-46F1-A564-33C5DC131AF6}"/>
+                <a16:creationId xmlns:a16="http://schemas.microsoft.com/office/drawing/2014/main" id="{FA9C8B28-1422-4B9E-A923-1741D351C507}"/>
               </a:ext>
             </a:extLst>
           </p:cNvPr>
@@ -6263,7 +6441,7 @@
           <p:cNvPr id="2" name="">
             <a:extLst xmlns:a="http://schemas.openxmlformats.org/drawingml/2006/main">
               <a:ext uri="{FF2B5EF4-FFF2-40B4-BE49-F238E27FC236}">
-                <a16:creationId xmlns:a16="http://schemas.microsoft.com/office/drawing/2014/main" id="{71F7690C-207E-4496-8F5D-DE352CDC2F61}"/>
+                <a16:creationId xmlns:a16="http://schemas.microsoft.com/office/drawing/2014/main" id="{E3E5020F-164C-49DD-8C08-86D52695E0AA}"/>
               </a:ext>
             </a:extLst>
           </p:cNvPr>
@@ -6327,7 +6505,7 @@
         </p:xfrm>
         <a:graphic xmlns:a="http://schemas.openxmlformats.org/drawingml/2006/main">
           <a:graphicData uri="http://schemas.openxmlformats.org/drawingml/2006/chart">
-            <c:chart xmlns:r="http://schemas.openxmlformats.org/officeDocument/2006/relationships" xmlns:c="http://schemas.openxmlformats.org/drawingml/2006/chart" r:id="R65864b45fb9b4810"/>
+            <c:chart xmlns:r="http://schemas.openxmlformats.org/officeDocument/2006/relationships" xmlns:c="http://schemas.openxmlformats.org/drawingml/2006/chart" r:id="Rdf0c5ab76b9e4eab"/>
           </a:graphicData>
         </a:graphic>
       </p:graphicFrame>
@@ -6336,7 +6514,7 @@
           <p:cNvPr id="4" name="">
             <a:extLst xmlns:a="http://schemas.openxmlformats.org/drawingml/2006/main">
               <a:ext uri="{FF2B5EF4-FFF2-40B4-BE49-F238E27FC236}">
-                <a16:creationId xmlns:a16="http://schemas.microsoft.com/office/drawing/2014/main" id="{1466EBB1-B079-496E-BE34-41E2EFE7020E}"/>
+                <a16:creationId xmlns:a16="http://schemas.microsoft.com/office/drawing/2014/main" id="{522293D7-AC73-41B2-8372-6643C13EAD0C}"/>
               </a:ext>
             </a:extLst>
           </p:cNvPr>
@@ -6393,7 +6571,7 @@
           <p:cNvPr id="5" name="">
             <a:extLst xmlns:a="http://schemas.openxmlformats.org/drawingml/2006/main">
               <a:ext uri="{FF2B5EF4-FFF2-40B4-BE49-F238E27FC236}">
-                <a16:creationId xmlns:a16="http://schemas.microsoft.com/office/drawing/2014/main" id="{6F74EF3A-4675-456E-AEE8-0FE47AE9940A}"/>
+                <a16:creationId xmlns:a16="http://schemas.microsoft.com/office/drawing/2014/main" id="{1C7C9BC2-9703-4F86-9C42-971F6F6B5B1F}"/>
               </a:ext>
             </a:extLst>
           </p:cNvPr>
@@ -6422,7 +6600,7 @@
           <a:lstStyle xmlns:a="http://schemas.openxmlformats.org/drawingml/2006/main"/>
           <a:p xmlns:a="http://schemas.openxmlformats.org/drawingml/2006/main">
             <a:pPr algn="ctr">
-              <a:defRPr sz="2700" b="1">
+              <a:defRPr sz="2550" b="1">
                 <a:solidFill>
                   <a:srgbClr val="183A63"/>
                 </a:solidFill>
@@ -6432,7 +6610,7 @@
               </a:defRPr>
             </a:pPr>
             <a:r>
-              <a:rPr sz="2700" b="1">
+              <a:rPr sz="2550" b="1">
                 <a:solidFill>
                   <a:srgbClr val="183A63"/>
                 </a:solidFill>
@@ -6440,12 +6618,12 @@
                 <a:ea typeface="Aptos"/>
                 <a:cs typeface="Aptos"/>
               </a:rPr>
-              <a:t>Regresión</a:t>
+              <a:t>Logística</a:t>
             </a:r>
           </a:p>
           <a:p xmlns:a="http://schemas.openxmlformats.org/drawingml/2006/main">
             <a:pPr algn="ctr">
-              <a:defRPr sz="2700" b="1">
+              <a:defRPr sz="2550" b="1">
                 <a:solidFill>
                   <a:srgbClr val="183A63"/>
                 </a:solidFill>
@@ -6455,7 +6633,7 @@
               </a:defRPr>
             </a:pPr>
             <a:r>
-              <a:rPr sz="2700" b="1">
+              <a:rPr sz="2550" b="1">
                 <a:solidFill>
                   <a:srgbClr val="183A63"/>
                 </a:solidFill>
@@ -6463,7 +6641,7 @@
                 <a:ea typeface="Aptos"/>
                 <a:cs typeface="Aptos"/>
               </a:rPr>
-              <a:t>Logística</a:t>
+              <a:t>umbral 0,35</a:t>
             </a:r>
           </a:p>
         </p:txBody>
@@ -6473,7 +6651,7 @@
           <p:cNvPr id="6" name="">
             <a:extLst xmlns:a="http://schemas.openxmlformats.org/drawingml/2006/main">
               <a:ext uri="{FF2B5EF4-FFF2-40B4-BE49-F238E27FC236}">
-                <a16:creationId xmlns:a16="http://schemas.microsoft.com/office/drawing/2014/main" id="{4B8923D1-DEF9-40A4-95EA-8D5F661EE1B6}"/>
+                <a16:creationId xmlns:a16="http://schemas.microsoft.com/office/drawing/2014/main" id="{D3CEB88C-2D64-4C5E-A640-52B3BE5D831F}"/>
               </a:ext>
             </a:extLst>
           </p:cNvPr>
@@ -6502,7 +6680,7 @@
           <a:lstStyle xmlns:a="http://schemas.openxmlformats.org/drawingml/2006/main"/>
           <a:p xmlns:a="http://schemas.openxmlformats.org/drawingml/2006/main">
             <a:pPr algn="ctr">
-              <a:defRPr sz="2025" b="0">
+              <a:defRPr sz="1875" b="0">
                 <a:solidFill>
                   <a:srgbClr val="202B38"/>
                 </a:solidFill>
@@ -6512,7 +6690,7 @@
               </a:defRPr>
             </a:pPr>
             <a:r>
-              <a:rPr sz="2025" b="0">
+              <a:rPr sz="1875" b="0">
                 <a:solidFill>
                   <a:srgbClr val="202B38"/>
                 </a:solidFill>
@@ -6520,12 +6698,12 @@
                 <a:ea typeface="Aptos"/>
                 <a:cs typeface="Aptos"/>
               </a:rPr>
-              <a:t>Recall 0,72</a:t>
+              <a:t>Recall 0,887</a:t>
             </a:r>
           </a:p>
           <a:p xmlns:a="http://schemas.openxmlformats.org/drawingml/2006/main">
             <a:pPr algn="ctr">
-              <a:defRPr sz="2025" b="0">
+              <a:defRPr sz="1875" b="0">
                 <a:solidFill>
                   <a:srgbClr val="202B38"/>
                 </a:solidFill>
@@ -6535,7 +6713,7 @@
               </a:defRPr>
             </a:pPr>
             <a:r>
-              <a:rPr sz="2025" b="0">
+              <a:rPr sz="1875" b="0">
                 <a:solidFill>
                   <a:srgbClr val="202B38"/>
                 </a:solidFill>
@@ -6543,12 +6721,12 @@
                 <a:ea typeface="Aptos"/>
                 <a:cs typeface="Aptos"/>
               </a:rPr>
-              <a:t>F1 0,58</a:t>
+              <a:t>F1 0,573</a:t>
             </a:r>
           </a:p>
           <a:p xmlns:a="http://schemas.openxmlformats.org/drawingml/2006/main">
             <a:pPr algn="ctr">
-              <a:defRPr sz="2025" b="0">
+              <a:defRPr sz="1875" b="0">
                 <a:solidFill>
                   <a:srgbClr val="202B38"/>
                 </a:solidFill>
@@ -6558,7 +6736,7 @@
               </a:defRPr>
             </a:pPr>
             <a:r>
-              <a:rPr sz="2025" b="0">
+              <a:rPr sz="1875" b="0">
                 <a:solidFill>
                   <a:srgbClr val="202B38"/>
                 </a:solidFill>
@@ -6566,7 +6744,7 @@
                 <a:ea typeface="Aptos"/>
                 <a:cs typeface="Aptos"/>
               </a:rPr>
-              <a:t>ROC-AUC 0,81</a:t>
+              <a:t>ROC-AUC 0,821</a:t>
             </a:r>
           </a:p>
         </p:txBody>
@@ -6576,7 +6754,7 @@
           <p:cNvPr id="7" name="">
             <a:extLst xmlns:a="http://schemas.openxmlformats.org/drawingml/2006/main">
               <a:ext uri="{FF2B5EF4-FFF2-40B4-BE49-F238E27FC236}">
-                <a16:creationId xmlns:a16="http://schemas.microsoft.com/office/drawing/2014/main" id="{6AD023F7-96E1-480B-9A7A-5B1A7E20ACBE}"/>
+                <a16:creationId xmlns:a16="http://schemas.microsoft.com/office/drawing/2014/main" id="{18C36AA6-6885-4AAA-AB98-E83E2B56E8BC}"/>
               </a:ext>
             </a:extLst>
           </p:cNvPr>
@@ -6623,7 +6801,7 @@
                 <a:ea typeface="Aptos"/>
                 <a:cs typeface="Aptos"/>
               </a:rPr>
-              <a:t>Mayor detección de churn entre los modelos evaluados</a:t>
+              <a:t>Seleccionada con validación antes de evaluar el test</a:t>
             </a:r>
           </a:p>
         </p:txBody>
@@ -6631,7 +6809,7 @@
     </p:spTree>
     <p:extLst>
       <p:ext uri="{BB962C8B-B14F-4D97-AF65-F5344CB8AC3E}">
-        <p14:creationId xmlns:p14="http://schemas.microsoft.com/office/powerpoint/2010/main" val="231216573"/>
+        <p14:creationId xmlns:p14="http://schemas.microsoft.com/office/powerpoint/2010/main" val="216569611"/>
       </p:ext>
     </p:extLst>
   </p:cSld>
@@ -6662,7 +6840,7 @@
           <p:cNvPr id="10" name="">
             <a:extLst xmlns:a="http://schemas.openxmlformats.org/drawingml/2006/main">
               <a:ext uri="{FF2B5EF4-FFF2-40B4-BE49-F238E27FC236}">
-                <a16:creationId xmlns:a16="http://schemas.microsoft.com/office/drawing/2014/main" id="{0F43E412-43C3-43F7-B643-45EAF0215825}"/>
+                <a16:creationId xmlns:a16="http://schemas.microsoft.com/office/drawing/2014/main" id="{5386487B-DA22-460B-9266-8C97D6D90F51}"/>
               </a:ext>
             </a:extLst>
           </p:cNvPr>
@@ -6709,7 +6887,7 @@
                 <a:ea typeface="Aptos"/>
                 <a:cs typeface="Aptos"/>
               </a:rPr>
-              <a:t>Modelo candidato inicial</a:t>
+              <a:t>Evaluación final del candidato</a:t>
             </a:r>
           </a:p>
         </p:txBody>
@@ -6719,7 +6897,7 @@
           <p:cNvPr id="2" name="">
             <a:extLst xmlns:a="http://schemas.openxmlformats.org/drawingml/2006/main">
               <a:ext uri="{FF2B5EF4-FFF2-40B4-BE49-F238E27FC236}">
-                <a16:creationId xmlns:a16="http://schemas.microsoft.com/office/drawing/2014/main" id="{9B62E4D9-C02A-4C32-AA30-236FD34C3C80}"/>
+                <a16:creationId xmlns:a16="http://schemas.microsoft.com/office/drawing/2014/main" id="{ECBAF2F4-E80D-4CE2-B4F1-4C27AA0840F2}"/>
               </a:ext>
             </a:extLst>
           </p:cNvPr>
@@ -6776,7 +6954,7 @@
           <p:cNvPr id="3" name="">
             <a:extLst xmlns:a="http://schemas.openxmlformats.org/drawingml/2006/main">
               <a:ext uri="{FF2B5EF4-FFF2-40B4-BE49-F238E27FC236}">
-                <a16:creationId xmlns:a16="http://schemas.microsoft.com/office/drawing/2014/main" id="{E853359D-07CA-40CE-92ED-6685D29834EA}"/>
+                <a16:creationId xmlns:a16="http://schemas.microsoft.com/office/drawing/2014/main" id="{DC927F00-CEFB-45DC-A0B9-B881E60FB7DE}"/>
               </a:ext>
             </a:extLst>
           </p:cNvPr>
@@ -6805,7 +6983,7 @@
           <a:lstStyle xmlns:a="http://schemas.openxmlformats.org/drawingml/2006/main"/>
           <a:p xmlns:a="http://schemas.openxmlformats.org/drawingml/2006/main">
             <a:pPr algn="ctr">
-              <a:defRPr sz="2325" b="1">
+              <a:defRPr sz="2250" b="1">
                 <a:solidFill>
                   <a:srgbClr val="183A63"/>
                 </a:solidFill>
@@ -6815,7 +6993,7 @@
               </a:defRPr>
             </a:pPr>
             <a:r>
-              <a:rPr sz="2325" b="1">
+              <a:rPr sz="2250" b="1">
                 <a:solidFill>
                   <a:srgbClr val="183A63"/>
                 </a:solidFill>
@@ -6823,7 +7001,7 @@
                 <a:ea typeface="Aptos"/>
                 <a:cs typeface="Aptos"/>
               </a:rPr>
-              <a:t>Regresión Logística balanceada</a:t>
+              <a:t>Regresión Logística balanceada con umbral 0,35</a:t>
             </a:r>
           </a:p>
         </p:txBody>
@@ -6960,7 +7138,7 @@
                           <a:ea typeface="Aptos"/>
                           <a:cs typeface="Aptos"/>
                         </a:rPr>
-                        <a:t>747 TN</a:t>
+                        <a:t>609 TN</a:t>
                       </a:r>
                     </a:p>
                   </a:txBody>
@@ -6984,7 +7162,7 @@
                           <a:ea typeface="Aptos"/>
                           <a:cs typeface="Aptos"/>
                         </a:rPr>
-                        <a:t>290 FP</a:t>
+                        <a:t>428 FP</a:t>
                       </a:r>
                     </a:p>
                   </a:txBody>
@@ -7034,7 +7212,7 @@
                           <a:ea typeface="Aptos"/>
                           <a:cs typeface="Aptos"/>
                         </a:rPr>
-                        <a:t>103 FN</a:t>
+                        <a:t>57 FN</a:t>
                       </a:r>
                     </a:p>
                   </a:txBody>
@@ -7058,7 +7236,7 @@
                           <a:ea typeface="Aptos"/>
                           <a:cs typeface="Aptos"/>
                         </a:rPr>
-                        <a:t>269 TP</a:t>
+                        <a:t>315 TP</a:t>
                       </a:r>
                     </a:p>
                   </a:txBody>
@@ -7078,7 +7256,7 @@
           <p:cNvPr id="5" name="">
             <a:extLst xmlns:a="http://schemas.openxmlformats.org/drawingml/2006/main">
               <a:ext uri="{FF2B5EF4-FFF2-40B4-BE49-F238E27FC236}">
-                <a16:creationId xmlns:a16="http://schemas.microsoft.com/office/drawing/2014/main" id="{41CB93E3-3694-4113-87A9-CE9E38C692D4}"/>
+                <a16:creationId xmlns:a16="http://schemas.microsoft.com/office/drawing/2014/main" id="{22D6DA99-F8C5-4D94-9DFB-10FF45C81125}"/>
               </a:ext>
             </a:extLst>
           </p:cNvPr>
@@ -7125,7 +7303,7 @@
                 <a:ea typeface="Aptos"/>
                 <a:cs typeface="Aptos"/>
               </a:rPr>
-              <a:t>0,72</a:t>
+              <a:t>0,847</a:t>
             </a:r>
           </a:p>
         </p:txBody>
@@ -7135,7 +7313,7 @@
           <p:cNvPr id="6" name="">
             <a:extLst xmlns:a="http://schemas.openxmlformats.org/drawingml/2006/main">
               <a:ext uri="{FF2B5EF4-FFF2-40B4-BE49-F238E27FC236}">
-                <a16:creationId xmlns:a16="http://schemas.microsoft.com/office/drawing/2014/main" id="{6F1A6F94-0252-4D3C-B234-06B9CBB44705}"/>
+                <a16:creationId xmlns:a16="http://schemas.microsoft.com/office/drawing/2014/main" id="{FE367B91-37FF-4E81-B7FE-29F876F35C96}"/>
               </a:ext>
             </a:extLst>
           </p:cNvPr>
@@ -7192,7 +7370,7 @@
           <p:cNvPr id="7" name="">
             <a:extLst xmlns:a="http://schemas.openxmlformats.org/drawingml/2006/main">
               <a:ext uri="{FF2B5EF4-FFF2-40B4-BE49-F238E27FC236}">
-                <a16:creationId xmlns:a16="http://schemas.microsoft.com/office/drawing/2014/main" id="{4A427EF5-4576-402E-BCC5-68444C04001A}"/>
+                <a16:creationId xmlns:a16="http://schemas.microsoft.com/office/drawing/2014/main" id="{2884F44C-DCF2-4E45-B444-AE502EBC2B6A}"/>
               </a:ext>
             </a:extLst>
           </p:cNvPr>
@@ -7239,7 +7417,7 @@
                 <a:ea typeface="Aptos"/>
                 <a:cs typeface="Aptos"/>
               </a:rPr>
-              <a:t>269</a:t>
+              <a:t>315</a:t>
             </a:r>
           </a:p>
         </p:txBody>
@@ -7249,7 +7427,7 @@
           <p:cNvPr id="8" name="">
             <a:extLst xmlns:a="http://schemas.openxmlformats.org/drawingml/2006/main">
               <a:ext uri="{FF2B5EF4-FFF2-40B4-BE49-F238E27FC236}">
-                <a16:creationId xmlns:a16="http://schemas.microsoft.com/office/drawing/2014/main" id="{8F338D22-1754-48AB-92DA-553C51733153}"/>
+                <a16:creationId xmlns:a16="http://schemas.microsoft.com/office/drawing/2014/main" id="{776A367F-1D61-4E1A-8D2A-15E0F4DCC246}"/>
               </a:ext>
             </a:extLst>
           </p:cNvPr>
@@ -7306,7 +7484,7 @@
           <p:cNvPr id="9" name="">
             <a:extLst xmlns:a="http://schemas.openxmlformats.org/drawingml/2006/main">
               <a:ext uri="{FF2B5EF4-FFF2-40B4-BE49-F238E27FC236}">
-                <a16:creationId xmlns:a16="http://schemas.microsoft.com/office/drawing/2014/main" id="{A4A089F7-B1BD-4AFB-95EE-653FDB5FE0A3}"/>
+                <a16:creationId xmlns:a16="http://schemas.microsoft.com/office/drawing/2014/main" id="{CA67C36E-C52B-4885-B7B5-5A4E1E354B79}"/>
               </a:ext>
             </a:extLst>
           </p:cNvPr>
@@ -7353,7 +7531,7 @@
                 <a:ea typeface="Aptos"/>
                 <a:cs typeface="Aptos"/>
               </a:rPr>
-              <a:t>La conclusión corresponde a una sola partición train/test y todavía no incluye validación cruzada ni ajuste del umbral.</a:t>
+              <a:t>El modelo se seleccionó con validación y se evaluó una sola vez sobre el test aislado.</a:t>
             </a:r>
           </a:p>
         </p:txBody>
@@ -7361,7 +7539,7 @@
     </p:spTree>
     <p:extLst>
       <p:ext uri="{BB962C8B-B14F-4D97-AF65-F5344CB8AC3E}">
-        <p14:creationId xmlns:p14="http://schemas.microsoft.com/office/powerpoint/2010/main" val="586516284"/>
+        <p14:creationId xmlns:p14="http://schemas.microsoft.com/office/powerpoint/2010/main" val="146999511"/>
       </p:ext>
     </p:extLst>
   </p:cSld>
@@ -7392,7 +7570,7 @@
           <p:cNvPr id="5" name="">
             <a:extLst xmlns:a="http://schemas.openxmlformats.org/drawingml/2006/main">
               <a:ext uri="{FF2B5EF4-FFF2-40B4-BE49-F238E27FC236}">
-                <a16:creationId xmlns:a16="http://schemas.microsoft.com/office/drawing/2014/main" id="{C8ED97DB-CF15-4F0D-8712-E4F772F2DC9E}"/>
+                <a16:creationId xmlns:a16="http://schemas.microsoft.com/office/drawing/2014/main" id="{F13E0FFC-F99C-45B3-9512-C382FAED1DDC}"/>
               </a:ext>
             </a:extLst>
           </p:cNvPr>
@@ -7439,7 +7617,7 @@
                 <a:ea typeface="Aptos"/>
                 <a:cs typeface="Aptos"/>
               </a:rPr>
-              <a:t>Requisitos presentes en el repositorio</a:t>
+              <a:t>Experimentos registrados en MLflow</a:t>
             </a:r>
           </a:p>
         </p:txBody>
@@ -7449,7 +7627,7 @@
           <p:cNvPr id="2" name="">
             <a:extLst xmlns:a="http://schemas.openxmlformats.org/drawingml/2006/main">
               <a:ext uri="{FF2B5EF4-FFF2-40B4-BE49-F238E27FC236}">
-                <a16:creationId xmlns:a16="http://schemas.microsoft.com/office/drawing/2014/main" id="{610F1A92-1396-409B-BF01-DE977352EA47}"/>
+                <a16:creationId xmlns:a16="http://schemas.microsoft.com/office/drawing/2014/main" id="{A983D927-EBA6-470D-94C4-C3766111BF54}"/>
               </a:ext>
             </a:extLst>
           </p:cNvPr>
@@ -7508,25 +7686,27 @@
           <p:nvPr/>
         </p:nvGraphicFramePr>
         <p:xfrm>
-          <a:off xmlns:a="http://schemas.openxmlformats.org/drawingml/2006/main" x="666750" y="1162050"/>
-          <a:ext xmlns:a="http://schemas.openxmlformats.org/drawingml/2006/main" cx="10858500" cy="4857750"/>
+          <a:off xmlns:a="http://schemas.openxmlformats.org/drawingml/2006/main" x="857250" y="1285875"/>
+          <a:ext xmlns:a="http://schemas.openxmlformats.org/drawingml/2006/main" cx="10477500" cy="4191000"/>
         </p:xfrm>
         <a:graphic xmlns:a="http://schemas.openxmlformats.org/drawingml/2006/main">
           <a:graphicData uri="http://schemas.openxmlformats.org/drawingml/2006/table">
             <a:tbl>
               <a:tblPr/>
               <a:tblGrid>
-                <a:gridCol w="4000500"/>
-                <a:gridCol w="6858000"/>
+                <a:gridCol w="4762500"/>
+                <a:gridCol w="1905000"/>
+                <a:gridCol w="1905000"/>
+                <a:gridCol w="1905000"/>
               </a:tblGrid>
-              <a:tr h="485775">
+              <a:tr h="598714">
                 <a:tc>
                   <a:txBody>
                     <a:bodyPr/>
                     <a:lstStyle/>
                     <a:p>
                       <a:r>
-                        <a:rPr sz="1125" b="1">
+                        <a:rPr sz="1275" b="1">
                           <a:solidFill>
                             <a:srgbClr val="FFFFFF"/>
                           </a:solidFill>
@@ -7534,7 +7714,7 @@
                           <a:ea typeface="Aptos"/>
                           <a:cs typeface="Aptos"/>
                         </a:rPr>
-                        <a:t>Requisito</a:t>
+                        <a:t>Run</a:t>
                       </a:r>
                     </a:p>
                   </a:txBody>
@@ -7550,7 +7730,7 @@
                     <a:lstStyle/>
                     <a:p>
                       <a:r>
-                        <a:rPr sz="1125" b="1">
+                        <a:rPr sz="1275" b="1">
                           <a:solidFill>
                             <a:srgbClr val="FFFFFF"/>
                           </a:solidFill>
@@ -7558,7 +7738,55 @@
                           <a:ea typeface="Aptos"/>
                           <a:cs typeface="Aptos"/>
                         </a:rPr>
-                        <a:t>Evidencia actual</a:t>
+                        <a:t>Recall</a:t>
+                      </a:r>
+                    </a:p>
+                  </a:txBody>
+                  <a:tcPr marL="91440" marR="91440" marT="45720" marB="45720" anchor="ctr">
+                    <a:solidFill>
+                      <a:srgbClr val="183A63"/>
+                    </a:solidFill>
+                  </a:tcPr>
+                </a:tc>
+                <a:tc>
+                  <a:txBody>
+                    <a:bodyPr/>
+                    <a:lstStyle/>
+                    <a:p>
+                      <a:r>
+                        <a:rPr sz="1275" b="1">
+                          <a:solidFill>
+                            <a:srgbClr val="FFFFFF"/>
+                          </a:solidFill>
+                          <a:latin typeface="Aptos"/>
+                          <a:ea typeface="Aptos"/>
+                          <a:cs typeface="Aptos"/>
+                        </a:rPr>
+                        <a:t>F1</a:t>
+                      </a:r>
+                    </a:p>
+                  </a:txBody>
+                  <a:tcPr marL="91440" marR="91440" marT="45720" marB="45720" anchor="ctr">
+                    <a:solidFill>
+                      <a:srgbClr val="183A63"/>
+                    </a:solidFill>
+                  </a:tcPr>
+                </a:tc>
+                <a:tc>
+                  <a:txBody>
+                    <a:bodyPr/>
+                    <a:lstStyle/>
+                    <a:p>
+                      <a:r>
+                        <a:rPr sz="1275" b="1">
+                          <a:solidFill>
+                            <a:srgbClr val="FFFFFF"/>
+                          </a:solidFill>
+                          <a:latin typeface="Aptos"/>
+                          <a:ea typeface="Aptos"/>
+                          <a:cs typeface="Aptos"/>
+                        </a:rPr>
+                        <a:t>ROC-AUC</a:t>
                       </a:r>
                     </a:p>
                   </a:txBody>
@@ -7569,14 +7797,14 @@
                   </a:tcPr>
                 </a:tc>
               </a:tr>
-              <a:tr h="485775">
+              <a:tr h="598714">
                 <a:tc>
                   <a:txBody>
                     <a:bodyPr/>
                     <a:lstStyle/>
                     <a:p>
                       <a:r>
-                        <a:rPr sz="1125">
+                        <a:rPr sz="1275">
                           <a:solidFill>
                             <a:srgbClr val="202B38"/>
                           </a:solidFill>
@@ -7584,7 +7812,7 @@
                           <a:ea typeface="Aptos"/>
                           <a:cs typeface="Aptos"/>
                         </a:rPr>
-                        <a:t>GitHub, README y requirements</a:t>
+                        <a:t>dummy_prior</a:t>
                       </a:r>
                     </a:p>
                   </a:txBody>
@@ -7600,7 +7828,7 @@
                     <a:lstStyle/>
                     <a:p>
                       <a:r>
-                        <a:rPr sz="1125">
+                        <a:rPr sz="1275">
                           <a:solidFill>
                             <a:srgbClr val="202B38"/>
                           </a:solidFill>
@@ -7608,7 +7836,55 @@
                           <a:ea typeface="Aptos"/>
                           <a:cs typeface="Aptos"/>
                         </a:rPr>
-                        <a:t>Repositorio compartido y dependencias declaradas</a:t>
+                        <a:t>0,000</a:t>
+                      </a:r>
+                    </a:p>
+                  </a:txBody>
+                  <a:tcPr marL="91440" marR="91440" marT="45720" marB="45720" anchor="ctr">
+                    <a:solidFill>
+                      <a:srgbClr val="FFFFFF"/>
+                    </a:solidFill>
+                  </a:tcPr>
+                </a:tc>
+                <a:tc>
+                  <a:txBody>
+                    <a:bodyPr/>
+                    <a:lstStyle/>
+                    <a:p>
+                      <a:r>
+                        <a:rPr sz="1275">
+                          <a:solidFill>
+                            <a:srgbClr val="202B38"/>
+                          </a:solidFill>
+                          <a:latin typeface="Aptos"/>
+                          <a:ea typeface="Aptos"/>
+                          <a:cs typeface="Aptos"/>
+                        </a:rPr>
+                        <a:t>0,000</a:t>
+                      </a:r>
+                    </a:p>
+                  </a:txBody>
+                  <a:tcPr marL="91440" marR="91440" marT="45720" marB="45720" anchor="ctr">
+                    <a:solidFill>
+                      <a:srgbClr val="FFFFFF"/>
+                    </a:solidFill>
+                  </a:tcPr>
+                </a:tc>
+                <a:tc>
+                  <a:txBody>
+                    <a:bodyPr/>
+                    <a:lstStyle/>
+                    <a:p>
+                      <a:r>
+                        <a:rPr sz="1275">
+                          <a:solidFill>
+                            <a:srgbClr val="202B38"/>
+                          </a:solidFill>
+                          <a:latin typeface="Aptos"/>
+                          <a:ea typeface="Aptos"/>
+                          <a:cs typeface="Aptos"/>
+                        </a:rPr>
+                        <a:t>0,500</a:t>
                       </a:r>
                     </a:p>
                   </a:txBody>
@@ -7619,14 +7895,14 @@
                   </a:tcPr>
                 </a:tc>
               </a:tr>
-              <a:tr h="485775">
+              <a:tr h="598714">
                 <a:tc>
                   <a:txBody>
                     <a:bodyPr/>
                     <a:lstStyle/>
                     <a:p>
                       <a:r>
-                        <a:rPr sz="1125">
+                        <a:rPr sz="1275">
                           <a:solidFill>
                             <a:srgbClr val="202B38"/>
                           </a:solidFill>
@@ -7634,7 +7910,7 @@
                           <a:ea typeface="Aptos"/>
                           <a:cs typeface="Aptos"/>
                         </a:rPr>
-                        <a:t>EDA razonable</a:t>
+                        <a:t>logreg_c0.5</a:t>
                       </a:r>
                     </a:p>
                   </a:txBody>
@@ -7650,7 +7926,7 @@
                     <a:lstStyle/>
                     <a:p>
                       <a:r>
-                        <a:rPr sz="1125">
+                        <a:rPr sz="1275">
                           <a:solidFill>
                             <a:srgbClr val="202B38"/>
                           </a:solidFill>
@@ -7658,7 +7934,55 @@
                           <a:ea typeface="Aptos"/>
                           <a:cs typeface="Aptos"/>
                         </a:rPr>
-                        <a:t>Dimensiones, tipos, faltantes, target y relaciones</a:t>
+                        <a:t>0,768</a:t>
+                      </a:r>
+                    </a:p>
+                  </a:txBody>
+                  <a:tcPr marL="91440" marR="91440" marT="45720" marB="45720" anchor="ctr">
+                    <a:solidFill>
+                      <a:srgbClr val="E8F0F5"/>
+                    </a:solidFill>
+                  </a:tcPr>
+                </a:tc>
+                <a:tc>
+                  <a:txBody>
+                    <a:bodyPr/>
+                    <a:lstStyle/>
+                    <a:p>
+                      <a:r>
+                        <a:rPr sz="1275">
+                          <a:solidFill>
+                            <a:srgbClr val="202B38"/>
+                          </a:solidFill>
+                          <a:latin typeface="Aptos"/>
+                          <a:ea typeface="Aptos"/>
+                          <a:cs typeface="Aptos"/>
+                        </a:rPr>
+                        <a:t>0,603</a:t>
+                      </a:r>
+                    </a:p>
+                  </a:txBody>
+                  <a:tcPr marL="91440" marR="91440" marT="45720" marB="45720" anchor="ctr">
+                    <a:solidFill>
+                      <a:srgbClr val="E8F0F5"/>
+                    </a:solidFill>
+                  </a:tcPr>
+                </a:tc>
+                <a:tc>
+                  <a:txBody>
+                    <a:bodyPr/>
+                    <a:lstStyle/>
+                    <a:p>
+                      <a:r>
+                        <a:rPr sz="1275">
+                          <a:solidFill>
+                            <a:srgbClr val="202B38"/>
+                          </a:solidFill>
+                          <a:latin typeface="Aptos"/>
+                          <a:ea typeface="Aptos"/>
+                          <a:cs typeface="Aptos"/>
+                        </a:rPr>
+                        <a:t>0,821</a:t>
                       </a:r>
                     </a:p>
                   </a:txBody>
@@ -7669,14 +7993,14 @@
                   </a:tcPr>
                 </a:tc>
               </a:tr>
-              <a:tr h="485775">
+              <a:tr h="598714">
                 <a:tc>
                   <a:txBody>
                     <a:bodyPr/>
                     <a:lstStyle/>
                     <a:p>
                       <a:r>
-                        <a:rPr sz="1125">
+                        <a:rPr sz="1275">
                           <a:solidFill>
                             <a:srgbClr val="202B38"/>
                           </a:solidFill>
@@ -7684,7 +8008,7 @@
                           <a:ea typeface="Aptos"/>
                           <a:cs typeface="Aptos"/>
                         </a:rPr>
-                        <a:t>Partición reproducible</a:t>
+                        <a:t>logreg_c1</a:t>
                       </a:r>
                     </a:p>
                   </a:txBody>
@@ -7700,7 +8024,7 @@
                     <a:lstStyle/>
                     <a:p>
                       <a:r>
-                        <a:rPr sz="1125">
+                        <a:rPr sz="1275">
                           <a:solidFill>
                             <a:srgbClr val="202B38"/>
                           </a:solidFill>
@@ -7708,7 +8032,55 @@
                           <a:ea typeface="Aptos"/>
                           <a:cs typeface="Aptos"/>
                         </a:rPr>
-                        <a:t>80/20 estratificado con random_state=42</a:t>
+                        <a:t>0,771</a:t>
+                      </a:r>
+                    </a:p>
+                  </a:txBody>
+                  <a:tcPr marL="91440" marR="91440" marT="45720" marB="45720" anchor="ctr">
+                    <a:solidFill>
+                      <a:srgbClr val="FFFFFF"/>
+                    </a:solidFill>
+                  </a:tcPr>
+                </a:tc>
+                <a:tc>
+                  <a:txBody>
+                    <a:bodyPr/>
+                    <a:lstStyle/>
+                    <a:p>
+                      <a:r>
+                        <a:rPr sz="1275">
+                          <a:solidFill>
+                            <a:srgbClr val="202B38"/>
+                          </a:solidFill>
+                          <a:latin typeface="Aptos"/>
+                          <a:ea typeface="Aptos"/>
+                          <a:cs typeface="Aptos"/>
+                        </a:rPr>
+                        <a:t>0,603</a:t>
+                      </a:r>
+                    </a:p>
+                  </a:txBody>
+                  <a:tcPr marL="91440" marR="91440" marT="45720" marB="45720" anchor="ctr">
+                    <a:solidFill>
+                      <a:srgbClr val="FFFFFF"/>
+                    </a:solidFill>
+                  </a:tcPr>
+                </a:tc>
+                <a:tc>
+                  <a:txBody>
+                    <a:bodyPr/>
+                    <a:lstStyle/>
+                    <a:p>
+                      <a:r>
+                        <a:rPr sz="1275">
+                          <a:solidFill>
+                            <a:srgbClr val="202B38"/>
+                          </a:solidFill>
+                          <a:latin typeface="Aptos"/>
+                          <a:ea typeface="Aptos"/>
+                          <a:cs typeface="Aptos"/>
+                        </a:rPr>
+                        <a:t>0,821</a:t>
                       </a:r>
                     </a:p>
                   </a:txBody>
@@ -7719,14 +8091,14 @@
                   </a:tcPr>
                 </a:tc>
               </a:tr>
-              <a:tr h="485775">
+              <a:tr h="598714">
                 <a:tc>
                   <a:txBody>
                     <a:bodyPr/>
                     <a:lstStyle/>
                     <a:p>
                       <a:r>
-                        <a:rPr sz="1125">
+                        <a:rPr sz="1275">
                           <a:solidFill>
                             <a:srgbClr val="202B38"/>
                           </a:solidFill>
@@ -7734,7 +8106,7 @@
                           <a:ea typeface="Aptos"/>
                           <a:cs typeface="Aptos"/>
                         </a:rPr>
-                        <a:t>Pipeline de scikit-learn</a:t>
+                        <a:t>logreg_c1_threshold035</a:t>
                       </a:r>
                     </a:p>
                   </a:txBody>
@@ -7750,7 +8122,7 @@
                     <a:lstStyle/>
                     <a:p>
                       <a:r>
-                        <a:rPr sz="1125">
+                        <a:rPr sz="1275">
                           <a:solidFill>
                             <a:srgbClr val="202B38"/>
                           </a:solidFill>
@@ -7758,7 +8130,55 @@
                           <a:ea typeface="Aptos"/>
                           <a:cs typeface="Aptos"/>
                         </a:rPr>
-                        <a:t>ColumnTransformer dentro de Pipeline</a:t>
+                        <a:t>0,887</a:t>
+                      </a:r>
+                    </a:p>
+                  </a:txBody>
+                  <a:tcPr marL="91440" marR="91440" marT="45720" marB="45720" anchor="ctr">
+                    <a:solidFill>
+                      <a:srgbClr val="E8F0F5"/>
+                    </a:solidFill>
+                  </a:tcPr>
+                </a:tc>
+                <a:tc>
+                  <a:txBody>
+                    <a:bodyPr/>
+                    <a:lstStyle/>
+                    <a:p>
+                      <a:r>
+                        <a:rPr sz="1275">
+                          <a:solidFill>
+                            <a:srgbClr val="202B38"/>
+                          </a:solidFill>
+                          <a:latin typeface="Aptos"/>
+                          <a:ea typeface="Aptos"/>
+                          <a:cs typeface="Aptos"/>
+                        </a:rPr>
+                        <a:t>0,573</a:t>
+                      </a:r>
+                    </a:p>
+                  </a:txBody>
+                  <a:tcPr marL="91440" marR="91440" marT="45720" marB="45720" anchor="ctr">
+                    <a:solidFill>
+                      <a:srgbClr val="E8F0F5"/>
+                    </a:solidFill>
+                  </a:tcPr>
+                </a:tc>
+                <a:tc>
+                  <a:txBody>
+                    <a:bodyPr/>
+                    <a:lstStyle/>
+                    <a:p>
+                      <a:r>
+                        <a:rPr sz="1275">
+                          <a:solidFill>
+                            <a:srgbClr val="202B38"/>
+                          </a:solidFill>
+                          <a:latin typeface="Aptos"/>
+                          <a:ea typeface="Aptos"/>
+                          <a:cs typeface="Aptos"/>
+                        </a:rPr>
+                        <a:t>0,821</a:t>
                       </a:r>
                     </a:p>
                   </a:txBody>
@@ -7769,14 +8189,14 @@
                   </a:tcPr>
                 </a:tc>
               </a:tr>
-              <a:tr h="485775">
+              <a:tr h="598714">
                 <a:tc>
                   <a:txBody>
                     <a:bodyPr/>
                     <a:lstStyle/>
                     <a:p>
                       <a:r>
-                        <a:rPr sz="1125">
+                        <a:rPr sz="1275">
                           <a:solidFill>
                             <a:srgbClr val="202B38"/>
                           </a:solidFill>
@@ -7784,7 +8204,7 @@
                           <a:ea typeface="Aptos"/>
                           <a:cs typeface="Aptos"/>
                         </a:rPr>
-                        <a:t>Tres alternativas</a:t>
+                        <a:t>random_forest_depth5</a:t>
                       </a:r>
                     </a:p>
                   </a:txBody>
@@ -7800,7 +8220,7 @@
                     <a:lstStyle/>
                     <a:p>
                       <a:r>
-                        <a:rPr sz="1125">
+                        <a:rPr sz="1275">
                           <a:solidFill>
                             <a:srgbClr val="202B38"/>
                           </a:solidFill>
@@ -7808,7 +8228,55 @@
                           <a:ea typeface="Aptos"/>
                           <a:cs typeface="Aptos"/>
                         </a:rPr>
-                        <a:t>Dummy, Regresión Logística y Random Forest</a:t>
+                        <a:t>0,784</a:t>
+                      </a:r>
+                    </a:p>
+                  </a:txBody>
+                  <a:tcPr marL="91440" marR="91440" marT="45720" marB="45720" anchor="ctr">
+                    <a:solidFill>
+                      <a:srgbClr val="FFFFFF"/>
+                    </a:solidFill>
+                  </a:tcPr>
+                </a:tc>
+                <a:tc>
+                  <a:txBody>
+                    <a:bodyPr/>
+                    <a:lstStyle/>
+                    <a:p>
+                      <a:r>
+                        <a:rPr sz="1275">
+                          <a:solidFill>
+                            <a:srgbClr val="202B38"/>
+                          </a:solidFill>
+                          <a:latin typeface="Aptos"/>
+                          <a:ea typeface="Aptos"/>
+                          <a:cs typeface="Aptos"/>
+                        </a:rPr>
+                        <a:t>0,583</a:t>
+                      </a:r>
+                    </a:p>
+                  </a:txBody>
+                  <a:tcPr marL="91440" marR="91440" marT="45720" marB="45720" anchor="ctr">
+                    <a:solidFill>
+                      <a:srgbClr val="FFFFFF"/>
+                    </a:solidFill>
+                  </a:tcPr>
+                </a:tc>
+                <a:tc>
+                  <a:txBody>
+                    <a:bodyPr/>
+                    <a:lstStyle/>
+                    <a:p>
+                      <a:r>
+                        <a:rPr sz="1275">
+                          <a:solidFill>
+                            <a:srgbClr val="202B38"/>
+                          </a:solidFill>
+                          <a:latin typeface="Aptos"/>
+                          <a:ea typeface="Aptos"/>
+                          <a:cs typeface="Aptos"/>
+                        </a:rPr>
+                        <a:t>0,804</a:t>
                       </a:r>
                     </a:p>
                   </a:txBody>
@@ -7819,14 +8287,14 @@
                   </a:tcPr>
                 </a:tc>
               </a:tr>
-              <a:tr h="485775">
+              <a:tr h="598714">
                 <a:tc>
                   <a:txBody>
                     <a:bodyPr/>
                     <a:lstStyle/>
                     <a:p>
                       <a:r>
-                        <a:rPr sz="1125">
+                        <a:rPr sz="1275">
                           <a:solidFill>
                             <a:srgbClr val="202B38"/>
                           </a:solidFill>
@@ -7834,7 +8302,7 @@
                           <a:ea typeface="Aptos"/>
                           <a:cs typeface="Aptos"/>
                         </a:rPr>
-                        <a:t>Entrenamiento desde Python</a:t>
+                        <a:t>random_forest_depth10</a:t>
                       </a:r>
                     </a:p>
                   </a:txBody>
@@ -7850,7 +8318,7 @@
                     <a:lstStyle/>
                     <a:p>
                       <a:r>
-                        <a:rPr sz="1125">
+                        <a:rPr sz="1275">
                           <a:solidFill>
                             <a:srgbClr val="202B38"/>
                           </a:solidFill>
@@ -7858,83 +8326,7 @@
                           <a:ea typeface="Aptos"/>
                           <a:cs typeface="Aptos"/>
                         </a:rPr>
-                        <a:t>src/training/train.py ejecutable como módulo</a:t>
-                      </a:r>
-                    </a:p>
-                  </a:txBody>
-                  <a:tcPr marL="91440" marR="91440" marT="45720" marB="45720" anchor="ctr">
-                    <a:solidFill>
-                      <a:srgbClr val="E8F0F5"/>
-                    </a:solidFill>
-                  </a:tcPr>
-                </a:tc>
-              </a:tr>
-              <a:tr h="485775">
-                <a:tc>
-                  <a:txBody>
-                    <a:bodyPr/>
-                    <a:lstStyle/>
-                    <a:p>
-                      <a:r>
-                        <a:rPr sz="1125">
-                          <a:solidFill>
-                            <a:srgbClr val="202B38"/>
-                          </a:solidFill>
-                          <a:latin typeface="Aptos"/>
-                          <a:ea typeface="Aptos"/>
-                          <a:cs typeface="Aptos"/>
-                        </a:rPr>
-                        <a:t>Pruebas automáticas</a:t>
-                      </a:r>
-                    </a:p>
-                  </a:txBody>
-                  <a:tcPr marL="91440" marR="91440" marT="45720" marB="45720" anchor="ctr">
-                    <a:solidFill>
-                      <a:srgbClr val="FFFFFF"/>
-                    </a:solidFill>
-                  </a:tcPr>
-                </a:tc>
-                <a:tc>
-                  <a:txBody>
-                    <a:bodyPr/>
-                    <a:lstStyle/>
-                    <a:p>
-                      <a:r>
-                        <a:rPr sz="1125">
-                          <a:solidFill>
-                            <a:srgbClr val="202B38"/>
-                          </a:solidFill>
-                          <a:latin typeface="Aptos"/>
-                          <a:ea typeface="Aptos"/>
-                          <a:cs typeface="Aptos"/>
-                        </a:rPr>
-                        <a:t>Métricas y preprocesamiento comprobados</a:t>
-                      </a:r>
-                    </a:p>
-                  </a:txBody>
-                  <a:tcPr marL="91440" marR="91440" marT="45720" marB="45720" anchor="ctr">
-                    <a:solidFill>
-                      <a:srgbClr val="FFFFFF"/>
-                    </a:solidFill>
-                  </a:tcPr>
-                </a:tc>
-              </a:tr>
-              <a:tr h="485775">
-                <a:tc>
-                  <a:txBody>
-                    <a:bodyPr/>
-                    <a:lstStyle/>
-                    <a:p>
-                      <a:r>
-                        <a:rPr sz="1125">
-                          <a:solidFill>
-                            <a:srgbClr val="202B38"/>
-                          </a:solidFill>
-                          <a:latin typeface="Aptos"/>
-                          <a:ea typeface="Aptos"/>
-                          <a:cs typeface="Aptos"/>
-                        </a:rPr>
-                        <a:t>Dataset rastreado con DVC</a:t>
+                        <a:t>0,717</a:t>
                       </a:r>
                     </a:p>
                   </a:txBody>
@@ -7950,7 +8342,7 @@
                     <a:lstStyle/>
                     <a:p>
                       <a:r>
-                        <a:rPr sz="1125">
+                        <a:rPr sz="1275">
                           <a:solidFill>
                             <a:srgbClr val="202B38"/>
                           </a:solidFill>
@@ -7958,7 +8350,31 @@
                           <a:ea typeface="Aptos"/>
                           <a:cs typeface="Aptos"/>
                         </a:rPr>
-                        <a:t>Archivo .dvc y cache local verificados</a:t>
+                        <a:t>0,600</a:t>
+                      </a:r>
+                    </a:p>
+                  </a:txBody>
+                  <a:tcPr marL="91440" marR="91440" marT="45720" marB="45720" anchor="ctr">
+                    <a:solidFill>
+                      <a:srgbClr val="E8F0F5"/>
+                    </a:solidFill>
+                  </a:tcPr>
+                </a:tc>
+                <a:tc>
+                  <a:txBody>
+                    <a:bodyPr/>
+                    <a:lstStyle/>
+                    <a:p>
+                      <a:r>
+                        <a:rPr sz="1275">
+                          <a:solidFill>
+                            <a:srgbClr val="202B38"/>
+                          </a:solidFill>
+                          <a:latin typeface="Aptos"/>
+                          <a:ea typeface="Aptos"/>
+                          <a:cs typeface="Aptos"/>
+                        </a:rPr>
+                        <a:t>0,807</a:t>
                       </a:r>
                     </a:p>
                   </a:txBody>
@@ -7969,56 +8385,6 @@
                   </a:tcPr>
                 </a:tc>
               </a:tr>
-              <a:tr h="485775">
-                <a:tc>
-                  <a:txBody>
-                    <a:bodyPr/>
-                    <a:lstStyle/>
-                    <a:p>
-                      <a:r>
-                        <a:rPr sz="1125">
-                          <a:solidFill>
-                            <a:srgbClr val="202B38"/>
-                          </a:solidFill>
-                          <a:latin typeface="Aptos"/>
-                          <a:ea typeface="Aptos"/>
-                          <a:cs typeface="Aptos"/>
-                        </a:rPr>
-                        <a:t>Remote DVC configurado</a:t>
-                      </a:r>
-                    </a:p>
-                  </a:txBody>
-                  <a:tcPr marL="91440" marR="91440" marT="45720" marB="45720" anchor="ctr">
-                    <a:solidFill>
-                      <a:srgbClr val="FFFFFF"/>
-                    </a:solidFill>
-                  </a:tcPr>
-                </a:tc>
-                <a:tc>
-                  <a:txBody>
-                    <a:bodyPr/>
-                    <a:lstStyle/>
-                    <a:p>
-                      <a:r>
-                        <a:rPr sz="1125">
-                          <a:solidFill>
-                            <a:srgbClr val="202B38"/>
-                          </a:solidFill>
-                          <a:latin typeface="Aptos"/>
-                          <a:ea typeface="Aptos"/>
-                          <a:cs typeface="Aptos"/>
-                        </a:rPr>
-                        <a:t>DagsHub: giselle.san/entregaPrimerParcial</a:t>
-                      </a:r>
-                    </a:p>
-                  </a:txBody>
-                  <a:tcPr marL="91440" marR="91440" marT="45720" marB="45720" anchor="ctr">
-                    <a:solidFill>
-                      <a:srgbClr val="FFFFFF"/>
-                    </a:solidFill>
-                  </a:tcPr>
-                </a:tc>
-              </a:tr>
             </a:tbl>
           </a:graphicData>
         </a:graphic>
@@ -8028,7 +8394,7 @@
           <p:cNvPr id="4" name="">
             <a:extLst xmlns:a="http://schemas.openxmlformats.org/drawingml/2006/main">
               <a:ext uri="{FF2B5EF4-FFF2-40B4-BE49-F238E27FC236}">
-                <a16:creationId xmlns:a16="http://schemas.microsoft.com/office/drawing/2014/main" id="{8BA51312-769F-4861-82B4-9553AD5EFD62}"/>
+                <a16:creationId xmlns:a16="http://schemas.microsoft.com/office/drawing/2014/main" id="{F609A6EE-BF5B-4EBC-AD73-483F23A90933}"/>
               </a:ext>
             </a:extLst>
           </p:cNvPr>
@@ -8039,8 +8405,8 @@
         </p:nvSpPr>
         <p:spPr>
           <a:xfrm xmlns:a="http://schemas.openxmlformats.org/drawingml/2006/main">
-            <a:off x="1714500" y="6115050"/>
-            <a:ext cx="8763000" cy="333375"/>
+            <a:off x="1381125" y="5715000"/>
+            <a:ext cx="9429750" cy="457200"/>
           </a:xfrm>
           <a:prstGeom xmlns:a="http://schemas.openxmlformats.org/drawingml/2006/main" prst="rect">
             <a:avLst/>
@@ -8057,7 +8423,7 @@
           <a:lstStyle xmlns:a="http://schemas.openxmlformats.org/drawingml/2006/main"/>
           <a:p xmlns:a="http://schemas.openxmlformats.org/drawingml/2006/main">
             <a:pPr algn="ctr">
-              <a:defRPr sz="1500" b="1">
+              <a:defRPr sz="1575" b="1">
                 <a:solidFill>
                   <a:srgbClr val="2F7D55"/>
                 </a:solidFill>
@@ -8067,7 +8433,7 @@
               </a:defRPr>
             </a:pPr>
             <a:r>
-              <a:rPr sz="1500" b="1">
+              <a:rPr sz="1575" b="1">
                 <a:solidFill>
                   <a:srgbClr val="2F7D55"/>
                 </a:solidFill>
@@ -8075,7 +8441,7 @@
                 <a:ea typeface="Aptos"/>
                 <a:cs typeface="Aptos"/>
               </a:rPr>
-              <a:t>El notebook conserva el análisis y src contiene la lógica reutilizable.</a:t>
+              <a:t>Cada Run guarda parámetros, métricas, artefactos, pipeline, commit y hash del dataset.</a:t>
             </a:r>
           </a:p>
         </p:txBody>
@@ -8083,7 +8449,7 @@
     </p:spTree>
     <p:extLst>
       <p:ext uri="{BB962C8B-B14F-4D97-AF65-F5344CB8AC3E}">
-        <p14:creationId xmlns:p14="http://schemas.microsoft.com/office/powerpoint/2010/main" val="1518022377"/>
+        <p14:creationId xmlns:p14="http://schemas.microsoft.com/office/powerpoint/2010/main" val="892288353"/>
       </p:ext>
     </p:extLst>
   </p:cSld>

</xml_diff>